<commit_message>
feat: qualify process recovery and bind replay receipts to exact proposals
</commit_message>
<xml_diff>
--- a/fssai-ra/docs/trust-by-construction-final.pptx
+++ b/fssai-ra/docs/trust-by-construction-final.pptx
@@ -2,26 +2,26 @@
 <file path=ppt/presentation.xml><?xml version="1.0" encoding="utf-8"?>
 <p:presentation xmlns:p="http://schemas.openxmlformats.org/presentationml/2006/main">
   <p:sldMasterIdLst>
-    <p:sldMasterId xmlns:r="http://schemas.openxmlformats.org/officeDocument/2006/relationships" id="2147483648" r:id="R48ec0592569d401f"/>
+    <p:sldMasterId xmlns:r="http://schemas.openxmlformats.org/officeDocument/2006/relationships" id="2147483648" r:id="R9c4a94b2c29649c6"/>
   </p:sldMasterIdLst>
   <p:notesMasterIdLst>
-    <p:notesMasterId xmlns:r="http://schemas.openxmlformats.org/officeDocument/2006/relationships" r:id="R321495ba3c97430d"/>
+    <p:notesMasterId xmlns:r="http://schemas.openxmlformats.org/officeDocument/2006/relationships" r:id="R4fe6dcee8a404325"/>
   </p:notesMasterIdLst>
   <p:sldIdLst>
-    <p:sldId xmlns:r="http://schemas.openxmlformats.org/officeDocument/2006/relationships" id="256" r:id="R2d20d332d7ff4fe9"/>
-    <p:sldId xmlns:r="http://schemas.openxmlformats.org/officeDocument/2006/relationships" id="257" r:id="Ra8ca1215c3fa4a51"/>
-    <p:sldId xmlns:r="http://schemas.openxmlformats.org/officeDocument/2006/relationships" id="258" r:id="Rd308d00a7be64bdc"/>
-    <p:sldId xmlns:r="http://schemas.openxmlformats.org/officeDocument/2006/relationships" id="259" r:id="R834364a21f6044ee"/>
-    <p:sldId xmlns:r="http://schemas.openxmlformats.org/officeDocument/2006/relationships" id="260" r:id="R93dce0b282a94d44"/>
-    <p:sldId xmlns:r="http://schemas.openxmlformats.org/officeDocument/2006/relationships" id="261" r:id="R960c94a635e646a7"/>
-    <p:sldId xmlns:r="http://schemas.openxmlformats.org/officeDocument/2006/relationships" id="262" r:id="R1bb78aaf70fa4249"/>
-    <p:sldId xmlns:r="http://schemas.openxmlformats.org/officeDocument/2006/relationships" id="263" r:id="R58f591757e254be3"/>
-    <p:sldId xmlns:r="http://schemas.openxmlformats.org/officeDocument/2006/relationships" id="264" r:id="Rd29303db539b4483"/>
-    <p:sldId xmlns:r="http://schemas.openxmlformats.org/officeDocument/2006/relationships" id="265" r:id="R224a8c3e766341c3"/>
-    <p:sldId xmlns:r="http://schemas.openxmlformats.org/officeDocument/2006/relationships" id="266" r:id="R7b37aa79929d48b6"/>
-    <p:sldId xmlns:r="http://schemas.openxmlformats.org/officeDocument/2006/relationships" id="267" r:id="Rb7df62acf74146f2"/>
-    <p:sldId xmlns:r="http://schemas.openxmlformats.org/officeDocument/2006/relationships" id="268" r:id="R2d3cda1c07ce43bd"/>
-    <p:sldId xmlns:r="http://schemas.openxmlformats.org/officeDocument/2006/relationships" id="269" r:id="Raae284cc09f443e9"/>
+    <p:sldId xmlns:r="http://schemas.openxmlformats.org/officeDocument/2006/relationships" id="256" r:id="R69b113336a2d4107"/>
+    <p:sldId xmlns:r="http://schemas.openxmlformats.org/officeDocument/2006/relationships" id="257" r:id="R71971d954d464649"/>
+    <p:sldId xmlns:r="http://schemas.openxmlformats.org/officeDocument/2006/relationships" id="258" r:id="R7e8e2908f7734725"/>
+    <p:sldId xmlns:r="http://schemas.openxmlformats.org/officeDocument/2006/relationships" id="259" r:id="R0534aa8ee8d54d80"/>
+    <p:sldId xmlns:r="http://schemas.openxmlformats.org/officeDocument/2006/relationships" id="260" r:id="R97ccb3aaaa384688"/>
+    <p:sldId xmlns:r="http://schemas.openxmlformats.org/officeDocument/2006/relationships" id="261" r:id="Rce4617205bc34cce"/>
+    <p:sldId xmlns:r="http://schemas.openxmlformats.org/officeDocument/2006/relationships" id="262" r:id="R155d60752d7f4950"/>
+    <p:sldId xmlns:r="http://schemas.openxmlformats.org/officeDocument/2006/relationships" id="263" r:id="Rca94fd3b44f64d6a"/>
+    <p:sldId xmlns:r="http://schemas.openxmlformats.org/officeDocument/2006/relationships" id="264" r:id="R2ab25af56d224f27"/>
+    <p:sldId xmlns:r="http://schemas.openxmlformats.org/officeDocument/2006/relationships" id="265" r:id="Rce17538bfe974944"/>
+    <p:sldId xmlns:r="http://schemas.openxmlformats.org/officeDocument/2006/relationships" id="266" r:id="R24aa7d1deb514c23"/>
+    <p:sldId xmlns:r="http://schemas.openxmlformats.org/officeDocument/2006/relationships" id="267" r:id="R1c9778aebbe1493c"/>
+    <p:sldId xmlns:r="http://schemas.openxmlformats.org/officeDocument/2006/relationships" id="268" r:id="Ra4830e18a3f84d4c"/>
+    <p:sldId xmlns:r="http://schemas.openxmlformats.org/officeDocument/2006/relationships" id="269" r:id="Rd1c09202896d4e1e"/>
   </p:sldIdLst>
   <p:sldSz cx="12192000" cy="6858000"/>
   <p:notesSz cx="6858000" cy="9144000"/>
@@ -560,7 +560,7 @@
           </a:p>
           <a:p xmlns:a="http://schemas.openxmlformats.org/drawingml/2006/main">
             <a:r>
-              <a:t>- https://github.com/genaiworks/fssai-ra/blob/v1.0.0/evaluation/results/v1.0.0-verification.json</a:t>
+              <a:t>- https://github.com/genaiworks/fssai-ra/blob/v1.0.0/fssai-ra/evaluation/results/v1.0.0-verification.json</a:t>
             </a:r>
           </a:p>
         </p:txBody>
@@ -630,7 +630,7 @@
           <a:lstStyle xmlns:a="http://schemas.openxmlformats.org/drawingml/2006/main"/>
           <a:p xmlns:a="http://schemas.openxmlformats.org/drawingml/2006/main">
             <a:r>
-              <a:t>This new race harness tests an important failure mode without overclaiming. Thirty-two threads hit one approved request; exactly one mutation and one receipt were created, and all replays got that receipt. The bound excludes multiple processes and nodes.</a:t>
+              <a:t>This supplement is separate from the v1.0.0 baseline. Eight spawned processes with independent connections race the same approval. A second race uses eight distinct approvals against the same reviewed version, producing one mutation and seven version conflicts. Four workers exit abruptly after intent, mutation, outcome, or commit. Reopening and retrying leaves one complete evidence pair. This tests process exit, not power loss or PostgreSQL concurrency. Reproduce with fssaira resilience profiles/student_support.yaml. The report fingerprints the source and effective profile.</a:t>
             </a:r>
           </a:p>
           <a:p xmlns:a="http://schemas.openxmlformats.org/drawingml/2006/main">
@@ -645,7 +645,12 @@
           </a:p>
           <a:p xmlns:a="http://schemas.openxmlformats.org/drawingml/2006/main">
             <a:r>
-              <a:t>- https://github.com/genaiworks/fssai-ra/blob/v1.0.0/evaluation/results/v1.0.0-race.json</a:t>
+              <a:t>- https://github.com/genaiworks/fssai-ra/blob/main/fssai-ra/evaluation/results/resilience-student-support.json</a:t>
+            </a:r>
+          </a:p>
+          <a:p xmlns:a="http://schemas.openxmlformats.org/drawingml/2006/main">
+            <a:r>
+              <a:t>- https://github.com/genaiworks/fssai-ra/blob/main/fssai-ra/docs/RESILIENCE.md</a:t>
             </a:r>
           </a:p>
         </p:txBody>
@@ -1260,7 +1265,7 @@
           </a:p>
           <a:p xmlns:a="http://schemas.openxmlformats.org/drawingml/2006/main">
             <a:r>
-              <a:t>- https://github.com/genaiworks/fssai-ra/blob/v1.0.0/spec/control-contract.schema.json</a:t>
+              <a:t>- https://github.com/genaiworks/fssai-ra/tree/v1.0.0/fssai-ra/contract</a:t>
             </a:r>
           </a:p>
         </p:txBody>
@@ -1345,7 +1350,7 @@
           </a:p>
           <a:p xmlns:a="http://schemas.openxmlformats.org/drawingml/2006/main">
             <a:r>
-              <a:t>- https://github.com/genaiworks/fssai-ra/tree/v1.0.0/src/fssaira</a:t>
+              <a:t>- https://github.com/genaiworks/fssai-ra/tree/v1.0.0/fssai-ra/src/fssaira</a:t>
             </a:r>
           </a:p>
         </p:txBody>
@@ -1430,7 +1435,7 @@
           </a:p>
           <a:p xmlns:a="http://schemas.openxmlformats.org/drawingml/2006/main">
             <a:r>
-              <a:t>- https://github.com/genaiworks/fssai-ra/blob/v1.0.0/docs/DEMO.md</a:t>
+              <a:t>- https://github.com/genaiworks/fssai-ra/blob/v1.0.0/fssai-ra/docs/DEMO.md</a:t>
             </a:r>
           </a:p>
         </p:txBody>
@@ -1515,7 +1520,7 @@
           </a:p>
           <a:p xmlns:a="http://schemas.openxmlformats.org/drawingml/2006/main">
             <a:r>
-              <a:t>- https://github.com/genaiworks/fssai-ra/blob/v1.0.0/evaluation/results/RESULTS.md</a:t>
+              <a:t>- https://github.com/genaiworks/fssai-ra/blob/v1.0.0/fssai-ra/evaluation/results/RESULTS.md</a:t>
             </a:r>
           </a:p>
         </p:txBody>
@@ -1600,7 +1605,7 @@
           </a:p>
           <a:p xmlns:a="http://schemas.openxmlformats.org/drawingml/2006/main">
             <a:r>
-              <a:t>- https://github.com/genaiworks/fssai-ra/blob/v1.0.0/evaluation/results/v1.0.0-architecture-comparison.json</a:t>
+              <a:t>- https://github.com/genaiworks/fssai-ra/blob/v1.0.0/fssai-ra/evaluation/results/v1.0.0-architecture-comparison.json</a:t>
             </a:r>
           </a:p>
         </p:txBody>
@@ -1668,7 +1673,7 @@
   </p:cSld>
   <p:clrMap bg1="lt1" tx1="dk1" bg2="lt2" tx2="dk2" accent1="accent1" accent2="accent2" accent3="accent3" accent4="accent4" accent5="accent5" accent6="accent6" hlink="hlink" folHlink="folHlink"/>
   <p:sldLayoutIdLst>
-    <p:sldLayoutId xmlns:r="http://schemas.openxmlformats.org/officeDocument/2006/relationships" id="2147483649" r:id="Rf790659d9ba04c33"/>
+    <p:sldLayoutId xmlns:r="http://schemas.openxmlformats.org/officeDocument/2006/relationships" id="2147483649" r:id="Ra1bb66cc81bf448c"/>
   </p:sldLayoutIdLst>
   <p:txStyles>
     <p:titleStyle>
@@ -2466,7 +2471,7 @@
           <p:cNvPr id="12" name="">
             <a:extLst xmlns:a="http://schemas.openxmlformats.org/drawingml/2006/main">
               <a:ext uri="{FF2B5EF4-FFF2-40B4-BE49-F238E27FC236}">
-                <a16:creationId xmlns:a16="http://schemas.microsoft.com/office/drawing/2014/main" id="{046B7BAF-6D19-4D6A-A5CB-446B2D7856E7}"/>
+                <a16:creationId xmlns:a16="http://schemas.microsoft.com/office/drawing/2014/main" id="{92B1DF59-A739-4D49-98B4-5927201FE592}"/>
               </a:ext>
             </a:extLst>
           </p:cNvPr>
@@ -2498,7 +2503,7 @@
           <p:cNvPr id="2" name="">
             <a:extLst xmlns:a="http://schemas.openxmlformats.org/drawingml/2006/main">
               <a:ext uri="{FF2B5EF4-FFF2-40B4-BE49-F238E27FC236}">
-                <a16:creationId xmlns:a16="http://schemas.microsoft.com/office/drawing/2014/main" id="{B6A63AE3-4023-4EBA-9E11-09EFC0FBC7CA}"/>
+                <a16:creationId xmlns:a16="http://schemas.microsoft.com/office/drawing/2014/main" id="{746462DF-A753-418E-87A2-2097C2169ACB}"/>
               </a:ext>
             </a:extLst>
           </p:cNvPr>
@@ -2555,7 +2560,7 @@
           <p:cNvPr id="3" name="">
             <a:extLst xmlns:a="http://schemas.openxmlformats.org/drawingml/2006/main">
               <a:ext uri="{FF2B5EF4-FFF2-40B4-BE49-F238E27FC236}">
-                <a16:creationId xmlns:a16="http://schemas.microsoft.com/office/drawing/2014/main" id="{DF3A49DA-1A48-4BE5-BBB0-00058DF7120E}"/>
+                <a16:creationId xmlns:a16="http://schemas.microsoft.com/office/drawing/2014/main" id="{08AA0ECE-42A1-4B6F-8A7A-AB2ED724E327}"/>
               </a:ext>
             </a:extLst>
           </p:cNvPr>
@@ -2635,7 +2640,7 @@
           <p:cNvPr id="4" name="">
             <a:extLst xmlns:a="http://schemas.openxmlformats.org/drawingml/2006/main">
               <a:ext uri="{FF2B5EF4-FFF2-40B4-BE49-F238E27FC236}">
-                <a16:creationId xmlns:a16="http://schemas.microsoft.com/office/drawing/2014/main" id="{E0076499-B91E-4FBB-A4DF-6163CD57EF72}"/>
+                <a16:creationId xmlns:a16="http://schemas.microsoft.com/office/drawing/2014/main" id="{BF75CBA9-72AE-4E03-AFA6-7E1B71C07A8C}"/>
               </a:ext>
             </a:extLst>
           </p:cNvPr>
@@ -2692,7 +2697,7 @@
           <p:cNvPr id="5" name="">
             <a:extLst xmlns:a="http://schemas.openxmlformats.org/drawingml/2006/main">
               <a:ext uri="{FF2B5EF4-FFF2-40B4-BE49-F238E27FC236}">
-                <a16:creationId xmlns:a16="http://schemas.microsoft.com/office/drawing/2014/main" id="{0B0716B1-1116-4489-B7AC-210D76911274}"/>
+                <a16:creationId xmlns:a16="http://schemas.microsoft.com/office/drawing/2014/main" id="{67357384-5E2F-4F18-BC1C-30E031E3A856}"/>
               </a:ext>
             </a:extLst>
           </p:cNvPr>
@@ -2726,7 +2731,7 @@
           <p:cNvPr id="6" name="">
             <a:extLst xmlns:a="http://schemas.openxmlformats.org/drawingml/2006/main">
               <a:ext uri="{FF2B5EF4-FFF2-40B4-BE49-F238E27FC236}">
-                <a16:creationId xmlns:a16="http://schemas.microsoft.com/office/drawing/2014/main" id="{0C28142C-7122-4346-A9D8-029E9D9B4746}"/>
+                <a16:creationId xmlns:a16="http://schemas.microsoft.com/office/drawing/2014/main" id="{A422CB34-5AE4-4E49-A152-203B8F0487D0}"/>
               </a:ext>
             </a:extLst>
           </p:cNvPr>
@@ -2783,7 +2788,7 @@
           <p:cNvPr id="7" name="">
             <a:extLst xmlns:a="http://schemas.openxmlformats.org/drawingml/2006/main">
               <a:ext uri="{FF2B5EF4-FFF2-40B4-BE49-F238E27FC236}">
-                <a16:creationId xmlns:a16="http://schemas.microsoft.com/office/drawing/2014/main" id="{C6114616-9392-4781-9EFE-909DEDA2380D}"/>
+                <a16:creationId xmlns:a16="http://schemas.microsoft.com/office/drawing/2014/main" id="{CF2E1F5F-73C9-43C9-9D80-C4816362F584}"/>
               </a:ext>
             </a:extLst>
           </p:cNvPr>
@@ -2863,7 +2868,7 @@
           <p:cNvPr id="8" name="">
             <a:extLst xmlns:a="http://schemas.openxmlformats.org/drawingml/2006/main">
               <a:ext uri="{FF2B5EF4-FFF2-40B4-BE49-F238E27FC236}">
-                <a16:creationId xmlns:a16="http://schemas.microsoft.com/office/drawing/2014/main" id="{96137B49-B0AD-4B36-B04F-34B7A1AF36DB}"/>
+                <a16:creationId xmlns:a16="http://schemas.microsoft.com/office/drawing/2014/main" id="{965FCE6B-F984-472F-A1E7-E473A9E9A05C}"/>
               </a:ext>
             </a:extLst>
           </p:cNvPr>
@@ -2920,7 +2925,7 @@
           <p:cNvPr id="9" name="">
             <a:extLst xmlns:a="http://schemas.openxmlformats.org/drawingml/2006/main">
               <a:ext uri="{FF2B5EF4-FFF2-40B4-BE49-F238E27FC236}">
-                <a16:creationId xmlns:a16="http://schemas.microsoft.com/office/drawing/2014/main" id="{33744CB5-83CF-4C7D-B5DE-9DE46A5488F7}"/>
+                <a16:creationId xmlns:a16="http://schemas.microsoft.com/office/drawing/2014/main" id="{33A52B8B-712D-4980-806D-23D36375C300}"/>
               </a:ext>
             </a:extLst>
           </p:cNvPr>
@@ -3000,7 +3005,7 @@
           <p:cNvPr id="10" name="">
             <a:extLst xmlns:a="http://schemas.openxmlformats.org/drawingml/2006/main">
               <a:ext uri="{FF2B5EF4-FFF2-40B4-BE49-F238E27FC236}">
-                <a16:creationId xmlns:a16="http://schemas.microsoft.com/office/drawing/2014/main" id="{9FFC5964-20A1-43CF-A020-F1E3E2C72B35}"/>
+                <a16:creationId xmlns:a16="http://schemas.microsoft.com/office/drawing/2014/main" id="{E823A499-BD4F-49A7-8453-28E9B421053C}"/>
               </a:ext>
             </a:extLst>
           </p:cNvPr>
@@ -3012,7 +3017,7 @@
         <p:spPr>
           <a:xfrm xmlns:a="http://schemas.openxmlformats.org/drawingml/2006/main">
             <a:off x="666750" y="6115050"/>
-            <a:ext cx="8572500" cy="247650"/>
+            <a:ext cx="9906000" cy="247650"/>
           </a:xfrm>
           <a:prstGeom xmlns:a="http://schemas.openxmlformats.org/drawingml/2006/main" prst="rect">
             <a:avLst/>
@@ -3047,7 +3052,7 @@
                 <a:ea typeface="Arial"/>
                 <a:cs typeface="Arial"/>
               </a:rPr>
-              <a:t>Open reference implementation  •  Apache 2.0  •  v1.0.0</a:t>
+              <a:t>Open reference implementation  •  Apache 2.0  •  v1.0.0 + resilience supplement</a:t>
             </a:r>
           </a:p>
         </p:txBody>
@@ -3057,7 +3062,7 @@
           <p:cNvPr id="11" name="">
             <a:extLst xmlns:a="http://schemas.openxmlformats.org/drawingml/2006/main">
               <a:ext uri="{FF2B5EF4-FFF2-40B4-BE49-F238E27FC236}">
-                <a16:creationId xmlns:a16="http://schemas.microsoft.com/office/drawing/2014/main" id="{5326F8AB-8688-4CD0-A6A2-E446B8D6502C}"/>
+                <a16:creationId xmlns:a16="http://schemas.microsoft.com/office/drawing/2014/main" id="{A94BB273-F397-41E3-89B6-98F574FF2543}"/>
               </a:ext>
             </a:extLst>
           </p:cNvPr>
@@ -3112,7 +3117,7 @@
     </p:spTree>
     <p:extLst>
       <p:ext uri="{BB962C8B-B14F-4D97-AF65-F5344CB8AC3E}">
-        <p14:creationId xmlns:p14="http://schemas.microsoft.com/office/powerpoint/2010/main" val="1764703817"/>
+        <p14:creationId xmlns:p14="http://schemas.microsoft.com/office/powerpoint/2010/main" val="163995349"/>
       </p:ext>
     </p:extLst>
   </p:cSld>
@@ -3143,7 +3148,7 @@
           <p:cNvPr id="22" name="">
             <a:extLst xmlns:a="http://schemas.openxmlformats.org/drawingml/2006/main">
               <a:ext uri="{FF2B5EF4-FFF2-40B4-BE49-F238E27FC236}">
-                <a16:creationId xmlns:a16="http://schemas.microsoft.com/office/drawing/2014/main" id="{9F65882C-92FD-4654-A7C7-585ED291E856}"/>
+                <a16:creationId xmlns:a16="http://schemas.microsoft.com/office/drawing/2014/main" id="{93921DD1-3763-4D16-89FB-653BE9F96A09}"/>
               </a:ext>
             </a:extLst>
           </p:cNvPr>
@@ -3200,7 +3205,7 @@
           <p:cNvPr id="2" name="">
             <a:extLst xmlns:a="http://schemas.openxmlformats.org/drawingml/2006/main">
               <a:ext uri="{FF2B5EF4-FFF2-40B4-BE49-F238E27FC236}">
-                <a16:creationId xmlns:a16="http://schemas.microsoft.com/office/drawing/2014/main" id="{7EC59EA4-D9E5-4ADE-A26D-C1B2C468FD05}"/>
+                <a16:creationId xmlns:a16="http://schemas.microsoft.com/office/drawing/2014/main" id="{5A027FF8-EEEB-44F9-8E66-F01391777637}"/>
               </a:ext>
             </a:extLst>
           </p:cNvPr>
@@ -3257,7 +3262,7 @@
           <p:cNvPr id="3" name="">
             <a:extLst xmlns:a="http://schemas.openxmlformats.org/drawingml/2006/main">
               <a:ext uri="{FF2B5EF4-FFF2-40B4-BE49-F238E27FC236}">
-                <a16:creationId xmlns:a16="http://schemas.microsoft.com/office/drawing/2014/main" id="{1CC3620B-8A64-46B8-9DC0-F26E5F240C47}"/>
+                <a16:creationId xmlns:a16="http://schemas.microsoft.com/office/drawing/2014/main" id="{ADE24464-2EC2-44AC-9658-1247AA4616F2}"/>
               </a:ext>
             </a:extLst>
           </p:cNvPr>
@@ -3287,7 +3292,7 @@
           <p:cNvPr id="4" name="">
             <a:extLst xmlns:a="http://schemas.openxmlformats.org/drawingml/2006/main">
               <a:ext uri="{FF2B5EF4-FFF2-40B4-BE49-F238E27FC236}">
-                <a16:creationId xmlns:a16="http://schemas.microsoft.com/office/drawing/2014/main" id="{F7D0A669-16A8-4A34-831B-F6AE1D65CAAB}"/>
+                <a16:creationId xmlns:a16="http://schemas.microsoft.com/office/drawing/2014/main" id="{67B9CA22-5951-41D4-A852-97E323559FD4}"/>
               </a:ext>
             </a:extLst>
           </p:cNvPr>
@@ -3344,7 +3349,7 @@
           <p:cNvPr id="5" name="">
             <a:extLst xmlns:a="http://schemas.openxmlformats.org/drawingml/2006/main">
               <a:ext uri="{FF2B5EF4-FFF2-40B4-BE49-F238E27FC236}">
-                <a16:creationId xmlns:a16="http://schemas.microsoft.com/office/drawing/2014/main" id="{C6B22EF5-7EB2-4358-89D1-DD5B6636CDDD}"/>
+                <a16:creationId xmlns:a16="http://schemas.microsoft.com/office/drawing/2014/main" id="{10991833-A780-4722-AE4C-150C101B9A08}"/>
               </a:ext>
             </a:extLst>
           </p:cNvPr>
@@ -3376,7 +3381,7 @@
           <p:cNvPr id="6" name="">
             <a:extLst xmlns:a="http://schemas.openxmlformats.org/drawingml/2006/main">
               <a:ext uri="{FF2B5EF4-FFF2-40B4-BE49-F238E27FC236}">
-                <a16:creationId xmlns:a16="http://schemas.microsoft.com/office/drawing/2014/main" id="{13E1EEAF-3B45-424E-A536-76C162ED51C0}"/>
+                <a16:creationId xmlns:a16="http://schemas.microsoft.com/office/drawing/2014/main" id="{65205448-4762-4AF8-9093-8459E8FE1986}"/>
               </a:ext>
             </a:extLst>
           </p:cNvPr>
@@ -3433,7 +3438,7 @@
           <p:cNvPr id="7" name="">
             <a:extLst xmlns:a="http://schemas.openxmlformats.org/drawingml/2006/main">
               <a:ext uri="{FF2B5EF4-FFF2-40B4-BE49-F238E27FC236}">
-                <a16:creationId xmlns:a16="http://schemas.microsoft.com/office/drawing/2014/main" id="{1FF4905B-4376-41AC-9310-C590D703146F}"/>
+                <a16:creationId xmlns:a16="http://schemas.microsoft.com/office/drawing/2014/main" id="{885A5828-364E-4A49-9BB5-A160EB8E5CA9}"/>
               </a:ext>
             </a:extLst>
           </p:cNvPr>
@@ -3490,7 +3495,7 @@
           <p:cNvPr id="8" name="">
             <a:extLst xmlns:a="http://schemas.openxmlformats.org/drawingml/2006/main">
               <a:ext uri="{FF2B5EF4-FFF2-40B4-BE49-F238E27FC236}">
-                <a16:creationId xmlns:a16="http://schemas.microsoft.com/office/drawing/2014/main" id="{B111C161-6977-42A6-95FA-2C40A5DC57C6}"/>
+                <a16:creationId xmlns:a16="http://schemas.microsoft.com/office/drawing/2014/main" id="{F1F08754-6F77-4229-80D1-C95D9158F089}"/>
               </a:ext>
             </a:extLst>
           </p:cNvPr>
@@ -3522,7 +3527,7 @@
           <p:cNvPr id="9" name="">
             <a:extLst xmlns:a="http://schemas.openxmlformats.org/drawingml/2006/main">
               <a:ext uri="{FF2B5EF4-FFF2-40B4-BE49-F238E27FC236}">
-                <a16:creationId xmlns:a16="http://schemas.microsoft.com/office/drawing/2014/main" id="{8C7AEA0B-AA26-4E14-9004-3036188738B1}"/>
+                <a16:creationId xmlns:a16="http://schemas.microsoft.com/office/drawing/2014/main" id="{455F5488-030E-4D62-AB0E-71FFED812B47}"/>
               </a:ext>
             </a:extLst>
           </p:cNvPr>
@@ -3579,7 +3584,7 @@
           <p:cNvPr id="10" name="">
             <a:extLst xmlns:a="http://schemas.openxmlformats.org/drawingml/2006/main">
               <a:ext uri="{FF2B5EF4-FFF2-40B4-BE49-F238E27FC236}">
-                <a16:creationId xmlns:a16="http://schemas.microsoft.com/office/drawing/2014/main" id="{5E8AB179-E8B3-4C0A-829F-2E0FB6C11123}"/>
+                <a16:creationId xmlns:a16="http://schemas.microsoft.com/office/drawing/2014/main" id="{B7A9DD75-0777-4B59-B00E-4D4BD0859F50}"/>
               </a:ext>
             </a:extLst>
           </p:cNvPr>
@@ -3636,7 +3641,7 @@
           <p:cNvPr id="11" name="">
             <a:extLst xmlns:a="http://schemas.openxmlformats.org/drawingml/2006/main">
               <a:ext uri="{FF2B5EF4-FFF2-40B4-BE49-F238E27FC236}">
-                <a16:creationId xmlns:a16="http://schemas.microsoft.com/office/drawing/2014/main" id="{51FFA009-2BED-4F12-999D-CC4AFE923E28}"/>
+                <a16:creationId xmlns:a16="http://schemas.microsoft.com/office/drawing/2014/main" id="{5078FE9F-EEDD-4B6A-9E42-64749E8E7EC7}"/>
               </a:ext>
             </a:extLst>
           </p:cNvPr>
@@ -3668,7 +3673,7 @@
           <p:cNvPr id="12" name="">
             <a:extLst xmlns:a="http://schemas.openxmlformats.org/drawingml/2006/main">
               <a:ext uri="{FF2B5EF4-FFF2-40B4-BE49-F238E27FC236}">
-                <a16:creationId xmlns:a16="http://schemas.microsoft.com/office/drawing/2014/main" id="{B734F31E-FD61-432E-B27B-4FF279FC4B0F}"/>
+                <a16:creationId xmlns:a16="http://schemas.microsoft.com/office/drawing/2014/main" id="{521AFC4A-8BA7-4D5B-A9C8-320703CB5AF9}"/>
               </a:ext>
             </a:extLst>
           </p:cNvPr>
@@ -3725,7 +3730,7 @@
           <p:cNvPr id="13" name="">
             <a:extLst xmlns:a="http://schemas.openxmlformats.org/drawingml/2006/main">
               <a:ext uri="{FF2B5EF4-FFF2-40B4-BE49-F238E27FC236}">
-                <a16:creationId xmlns:a16="http://schemas.microsoft.com/office/drawing/2014/main" id="{8CAC731F-EEF1-464D-BD91-3DEF1B1B8E9B}"/>
+                <a16:creationId xmlns:a16="http://schemas.microsoft.com/office/drawing/2014/main" id="{929EE4AC-8DFC-488A-BC6E-4249D0FAAA5E}"/>
               </a:ext>
             </a:extLst>
           </p:cNvPr>
@@ -3782,7 +3787,7 @@
           <p:cNvPr id="14" name="">
             <a:extLst xmlns:a="http://schemas.openxmlformats.org/drawingml/2006/main">
               <a:ext uri="{FF2B5EF4-FFF2-40B4-BE49-F238E27FC236}">
-                <a16:creationId xmlns:a16="http://schemas.microsoft.com/office/drawing/2014/main" id="{434C26B3-AB08-443B-9967-A580687A4F35}"/>
+                <a16:creationId xmlns:a16="http://schemas.microsoft.com/office/drawing/2014/main" id="{233C77C5-6A88-4981-A13E-FBA3B39513F5}"/>
               </a:ext>
             </a:extLst>
           </p:cNvPr>
@@ -3814,7 +3819,7 @@
           <p:cNvPr id="15" name="">
             <a:extLst xmlns:a="http://schemas.openxmlformats.org/drawingml/2006/main">
               <a:ext uri="{FF2B5EF4-FFF2-40B4-BE49-F238E27FC236}">
-                <a16:creationId xmlns:a16="http://schemas.microsoft.com/office/drawing/2014/main" id="{FAFC7545-9DCC-4668-8602-B73A24202C82}"/>
+                <a16:creationId xmlns:a16="http://schemas.microsoft.com/office/drawing/2014/main" id="{800C7E63-6A6A-49DE-A1EC-96B813ED3CF3}"/>
               </a:ext>
             </a:extLst>
           </p:cNvPr>
@@ -3871,7 +3876,7 @@
           <p:cNvPr id="16" name="">
             <a:extLst xmlns:a="http://schemas.openxmlformats.org/drawingml/2006/main">
               <a:ext uri="{FF2B5EF4-FFF2-40B4-BE49-F238E27FC236}">
-                <a16:creationId xmlns:a16="http://schemas.microsoft.com/office/drawing/2014/main" id="{B3CAB2FA-EF17-4664-94C2-40A74BF33EA4}"/>
+                <a16:creationId xmlns:a16="http://schemas.microsoft.com/office/drawing/2014/main" id="{D91093FE-EEB7-41F6-B328-084D127C5434}"/>
               </a:ext>
             </a:extLst>
           </p:cNvPr>
@@ -3928,7 +3933,7 @@
           <p:cNvPr id="17" name="">
             <a:extLst xmlns:a="http://schemas.openxmlformats.org/drawingml/2006/main">
               <a:ext uri="{FF2B5EF4-FFF2-40B4-BE49-F238E27FC236}">
-                <a16:creationId xmlns:a16="http://schemas.microsoft.com/office/drawing/2014/main" id="{AE3C183A-01D2-4B62-96CB-90B6AADDFB4F}"/>
+                <a16:creationId xmlns:a16="http://schemas.microsoft.com/office/drawing/2014/main" id="{3F828BF6-6B03-4ACE-A9A9-BCFA4F9D48E0}"/>
               </a:ext>
             </a:extLst>
           </p:cNvPr>
@@ -3985,7 +3990,7 @@
           <p:cNvPr id="18" name="">
             <a:extLst xmlns:a="http://schemas.openxmlformats.org/drawingml/2006/main">
               <a:ext uri="{FF2B5EF4-FFF2-40B4-BE49-F238E27FC236}">
-                <a16:creationId xmlns:a16="http://schemas.microsoft.com/office/drawing/2014/main" id="{308413E2-3A7C-48B7-90C7-808B6CDF66F1}"/>
+                <a16:creationId xmlns:a16="http://schemas.microsoft.com/office/drawing/2014/main" id="{9EC15784-1B6F-4756-8E1A-ABFBD35E6A5A}"/>
               </a:ext>
             </a:extLst>
           </p:cNvPr>
@@ -4042,7 +4047,7 @@
           <p:cNvPr id="19" name="">
             <a:extLst xmlns:a="http://schemas.openxmlformats.org/drawingml/2006/main">
               <a:ext uri="{FF2B5EF4-FFF2-40B4-BE49-F238E27FC236}">
-                <a16:creationId xmlns:a16="http://schemas.microsoft.com/office/drawing/2014/main" id="{D1EDC020-9725-4D90-9E06-FE492EF56977}"/>
+                <a16:creationId xmlns:a16="http://schemas.microsoft.com/office/drawing/2014/main" id="{150ED0E8-0181-411B-A4F5-D9BB0F1B4AA6}"/>
               </a:ext>
             </a:extLst>
           </p:cNvPr>
@@ -4099,7 +4104,7 @@
           <p:cNvPr id="20" name="">
             <a:extLst xmlns:a="http://schemas.openxmlformats.org/drawingml/2006/main">
               <a:ext uri="{FF2B5EF4-FFF2-40B4-BE49-F238E27FC236}">
-                <a16:creationId xmlns:a16="http://schemas.microsoft.com/office/drawing/2014/main" id="{E4111420-0F3F-412A-A317-4D9EDE7FE1ED}"/>
+                <a16:creationId xmlns:a16="http://schemas.microsoft.com/office/drawing/2014/main" id="{88B1FB22-BEE0-40CD-9339-DDA323D8D5D0}"/>
               </a:ext>
             </a:extLst>
           </p:cNvPr>
@@ -4156,7 +4161,7 @@
           <p:cNvPr id="21" name="">
             <a:extLst xmlns:a="http://schemas.openxmlformats.org/drawingml/2006/main">
               <a:ext uri="{FF2B5EF4-FFF2-40B4-BE49-F238E27FC236}">
-                <a16:creationId xmlns:a16="http://schemas.microsoft.com/office/drawing/2014/main" id="{A55BE969-338C-4BB2-B6AE-D699B48E6783}"/>
+                <a16:creationId xmlns:a16="http://schemas.microsoft.com/office/drawing/2014/main" id="{6DBD7CB8-8AE2-49F9-A3CC-E990AE976B4A}"/>
               </a:ext>
             </a:extLst>
           </p:cNvPr>
@@ -4211,7 +4216,7 @@
     </p:spTree>
     <p:extLst>
       <p:ext uri="{BB962C8B-B14F-4D97-AF65-F5344CB8AC3E}">
-        <p14:creationId xmlns:p14="http://schemas.microsoft.com/office/powerpoint/2010/main" val="148776939"/>
+        <p14:creationId xmlns:p14="http://schemas.microsoft.com/office/powerpoint/2010/main" val="146981449"/>
       </p:ext>
     </p:extLst>
   </p:cSld>
@@ -4242,7 +4247,7 @@
           <p:cNvPr id="22" name="">
             <a:extLst xmlns:a="http://schemas.openxmlformats.org/drawingml/2006/main">
               <a:ext uri="{FF2B5EF4-FFF2-40B4-BE49-F238E27FC236}">
-                <a16:creationId xmlns:a16="http://schemas.microsoft.com/office/drawing/2014/main" id="{5B985D3C-7E37-481C-83BF-4AAC8EC35228}"/>
+                <a16:creationId xmlns:a16="http://schemas.microsoft.com/office/drawing/2014/main" id="{F7D56F4E-6BB6-4593-9C00-B2B1AE7D827C}"/>
               </a:ext>
             </a:extLst>
           </p:cNvPr>
@@ -4289,7 +4294,7 @@
                 <a:ea typeface="Arial"/>
                 <a:cs typeface="Arial"/>
               </a:rPr>
-              <a:t>BOUNDED CONCURRENCY</a:t>
+              <a:t>SUPPLEMENTAL SQLITE FIXTURES</a:t>
             </a:r>
           </a:p>
         </p:txBody>
@@ -4299,7 +4304,7 @@
           <p:cNvPr id="2" name="">
             <a:extLst xmlns:a="http://schemas.openxmlformats.org/drawingml/2006/main">
               <a:ext uri="{FF2B5EF4-FFF2-40B4-BE49-F238E27FC236}">
-                <a16:creationId xmlns:a16="http://schemas.microsoft.com/office/drawing/2014/main" id="{5CD23EB5-7AC0-4DD5-BB13-95DF7E6CD16A}"/>
+                <a16:creationId xmlns:a16="http://schemas.microsoft.com/office/drawing/2014/main" id="{9BEBB964-1B42-45B8-9F8F-501F3C2136FE}"/>
               </a:ext>
             </a:extLst>
           </p:cNvPr>
@@ -4346,7 +4351,7 @@
                 <a:ea typeface="Arial"/>
                 <a:cs typeface="Arial"/>
               </a:rPr>
-              <a:t>Thirty-two callers; one approved side effect</a:t>
+              <a:t>Independent processes and crash recovery</a:t>
             </a:r>
           </a:p>
         </p:txBody>
@@ -4356,7 +4361,7 @@
           <p:cNvPr id="3" name="">
             <a:extLst xmlns:a="http://schemas.openxmlformats.org/drawingml/2006/main">
               <a:ext uri="{FF2B5EF4-FFF2-40B4-BE49-F238E27FC236}">
-                <a16:creationId xmlns:a16="http://schemas.microsoft.com/office/drawing/2014/main" id="{19376F26-092D-45D8-BDF3-9E0C990D3611}"/>
+                <a16:creationId xmlns:a16="http://schemas.microsoft.com/office/drawing/2014/main" id="{C08C3FA8-61EC-4866-8E08-4BD64FC46DA2}"/>
               </a:ext>
             </a:extLst>
           </p:cNvPr>
@@ -4386,7 +4391,7 @@
           <p:cNvPr id="4" name="">
             <a:extLst xmlns:a="http://schemas.openxmlformats.org/drawingml/2006/main">
               <a:ext uri="{FF2B5EF4-FFF2-40B4-BE49-F238E27FC236}">
-                <a16:creationId xmlns:a16="http://schemas.microsoft.com/office/drawing/2014/main" id="{FD02DFF7-8937-4C6B-ADF4-5BAC880B00DA}"/>
+                <a16:creationId xmlns:a16="http://schemas.microsoft.com/office/drawing/2014/main" id="{E6DAC30E-CD1C-45CA-8BDC-745B53D0B8DC}"/>
               </a:ext>
             </a:extLst>
           </p:cNvPr>
@@ -4443,7 +4448,7 @@
           <p:cNvPr id="5" name="">
             <a:extLst xmlns:a="http://schemas.openxmlformats.org/drawingml/2006/main">
               <a:ext uri="{FF2B5EF4-FFF2-40B4-BE49-F238E27FC236}">
-                <a16:creationId xmlns:a16="http://schemas.microsoft.com/office/drawing/2014/main" id="{C631BE16-E65B-48F5-AF20-94C242513449}"/>
+                <a16:creationId xmlns:a16="http://schemas.microsoft.com/office/drawing/2014/main" id="{AF09435D-C686-44EE-B9AD-2A601CA1CD82}"/>
               </a:ext>
             </a:extLst>
           </p:cNvPr>
@@ -4475,7 +4480,7 @@
           <p:cNvPr id="6" name="">
             <a:extLst xmlns:a="http://schemas.openxmlformats.org/drawingml/2006/main">
               <a:ext uri="{FF2B5EF4-FFF2-40B4-BE49-F238E27FC236}">
-                <a16:creationId xmlns:a16="http://schemas.microsoft.com/office/drawing/2014/main" id="{EB8DF9AB-660A-49E3-A69F-98651D2EF1D0}"/>
+                <a16:creationId xmlns:a16="http://schemas.microsoft.com/office/drawing/2014/main" id="{D4542911-27B3-4C08-BCB7-E2ABA494C368}"/>
               </a:ext>
             </a:extLst>
           </p:cNvPr>
@@ -4522,7 +4527,7 @@
                 <a:ea typeface="Arial"/>
                 <a:cs typeface="Arial"/>
               </a:rPr>
-              <a:t>32</a:t>
+              <a:t>8</a:t>
             </a:r>
           </a:p>
         </p:txBody>
@@ -4532,7 +4537,7 @@
           <p:cNvPr id="7" name="">
             <a:extLst xmlns:a="http://schemas.openxmlformats.org/drawingml/2006/main">
               <a:ext uri="{FF2B5EF4-FFF2-40B4-BE49-F238E27FC236}">
-                <a16:creationId xmlns:a16="http://schemas.microsoft.com/office/drawing/2014/main" id="{4E77E8DE-D639-411E-AF2C-F461FE8E4A18}"/>
+                <a16:creationId xmlns:a16="http://schemas.microsoft.com/office/drawing/2014/main" id="{8E7E9E8D-C677-456A-B7A1-CAD38EA2C188}"/>
               </a:ext>
             </a:extLst>
           </p:cNvPr>
@@ -4579,7 +4584,7 @@
                 <a:ea typeface="Arial"/>
                 <a:cs typeface="Arial"/>
               </a:rPr>
-              <a:t>concurrent callers</a:t>
+              <a:t>independent processes</a:t>
             </a:r>
           </a:p>
         </p:txBody>
@@ -4589,7 +4594,7 @@
           <p:cNvPr id="8" name="">
             <a:extLst xmlns:a="http://schemas.openxmlformats.org/drawingml/2006/main">
               <a:ext uri="{FF2B5EF4-FFF2-40B4-BE49-F238E27FC236}">
-                <a16:creationId xmlns:a16="http://schemas.microsoft.com/office/drawing/2014/main" id="{5639AB6A-69F0-40DB-ADC1-CF1A73DCF4BA}"/>
+                <a16:creationId xmlns:a16="http://schemas.microsoft.com/office/drawing/2014/main" id="{74A1FC93-AE2E-4372-8A7C-F2580F9EC017}"/>
               </a:ext>
             </a:extLst>
           </p:cNvPr>
@@ -4646,7 +4651,7 @@
           <p:cNvPr id="9" name="">
             <a:extLst xmlns:a="http://schemas.openxmlformats.org/drawingml/2006/main">
               <a:ext uri="{FF2B5EF4-FFF2-40B4-BE49-F238E27FC236}">
-                <a16:creationId xmlns:a16="http://schemas.microsoft.com/office/drawing/2014/main" id="{C982EB48-8669-4015-BA9C-EF1A54757F35}"/>
+                <a16:creationId xmlns:a16="http://schemas.microsoft.com/office/drawing/2014/main" id="{FB74A166-DDAB-45B9-89B2-505213EDCE05}"/>
               </a:ext>
             </a:extLst>
           </p:cNvPr>
@@ -4693,7 +4698,7 @@
                 <a:ea typeface="Arial"/>
                 <a:cs typeface="Arial"/>
               </a:rPr>
-              <a:t>1 mutation  •  1 receipt</a:t>
+              <a:t>1 mutation and 1 receipt</a:t>
             </a:r>
           </a:p>
           <a:p xmlns:a="http://schemas.openxmlformats.org/drawingml/2006/main">
@@ -4716,7 +4721,7 @@
                 <a:ea typeface="Arial"/>
                 <a:cs typeface="Arial"/>
               </a:rPr>
-              <a:t>1 intent  •  1 outcome</a:t>
+              <a:t>7 safe replay responses</a:t>
             </a:r>
           </a:p>
         </p:txBody>
@@ -4726,7 +4731,7 @@
           <p:cNvPr id="10" name="">
             <a:extLst xmlns:a="http://schemas.openxmlformats.org/drawingml/2006/main">
               <a:ext uri="{FF2B5EF4-FFF2-40B4-BE49-F238E27FC236}">
-                <a16:creationId xmlns:a16="http://schemas.microsoft.com/office/drawing/2014/main" id="{EFBA047E-B0D4-45AD-BA15-7659FEB6A661}"/>
+                <a16:creationId xmlns:a16="http://schemas.microsoft.com/office/drawing/2014/main" id="{D148CA39-3429-4CB9-9432-06034D5A31E8}"/>
               </a:ext>
             </a:extLst>
           </p:cNvPr>
@@ -4758,7 +4763,7 @@
           <p:cNvPr id="11" name="">
             <a:extLst xmlns:a="http://schemas.openxmlformats.org/drawingml/2006/main">
               <a:ext uri="{FF2B5EF4-FFF2-40B4-BE49-F238E27FC236}">
-                <a16:creationId xmlns:a16="http://schemas.microsoft.com/office/drawing/2014/main" id="{6D341940-216B-4845-85C0-CC3C2E63F580}"/>
+                <a16:creationId xmlns:a16="http://schemas.microsoft.com/office/drawing/2014/main" id="{579DD8D0-DE43-4016-BEA6-65B0CF1E8CC4}"/>
               </a:ext>
             </a:extLst>
           </p:cNvPr>
@@ -4770,7 +4775,7 @@
         <p:spPr>
           <a:xfrm xmlns:a="http://schemas.openxmlformats.org/drawingml/2006/main">
             <a:off x="5476875" y="2019300"/>
-            <a:ext cx="2667000" cy="285750"/>
+            <a:ext cx="5334000" cy="285750"/>
           </a:xfrm>
           <a:prstGeom xmlns:a="http://schemas.openxmlformats.org/drawingml/2006/main" prst="rect">
             <a:avLst/>
@@ -4805,7 +4810,7 @@
                 <a:ea typeface="Arial"/>
                 <a:cs typeface="Arial"/>
               </a:rPr>
-              <a:t>ATOMIC RECORD</a:t>
+              <a:t>FOUR ABRUPT-EXIT CHECKPOINTS</a:t>
             </a:r>
           </a:p>
         </p:txBody>
@@ -4815,7 +4820,7 @@
           <p:cNvPr id="12" name="">
             <a:extLst xmlns:a="http://schemas.openxmlformats.org/drawingml/2006/main">
               <a:ext uri="{FF2B5EF4-FFF2-40B4-BE49-F238E27FC236}">
-                <a16:creationId xmlns:a16="http://schemas.microsoft.com/office/drawing/2014/main" id="{3BB4AC5E-2E0A-4BCC-8AAD-955A6311F889}"/>
+                <a16:creationId xmlns:a16="http://schemas.microsoft.com/office/drawing/2014/main" id="{041D41B4-74FB-4B27-8D6F-0759FA259765}"/>
               </a:ext>
             </a:extLst>
           </p:cNvPr>
@@ -4847,7 +4852,7 @@
           <p:cNvPr id="13" name="">
             <a:extLst xmlns:a="http://schemas.openxmlformats.org/drawingml/2006/main">
               <a:ext uri="{FF2B5EF4-FFF2-40B4-BE49-F238E27FC236}">
-                <a16:creationId xmlns:a16="http://schemas.microsoft.com/office/drawing/2014/main" id="{D64BAD81-64C5-49BC-AE93-2BD9502D6173}"/>
+                <a16:creationId xmlns:a16="http://schemas.microsoft.com/office/drawing/2014/main" id="{F219C178-6124-4E2E-AE20-10F5F57A4519}"/>
               </a:ext>
             </a:extLst>
           </p:cNvPr>
@@ -4904,7 +4909,7 @@
           <p:cNvPr id="14" name="">
             <a:extLst xmlns:a="http://schemas.openxmlformats.org/drawingml/2006/main">
               <a:ext uri="{FF2B5EF4-FFF2-40B4-BE49-F238E27FC236}">
-                <a16:creationId xmlns:a16="http://schemas.microsoft.com/office/drawing/2014/main" id="{3333C03A-0FD3-4D90-B4E4-0BFEF6423BAB}"/>
+                <a16:creationId xmlns:a16="http://schemas.microsoft.com/office/drawing/2014/main" id="{33F48184-B535-4C6B-B870-793717F67F66}"/>
               </a:ext>
             </a:extLst>
           </p:cNvPr>
@@ -4936,7 +4941,7 @@
           <p:cNvPr id="15" name="">
             <a:extLst xmlns:a="http://schemas.openxmlformats.org/drawingml/2006/main">
               <a:ext uri="{FF2B5EF4-FFF2-40B4-BE49-F238E27FC236}">
-                <a16:creationId xmlns:a16="http://schemas.microsoft.com/office/drawing/2014/main" id="{13BA9A39-BFF3-402B-BD30-19BA618207E3}"/>
+                <a16:creationId xmlns:a16="http://schemas.microsoft.com/office/drawing/2014/main" id="{A78E2F79-5659-42FE-92D4-A9D08594DCB1}"/>
               </a:ext>
             </a:extLst>
           </p:cNvPr>
@@ -4993,7 +4998,7 @@
           <p:cNvPr id="16" name="">
             <a:extLst xmlns:a="http://schemas.openxmlformats.org/drawingml/2006/main">
               <a:ext uri="{FF2B5EF4-FFF2-40B4-BE49-F238E27FC236}">
-                <a16:creationId xmlns:a16="http://schemas.microsoft.com/office/drawing/2014/main" id="{DD359413-35BB-4D95-A08C-3F0BA08DA32B}"/>
+                <a16:creationId xmlns:a16="http://schemas.microsoft.com/office/drawing/2014/main" id="{D782FE6B-55E8-4765-AA0F-B24BEA5D4E47}"/>
               </a:ext>
             </a:extLst>
           </p:cNvPr>
@@ -5025,7 +5030,7 @@
           <p:cNvPr id="17" name="">
             <a:extLst xmlns:a="http://schemas.openxmlformats.org/drawingml/2006/main">
               <a:ext uri="{FF2B5EF4-FFF2-40B4-BE49-F238E27FC236}">
-                <a16:creationId xmlns:a16="http://schemas.microsoft.com/office/drawing/2014/main" id="{37C2400C-318F-4D69-A6EE-8C52592A6F6F}"/>
+                <a16:creationId xmlns:a16="http://schemas.microsoft.com/office/drawing/2014/main" id="{C4C74829-2A44-4413-B101-0763CE831610}"/>
               </a:ext>
             </a:extLst>
           </p:cNvPr>
@@ -5072,7 +5077,7 @@
                 <a:ea typeface="Arial"/>
                 <a:cs typeface="Arial"/>
               </a:rPr>
-              <a:t>receipt</a:t>
+              <a:t>outcome</a:t>
             </a:r>
           </a:p>
         </p:txBody>
@@ -5082,7 +5087,7 @@
           <p:cNvPr id="18" name="">
             <a:extLst xmlns:a="http://schemas.openxmlformats.org/drawingml/2006/main">
               <a:ext uri="{FF2B5EF4-FFF2-40B4-BE49-F238E27FC236}">
-                <a16:creationId xmlns:a16="http://schemas.microsoft.com/office/drawing/2014/main" id="{B80F29BB-4EA0-4181-B04A-E37FD6216B75}"/>
+                <a16:creationId xmlns:a16="http://schemas.microsoft.com/office/drawing/2014/main" id="{A064EDE9-2545-43D4-A510-6568F94D8C64}"/>
               </a:ext>
             </a:extLst>
           </p:cNvPr>
@@ -5114,7 +5119,7 @@
           <p:cNvPr id="19" name="">
             <a:extLst xmlns:a="http://schemas.openxmlformats.org/drawingml/2006/main">
               <a:ext uri="{FF2B5EF4-FFF2-40B4-BE49-F238E27FC236}">
-                <a16:creationId xmlns:a16="http://schemas.microsoft.com/office/drawing/2014/main" id="{F77B6A6F-0D03-4756-8200-52CF481CC33B}"/>
+                <a16:creationId xmlns:a16="http://schemas.microsoft.com/office/drawing/2014/main" id="{7586D1DC-C048-4A45-9379-89A6D9C90962}"/>
               </a:ext>
             </a:extLst>
           </p:cNvPr>
@@ -5161,7 +5166,7 @@
                 <a:ea typeface="Arial"/>
                 <a:cs typeface="Arial"/>
               </a:rPr>
-              <a:t>outcome</a:t>
+              <a:t>commit</a:t>
             </a:r>
           </a:p>
         </p:txBody>
@@ -5171,7 +5176,7 @@
           <p:cNvPr id="20" name="">
             <a:extLst xmlns:a="http://schemas.openxmlformats.org/drawingml/2006/main">
               <a:ext uri="{FF2B5EF4-FFF2-40B4-BE49-F238E27FC236}">
-                <a16:creationId xmlns:a16="http://schemas.microsoft.com/office/drawing/2014/main" id="{7E0B0244-E70E-40E6-99C7-629113629E40}"/>
+                <a16:creationId xmlns:a16="http://schemas.microsoft.com/office/drawing/2014/main" id="{45BA9BE2-6797-4E53-BDB5-F31FE5A5B9BA}"/>
               </a:ext>
             </a:extLst>
           </p:cNvPr>
@@ -5218,7 +5223,7 @@
                 <a:ea typeface="Arial"/>
                 <a:cs typeface="Arial"/>
               </a:rPr>
-              <a:t>31 replay responses returned the same receipt</a:t>
+              <a:t>4/4 recovery checks passed after restart</a:t>
             </a:r>
           </a:p>
         </p:txBody>
@@ -5228,7 +5233,7 @@
           <p:cNvPr id="21" name="">
             <a:extLst xmlns:a="http://schemas.openxmlformats.org/drawingml/2006/main">
               <a:ext uri="{FF2B5EF4-FFF2-40B4-BE49-F238E27FC236}">
-                <a16:creationId xmlns:a16="http://schemas.microsoft.com/office/drawing/2014/main" id="{1C7F52F6-C80A-4382-9B9D-04FDE9008F05}"/>
+                <a16:creationId xmlns:a16="http://schemas.microsoft.com/office/drawing/2014/main" id="{BED304BF-31F4-4CA1-B968-1E70B83FC2E7}"/>
               </a:ext>
             </a:extLst>
           </p:cNvPr>
@@ -5275,7 +5280,7 @@
                 <a:ea typeface="Arial"/>
                 <a:cs typeface="Arial"/>
               </a:rPr>
-              <a:t>Bound: one process + one transactional SQLite database + one request.</a:t>
+              <a:t>One host, independent SQLite connections.</a:t>
             </a:r>
           </a:p>
           <a:p xmlns:a="http://schemas.openxmlformats.org/drawingml/2006/main">
@@ -5298,7 +5303,7 @@
                 <a:ea typeface="Arial"/>
                 <a:cs typeface="Arial"/>
               </a:rPr>
-              <a:t>This is not distributed linearizability.</a:t>
+              <a:t>Power loss and distributed systems remain untested.</a:t>
             </a:r>
           </a:p>
         </p:txBody>
@@ -5306,7 +5311,7 @@
     </p:spTree>
     <p:extLst>
       <p:ext uri="{BB962C8B-B14F-4D97-AF65-F5344CB8AC3E}">
-        <p14:creationId xmlns:p14="http://schemas.microsoft.com/office/powerpoint/2010/main" val="1044163360"/>
+        <p14:creationId xmlns:p14="http://schemas.microsoft.com/office/powerpoint/2010/main" val="1297542210"/>
       </p:ext>
     </p:extLst>
   </p:cSld>
@@ -5337,7 +5342,7 @@
           <p:cNvPr id="21" name="">
             <a:extLst xmlns:a="http://schemas.openxmlformats.org/drawingml/2006/main">
               <a:ext uri="{FF2B5EF4-FFF2-40B4-BE49-F238E27FC236}">
-                <a16:creationId xmlns:a16="http://schemas.microsoft.com/office/drawing/2014/main" id="{65F57354-ACC4-4A2C-B578-6042C9DFAB9A}"/>
+                <a16:creationId xmlns:a16="http://schemas.microsoft.com/office/drawing/2014/main" id="{87235FD9-DB43-42EF-85C2-CFF0A560281A}"/>
               </a:ext>
             </a:extLst>
           </p:cNvPr>
@@ -5394,7 +5399,7 @@
           <p:cNvPr id="2" name="">
             <a:extLst xmlns:a="http://schemas.openxmlformats.org/drawingml/2006/main">
               <a:ext uri="{FF2B5EF4-FFF2-40B4-BE49-F238E27FC236}">
-                <a16:creationId xmlns:a16="http://schemas.microsoft.com/office/drawing/2014/main" id="{073CB9BF-7FA6-4ADC-B6E1-29A5BA1BDF3F}"/>
+                <a16:creationId xmlns:a16="http://schemas.microsoft.com/office/drawing/2014/main" id="{2F20117D-F7F9-4159-A169-A30508872CF4}"/>
               </a:ext>
             </a:extLst>
           </p:cNvPr>
@@ -5451,7 +5456,7 @@
           <p:cNvPr id="3" name="">
             <a:extLst xmlns:a="http://schemas.openxmlformats.org/drawingml/2006/main">
               <a:ext uri="{FF2B5EF4-FFF2-40B4-BE49-F238E27FC236}">
-                <a16:creationId xmlns:a16="http://schemas.microsoft.com/office/drawing/2014/main" id="{0C851226-FEBA-47BC-B44A-EA3799B72CD4}"/>
+                <a16:creationId xmlns:a16="http://schemas.microsoft.com/office/drawing/2014/main" id="{8DC61C47-2F6F-421A-8C59-CA6C57544C4A}"/>
               </a:ext>
             </a:extLst>
           </p:cNvPr>
@@ -5481,7 +5486,7 @@
           <p:cNvPr id="4" name="">
             <a:extLst xmlns:a="http://schemas.openxmlformats.org/drawingml/2006/main">
               <a:ext uri="{FF2B5EF4-FFF2-40B4-BE49-F238E27FC236}">
-                <a16:creationId xmlns:a16="http://schemas.microsoft.com/office/drawing/2014/main" id="{EB186C40-2E05-429E-B0CF-E816078E99D7}"/>
+                <a16:creationId xmlns:a16="http://schemas.microsoft.com/office/drawing/2014/main" id="{5592DFBC-5577-4C2F-BD78-C06AB54D34A5}"/>
               </a:ext>
             </a:extLst>
           </p:cNvPr>
@@ -5538,7 +5543,7 @@
           <p:cNvPr id="5" name="">
             <a:extLst xmlns:a="http://schemas.openxmlformats.org/drawingml/2006/main">
               <a:ext uri="{FF2B5EF4-FFF2-40B4-BE49-F238E27FC236}">
-                <a16:creationId xmlns:a16="http://schemas.microsoft.com/office/drawing/2014/main" id="{49D3E8B3-58D0-486B-A542-575F2AB16EDA}"/>
+                <a16:creationId xmlns:a16="http://schemas.microsoft.com/office/drawing/2014/main" id="{F9CD68F9-51AE-4B27-BA0A-26F334931A33}"/>
               </a:ext>
             </a:extLst>
           </p:cNvPr>
@@ -5570,7 +5575,7 @@
           <p:cNvPr id="6" name="">
             <a:extLst xmlns:a="http://schemas.openxmlformats.org/drawingml/2006/main">
               <a:ext uri="{FF2B5EF4-FFF2-40B4-BE49-F238E27FC236}">
-                <a16:creationId xmlns:a16="http://schemas.microsoft.com/office/drawing/2014/main" id="{522066B9-FE8E-4E6F-B855-F8880F3FE7DB}"/>
+                <a16:creationId xmlns:a16="http://schemas.microsoft.com/office/drawing/2014/main" id="{700F4129-AC68-4908-81EB-B78E4F26424F}"/>
               </a:ext>
             </a:extLst>
           </p:cNvPr>
@@ -5627,7 +5632,7 @@
           <p:cNvPr id="7" name="">
             <a:extLst xmlns:a="http://schemas.openxmlformats.org/drawingml/2006/main">
               <a:ext uri="{FF2B5EF4-FFF2-40B4-BE49-F238E27FC236}">
-                <a16:creationId xmlns:a16="http://schemas.microsoft.com/office/drawing/2014/main" id="{BE6C2766-C66A-4549-B2E0-9DCD0852FC92}"/>
+                <a16:creationId xmlns:a16="http://schemas.microsoft.com/office/drawing/2014/main" id="{931E66AD-36C8-441B-AD70-AC58EF9737F2}"/>
               </a:ext>
             </a:extLst>
           </p:cNvPr>
@@ -5684,7 +5689,7 @@
           <p:cNvPr id="8" name="">
             <a:extLst xmlns:a="http://schemas.openxmlformats.org/drawingml/2006/main">
               <a:ext uri="{FF2B5EF4-FFF2-40B4-BE49-F238E27FC236}">
-                <a16:creationId xmlns:a16="http://schemas.microsoft.com/office/drawing/2014/main" id="{1CB3D34E-D487-47B6-9CDF-A9723653811B}"/>
+                <a16:creationId xmlns:a16="http://schemas.microsoft.com/office/drawing/2014/main" id="{96422F36-7797-4A19-86EF-7DF0314CC030}"/>
               </a:ext>
             </a:extLst>
           </p:cNvPr>
@@ -5716,7 +5721,7 @@
           <p:cNvPr id="9" name="">
             <a:extLst xmlns:a="http://schemas.openxmlformats.org/drawingml/2006/main">
               <a:ext uri="{FF2B5EF4-FFF2-40B4-BE49-F238E27FC236}">
-                <a16:creationId xmlns:a16="http://schemas.microsoft.com/office/drawing/2014/main" id="{D03430C4-2BFA-46C6-AFD8-C54E6F72178A}"/>
+                <a16:creationId xmlns:a16="http://schemas.microsoft.com/office/drawing/2014/main" id="{F0CBBC8A-1F05-4BB0-BAE5-1886DC2E3812}"/>
               </a:ext>
             </a:extLst>
           </p:cNvPr>
@@ -5773,7 +5778,7 @@
           <p:cNvPr id="10" name="">
             <a:extLst xmlns:a="http://schemas.openxmlformats.org/drawingml/2006/main">
               <a:ext uri="{FF2B5EF4-FFF2-40B4-BE49-F238E27FC236}">
-                <a16:creationId xmlns:a16="http://schemas.microsoft.com/office/drawing/2014/main" id="{4B94595F-8CD7-4D45-B88C-B03A1A62983D}"/>
+                <a16:creationId xmlns:a16="http://schemas.microsoft.com/office/drawing/2014/main" id="{1828D360-1339-4001-AC38-710CB855676C}"/>
               </a:ext>
             </a:extLst>
           </p:cNvPr>
@@ -5830,7 +5835,7 @@
           <p:cNvPr id="11" name="">
             <a:extLst xmlns:a="http://schemas.openxmlformats.org/drawingml/2006/main">
               <a:ext uri="{FF2B5EF4-FFF2-40B4-BE49-F238E27FC236}">
-                <a16:creationId xmlns:a16="http://schemas.microsoft.com/office/drawing/2014/main" id="{0B686EE5-33B4-4AF6-93F6-2A632D2044A5}"/>
+                <a16:creationId xmlns:a16="http://schemas.microsoft.com/office/drawing/2014/main" id="{83A331C9-13A2-4041-BE45-F8F38D761E14}"/>
               </a:ext>
             </a:extLst>
           </p:cNvPr>
@@ -5862,7 +5867,7 @@
           <p:cNvPr id="12" name="">
             <a:extLst xmlns:a="http://schemas.openxmlformats.org/drawingml/2006/main">
               <a:ext uri="{FF2B5EF4-FFF2-40B4-BE49-F238E27FC236}">
-                <a16:creationId xmlns:a16="http://schemas.microsoft.com/office/drawing/2014/main" id="{362ABE2E-758A-4636-9FA0-47B943DAB75F}"/>
+                <a16:creationId xmlns:a16="http://schemas.microsoft.com/office/drawing/2014/main" id="{AD760A1C-C45A-4639-8E41-312BF444C562}"/>
               </a:ext>
             </a:extLst>
           </p:cNvPr>
@@ -5919,7 +5924,7 @@
           <p:cNvPr id="13" name="">
             <a:extLst xmlns:a="http://schemas.openxmlformats.org/drawingml/2006/main">
               <a:ext uri="{FF2B5EF4-FFF2-40B4-BE49-F238E27FC236}">
-                <a16:creationId xmlns:a16="http://schemas.microsoft.com/office/drawing/2014/main" id="{12A4512F-E396-4AF2-BDD8-0BDB18F8DCA3}"/>
+                <a16:creationId xmlns:a16="http://schemas.microsoft.com/office/drawing/2014/main" id="{AC21621D-EA92-4E3D-80CD-9E9EABD8D5A9}"/>
               </a:ext>
             </a:extLst>
           </p:cNvPr>
@@ -5976,7 +5981,7 @@
           <p:cNvPr id="14" name="">
             <a:extLst xmlns:a="http://schemas.openxmlformats.org/drawingml/2006/main">
               <a:ext uri="{FF2B5EF4-FFF2-40B4-BE49-F238E27FC236}">
-                <a16:creationId xmlns:a16="http://schemas.microsoft.com/office/drawing/2014/main" id="{B2B46F8E-5978-466E-8E61-6A908D02841D}"/>
+                <a16:creationId xmlns:a16="http://schemas.microsoft.com/office/drawing/2014/main" id="{AEAE83B2-998B-4E35-9E63-5998B038824E}"/>
               </a:ext>
             </a:extLst>
           </p:cNvPr>
@@ -6008,7 +6013,7 @@
           <p:cNvPr id="15" name="">
             <a:extLst xmlns:a="http://schemas.openxmlformats.org/drawingml/2006/main">
               <a:ext uri="{FF2B5EF4-FFF2-40B4-BE49-F238E27FC236}">
-                <a16:creationId xmlns:a16="http://schemas.microsoft.com/office/drawing/2014/main" id="{AA903DED-6C50-451D-977C-38825ADA97C3}"/>
+                <a16:creationId xmlns:a16="http://schemas.microsoft.com/office/drawing/2014/main" id="{9B70CA89-D97D-4985-91E5-8D1EFDE078F5}"/>
               </a:ext>
             </a:extLst>
           </p:cNvPr>
@@ -6065,7 +6070,7 @@
           <p:cNvPr id="16" name="">
             <a:extLst xmlns:a="http://schemas.openxmlformats.org/drawingml/2006/main">
               <a:ext uri="{FF2B5EF4-FFF2-40B4-BE49-F238E27FC236}">
-                <a16:creationId xmlns:a16="http://schemas.microsoft.com/office/drawing/2014/main" id="{B5829B2E-F544-4755-8360-CEB5B24C0C97}"/>
+                <a16:creationId xmlns:a16="http://schemas.microsoft.com/office/drawing/2014/main" id="{D38F6FD1-738F-4347-83A5-85A522CAE175}"/>
               </a:ext>
             </a:extLst>
           </p:cNvPr>
@@ -6122,7 +6127,7 @@
           <p:cNvPr id="17" name="">
             <a:extLst xmlns:a="http://schemas.openxmlformats.org/drawingml/2006/main">
               <a:ext uri="{FF2B5EF4-FFF2-40B4-BE49-F238E27FC236}">
-                <a16:creationId xmlns:a16="http://schemas.microsoft.com/office/drawing/2014/main" id="{812933FB-14EF-4435-9008-CCFB49F2155D}"/>
+                <a16:creationId xmlns:a16="http://schemas.microsoft.com/office/drawing/2014/main" id="{767A905A-BFE9-4D1F-B710-10B35B52B3F0}"/>
               </a:ext>
             </a:extLst>
           </p:cNvPr>
@@ -6154,7 +6159,7 @@
           <p:cNvPr id="18" name="">
             <a:extLst xmlns:a="http://schemas.openxmlformats.org/drawingml/2006/main">
               <a:ext uri="{FF2B5EF4-FFF2-40B4-BE49-F238E27FC236}">
-                <a16:creationId xmlns:a16="http://schemas.microsoft.com/office/drawing/2014/main" id="{CC136385-FD8C-48A6-AD93-78EE99D2E60D}"/>
+                <a16:creationId xmlns:a16="http://schemas.microsoft.com/office/drawing/2014/main" id="{4492F279-950B-4EB5-A3E5-1DDEC3D82178}"/>
               </a:ext>
             </a:extLst>
           </p:cNvPr>
@@ -6211,7 +6216,7 @@
           <p:cNvPr id="19" name="">
             <a:extLst xmlns:a="http://schemas.openxmlformats.org/drawingml/2006/main">
               <a:ext uri="{FF2B5EF4-FFF2-40B4-BE49-F238E27FC236}">
-                <a16:creationId xmlns:a16="http://schemas.microsoft.com/office/drawing/2014/main" id="{8852F6F3-5F9B-4BF6-BFDD-3EC3D2CA6D61}"/>
+                <a16:creationId xmlns:a16="http://schemas.microsoft.com/office/drawing/2014/main" id="{D9E02A54-3DE9-4630-BEE5-A6B42113B000}"/>
               </a:ext>
             </a:extLst>
           </p:cNvPr>
@@ -6268,7 +6273,7 @@
           <p:cNvPr id="20" name="">
             <a:extLst xmlns:a="http://schemas.openxmlformats.org/drawingml/2006/main">
               <a:ext uri="{FF2B5EF4-FFF2-40B4-BE49-F238E27FC236}">
-                <a16:creationId xmlns:a16="http://schemas.microsoft.com/office/drawing/2014/main" id="{DDAFEB4B-AAD6-4B98-86E7-5EE5CF62C50D}"/>
+                <a16:creationId xmlns:a16="http://schemas.microsoft.com/office/drawing/2014/main" id="{5125AC36-D62B-4A24-B4ED-D60A1D9C2747}"/>
               </a:ext>
             </a:extLst>
           </p:cNvPr>
@@ -6323,7 +6328,7 @@
     </p:spTree>
     <p:extLst>
       <p:ext uri="{BB962C8B-B14F-4D97-AF65-F5344CB8AC3E}">
-        <p14:creationId xmlns:p14="http://schemas.microsoft.com/office/powerpoint/2010/main" val="959515679"/>
+        <p14:creationId xmlns:p14="http://schemas.microsoft.com/office/powerpoint/2010/main" val="1514912575"/>
       </p:ext>
     </p:extLst>
   </p:cSld>
@@ -6354,7 +6359,7 @@
           <p:cNvPr id="15" name="">
             <a:extLst xmlns:a="http://schemas.openxmlformats.org/drawingml/2006/main">
               <a:ext uri="{FF2B5EF4-FFF2-40B4-BE49-F238E27FC236}">
-                <a16:creationId xmlns:a16="http://schemas.microsoft.com/office/drawing/2014/main" id="{FAC178DE-4AE6-4240-9F82-B5D92D5383BE}"/>
+                <a16:creationId xmlns:a16="http://schemas.microsoft.com/office/drawing/2014/main" id="{2AD2F843-E1A8-4BF0-85AE-E3495B4BA347}"/>
               </a:ext>
             </a:extLst>
           </p:cNvPr>
@@ -6411,7 +6416,7 @@
           <p:cNvPr id="2" name="">
             <a:extLst xmlns:a="http://schemas.openxmlformats.org/drawingml/2006/main">
               <a:ext uri="{FF2B5EF4-FFF2-40B4-BE49-F238E27FC236}">
-                <a16:creationId xmlns:a16="http://schemas.microsoft.com/office/drawing/2014/main" id="{5F1D2605-8E7D-40F8-8F0F-AA06A12CF17D}"/>
+                <a16:creationId xmlns:a16="http://schemas.microsoft.com/office/drawing/2014/main" id="{3439824E-9DD1-4165-A328-40F8DF2766D7}"/>
               </a:ext>
             </a:extLst>
           </p:cNvPr>
@@ -6468,7 +6473,7 @@
           <p:cNvPr id="3" name="">
             <a:extLst xmlns:a="http://schemas.openxmlformats.org/drawingml/2006/main">
               <a:ext uri="{FF2B5EF4-FFF2-40B4-BE49-F238E27FC236}">
-                <a16:creationId xmlns:a16="http://schemas.microsoft.com/office/drawing/2014/main" id="{5F7883A7-BDC8-4D13-B22F-3D2D5297F7DD}"/>
+                <a16:creationId xmlns:a16="http://schemas.microsoft.com/office/drawing/2014/main" id="{7F4F3CF1-74D7-4942-915E-96C2A540AAE0}"/>
               </a:ext>
             </a:extLst>
           </p:cNvPr>
@@ -6498,7 +6503,7 @@
           <p:cNvPr id="4" name="">
             <a:extLst xmlns:a="http://schemas.openxmlformats.org/drawingml/2006/main">
               <a:ext uri="{FF2B5EF4-FFF2-40B4-BE49-F238E27FC236}">
-                <a16:creationId xmlns:a16="http://schemas.microsoft.com/office/drawing/2014/main" id="{A320D738-1871-4955-9F41-7C4D17F32A64}"/>
+                <a16:creationId xmlns:a16="http://schemas.microsoft.com/office/drawing/2014/main" id="{8A47CDAE-33E1-4680-B8B7-6FF614EA1494}"/>
               </a:ext>
             </a:extLst>
           </p:cNvPr>
@@ -6555,7 +6560,7 @@
           <p:cNvPr id="5" name="">
             <a:extLst xmlns:a="http://schemas.openxmlformats.org/drawingml/2006/main">
               <a:ext uri="{FF2B5EF4-FFF2-40B4-BE49-F238E27FC236}">
-                <a16:creationId xmlns:a16="http://schemas.microsoft.com/office/drawing/2014/main" id="{6E4A3505-B88C-4C2E-A7D1-755F25CC0F6F}"/>
+                <a16:creationId xmlns:a16="http://schemas.microsoft.com/office/drawing/2014/main" id="{FD685399-4C3F-4EC0-A071-666E066A0997}"/>
               </a:ext>
             </a:extLst>
           </p:cNvPr>
@@ -6587,7 +6592,7 @@
           <p:cNvPr id="6" name="">
             <a:extLst xmlns:a="http://schemas.openxmlformats.org/drawingml/2006/main">
               <a:ext uri="{FF2B5EF4-FFF2-40B4-BE49-F238E27FC236}">
-                <a16:creationId xmlns:a16="http://schemas.microsoft.com/office/drawing/2014/main" id="{9092782E-6CD3-48C8-A07B-715E08FFA751}"/>
+                <a16:creationId xmlns:a16="http://schemas.microsoft.com/office/drawing/2014/main" id="{867B5FF3-22E4-41FE-94D3-DCE1AE78D450}"/>
               </a:ext>
             </a:extLst>
           </p:cNvPr>
@@ -6619,7 +6624,7 @@
           <p:cNvPr id="7" name="">
             <a:extLst xmlns:a="http://schemas.openxmlformats.org/drawingml/2006/main">
               <a:ext uri="{FF2B5EF4-FFF2-40B4-BE49-F238E27FC236}">
-                <a16:creationId xmlns:a16="http://schemas.microsoft.com/office/drawing/2014/main" id="{4A5F7B67-61B7-40A3-805A-7EE6513B34BE}"/>
+                <a16:creationId xmlns:a16="http://schemas.microsoft.com/office/drawing/2014/main" id="{FAB619E8-2180-4DD8-A459-850E35456BC8}"/>
               </a:ext>
             </a:extLst>
           </p:cNvPr>
@@ -6676,7 +6681,7 @@
           <p:cNvPr id="8" name="">
             <a:extLst xmlns:a="http://schemas.openxmlformats.org/drawingml/2006/main">
               <a:ext uri="{FF2B5EF4-FFF2-40B4-BE49-F238E27FC236}">
-                <a16:creationId xmlns:a16="http://schemas.microsoft.com/office/drawing/2014/main" id="{34F25684-2D16-4D9D-93EF-76DB657AE272}"/>
+                <a16:creationId xmlns:a16="http://schemas.microsoft.com/office/drawing/2014/main" id="{727720D3-306B-4450-A734-911D3D344EE9}"/>
               </a:ext>
             </a:extLst>
           </p:cNvPr>
@@ -6733,7 +6738,7 @@
           <p:cNvPr id="9" name="">
             <a:extLst xmlns:a="http://schemas.openxmlformats.org/drawingml/2006/main">
               <a:ext uri="{FF2B5EF4-FFF2-40B4-BE49-F238E27FC236}">
-                <a16:creationId xmlns:a16="http://schemas.microsoft.com/office/drawing/2014/main" id="{BF3F02FE-BC93-48C9-8176-2CEBF7B40103}"/>
+                <a16:creationId xmlns:a16="http://schemas.microsoft.com/office/drawing/2014/main" id="{51EE9A1E-D420-4860-961B-36F723F1FA51}"/>
               </a:ext>
             </a:extLst>
           </p:cNvPr>
@@ -6765,7 +6770,7 @@
           <p:cNvPr id="10" name="">
             <a:extLst xmlns:a="http://schemas.openxmlformats.org/drawingml/2006/main">
               <a:ext uri="{FF2B5EF4-FFF2-40B4-BE49-F238E27FC236}">
-                <a16:creationId xmlns:a16="http://schemas.microsoft.com/office/drawing/2014/main" id="{5855F9D8-8A21-45BD-8F21-82DA4151DF5B}"/>
+                <a16:creationId xmlns:a16="http://schemas.microsoft.com/office/drawing/2014/main" id="{6DAC183B-E386-415D-BA08-A1D4283F3C42}"/>
               </a:ext>
             </a:extLst>
           </p:cNvPr>
@@ -6797,7 +6802,7 @@
           <p:cNvPr id="11" name="">
             <a:extLst xmlns:a="http://schemas.openxmlformats.org/drawingml/2006/main">
               <a:ext uri="{FF2B5EF4-FFF2-40B4-BE49-F238E27FC236}">
-                <a16:creationId xmlns:a16="http://schemas.microsoft.com/office/drawing/2014/main" id="{3C011AAC-DB3E-470F-87BD-212BD49FC555}"/>
+                <a16:creationId xmlns:a16="http://schemas.microsoft.com/office/drawing/2014/main" id="{451A9528-1F02-42F8-BD4A-FCCA94D2BF6B}"/>
               </a:ext>
             </a:extLst>
           </p:cNvPr>
@@ -6854,7 +6859,7 @@
           <p:cNvPr id="12" name="">
             <a:extLst xmlns:a="http://schemas.openxmlformats.org/drawingml/2006/main">
               <a:ext uri="{FF2B5EF4-FFF2-40B4-BE49-F238E27FC236}">
-                <a16:creationId xmlns:a16="http://schemas.microsoft.com/office/drawing/2014/main" id="{823073CF-269B-460F-843C-C4462EDBB2DE}"/>
+                <a16:creationId xmlns:a16="http://schemas.microsoft.com/office/drawing/2014/main" id="{D7807C68-E220-4897-9A82-8C9998C67558}"/>
               </a:ext>
             </a:extLst>
           </p:cNvPr>
@@ -6911,7 +6916,7 @@
           <p:cNvPr id="13" name="">
             <a:extLst xmlns:a="http://schemas.openxmlformats.org/drawingml/2006/main">
               <a:ext uri="{FF2B5EF4-FFF2-40B4-BE49-F238E27FC236}">
-                <a16:creationId xmlns:a16="http://schemas.microsoft.com/office/drawing/2014/main" id="{B18240C7-CEDC-4373-B033-C7594831CDF4}"/>
+                <a16:creationId xmlns:a16="http://schemas.microsoft.com/office/drawing/2014/main" id="{0E61A63A-D582-4616-B1B6-6F5B8A4197EE}"/>
               </a:ext>
             </a:extLst>
           </p:cNvPr>
@@ -6968,7 +6973,7 @@
           <p:cNvPr id="14" name="">
             <a:extLst xmlns:a="http://schemas.openxmlformats.org/drawingml/2006/main">
               <a:ext uri="{FF2B5EF4-FFF2-40B4-BE49-F238E27FC236}">
-                <a16:creationId xmlns:a16="http://schemas.microsoft.com/office/drawing/2014/main" id="{B6EAF706-2785-4494-B727-76089365CE0A}"/>
+                <a16:creationId xmlns:a16="http://schemas.microsoft.com/office/drawing/2014/main" id="{05B47DE5-2370-4374-A864-7C0CA4E510F7}"/>
               </a:ext>
             </a:extLst>
           </p:cNvPr>
@@ -7023,7 +7028,7 @@
     </p:spTree>
     <p:extLst>
       <p:ext uri="{BB962C8B-B14F-4D97-AF65-F5344CB8AC3E}">
-        <p14:creationId xmlns:p14="http://schemas.microsoft.com/office/powerpoint/2010/main" val="904507493"/>
+        <p14:creationId xmlns:p14="http://schemas.microsoft.com/office/powerpoint/2010/main" val="1863439599"/>
       </p:ext>
     </p:extLst>
   </p:cSld>
@@ -7054,7 +7059,7 @@
           <p:cNvPr id="13" name="">
             <a:extLst xmlns:a="http://schemas.openxmlformats.org/drawingml/2006/main">
               <a:ext uri="{FF2B5EF4-FFF2-40B4-BE49-F238E27FC236}">
-                <a16:creationId xmlns:a16="http://schemas.microsoft.com/office/drawing/2014/main" id="{84C76732-5401-4CD2-9FFD-B991DF446D86}"/>
+                <a16:creationId xmlns:a16="http://schemas.microsoft.com/office/drawing/2014/main" id="{B41F7E60-F09F-4E99-8917-2FB99EB453CF}"/>
               </a:ext>
             </a:extLst>
           </p:cNvPr>
@@ -7111,7 +7116,7 @@
           <p:cNvPr id="2" name="">
             <a:extLst xmlns:a="http://schemas.openxmlformats.org/drawingml/2006/main">
               <a:ext uri="{FF2B5EF4-FFF2-40B4-BE49-F238E27FC236}">
-                <a16:creationId xmlns:a16="http://schemas.microsoft.com/office/drawing/2014/main" id="{F300770F-77E9-4B4C-835D-190A4FA104B6}"/>
+                <a16:creationId xmlns:a16="http://schemas.microsoft.com/office/drawing/2014/main" id="{A2E70330-50C2-4116-B0E0-39AFA4D95605}"/>
               </a:ext>
             </a:extLst>
           </p:cNvPr>
@@ -7168,7 +7173,7 @@
           <p:cNvPr id="3" name="">
             <a:extLst xmlns:a="http://schemas.openxmlformats.org/drawingml/2006/main">
               <a:ext uri="{FF2B5EF4-FFF2-40B4-BE49-F238E27FC236}">
-                <a16:creationId xmlns:a16="http://schemas.microsoft.com/office/drawing/2014/main" id="{5F1857A8-B2E4-4EA2-8C2F-3429C2A0E38C}"/>
+                <a16:creationId xmlns:a16="http://schemas.microsoft.com/office/drawing/2014/main" id="{F6E4B4E9-FA7B-4065-B6FD-12EF0214D84D}"/>
               </a:ext>
             </a:extLst>
           </p:cNvPr>
@@ -7198,7 +7203,7 @@
           <p:cNvPr id="4" name="">
             <a:extLst xmlns:a="http://schemas.openxmlformats.org/drawingml/2006/main">
               <a:ext uri="{FF2B5EF4-FFF2-40B4-BE49-F238E27FC236}">
-                <a16:creationId xmlns:a16="http://schemas.microsoft.com/office/drawing/2014/main" id="{4B2E4396-9285-4B75-B4DF-F346340F294A}"/>
+                <a16:creationId xmlns:a16="http://schemas.microsoft.com/office/drawing/2014/main" id="{255DBC3F-FF70-4072-BD0A-99D299120E09}"/>
               </a:ext>
             </a:extLst>
           </p:cNvPr>
@@ -7255,7 +7260,7 @@
           <p:cNvPr id="5" name="">
             <a:extLst xmlns:a="http://schemas.openxmlformats.org/drawingml/2006/main">
               <a:ext uri="{FF2B5EF4-FFF2-40B4-BE49-F238E27FC236}">
-                <a16:creationId xmlns:a16="http://schemas.microsoft.com/office/drawing/2014/main" id="{165A617B-0441-4782-9743-4CE87D1475EF}"/>
+                <a16:creationId xmlns:a16="http://schemas.microsoft.com/office/drawing/2014/main" id="{66E3835B-97FA-48DF-9C58-44ACFBA7C4ED}"/>
               </a:ext>
             </a:extLst>
           </p:cNvPr>
@@ -7287,7 +7292,7 @@
           <p:cNvPr id="6" name="">
             <a:extLst xmlns:a="http://schemas.openxmlformats.org/drawingml/2006/main">
               <a:ext uri="{FF2B5EF4-FFF2-40B4-BE49-F238E27FC236}">
-                <a16:creationId xmlns:a16="http://schemas.microsoft.com/office/drawing/2014/main" id="{DA719541-E8AD-40F1-AC2F-FCA1F516BDF0}"/>
+                <a16:creationId xmlns:a16="http://schemas.microsoft.com/office/drawing/2014/main" id="{0446DF6F-AD6C-4EB6-8B7D-B8FD9C65C928}"/>
               </a:ext>
             </a:extLst>
           </p:cNvPr>
@@ -7344,7 +7349,7 @@
           <p:cNvPr id="7" name="">
             <a:extLst xmlns:a="http://schemas.openxmlformats.org/drawingml/2006/main">
               <a:ext uri="{FF2B5EF4-FFF2-40B4-BE49-F238E27FC236}">
-                <a16:creationId xmlns:a16="http://schemas.microsoft.com/office/drawing/2014/main" id="{95293580-9E16-4D94-919C-CFD87DA68247}"/>
+                <a16:creationId xmlns:a16="http://schemas.microsoft.com/office/drawing/2014/main" id="{26AD3E99-A052-4F53-9C35-2A8FD9BC61FD}"/>
               </a:ext>
             </a:extLst>
           </p:cNvPr>
@@ -7516,7 +7521,7 @@
           <p:cNvPr id="8" name="">
             <a:extLst xmlns:a="http://schemas.openxmlformats.org/drawingml/2006/main">
               <a:ext uri="{FF2B5EF4-FFF2-40B4-BE49-F238E27FC236}">
-                <a16:creationId xmlns:a16="http://schemas.microsoft.com/office/drawing/2014/main" id="{D22E1076-548D-4DF7-85F5-505BBDEFB1A1}"/>
+                <a16:creationId xmlns:a16="http://schemas.microsoft.com/office/drawing/2014/main" id="{2596F3F9-C65D-464B-A17A-9FA25F4438B9}"/>
               </a:ext>
             </a:extLst>
           </p:cNvPr>
@@ -7548,7 +7553,7 @@
           <p:cNvPr id="9" name="">
             <a:extLst xmlns:a="http://schemas.openxmlformats.org/drawingml/2006/main">
               <a:ext uri="{FF2B5EF4-FFF2-40B4-BE49-F238E27FC236}">
-                <a16:creationId xmlns:a16="http://schemas.microsoft.com/office/drawing/2014/main" id="{6B56292E-9721-4E80-A34E-E5137FC38C76}"/>
+                <a16:creationId xmlns:a16="http://schemas.microsoft.com/office/drawing/2014/main" id="{DA68D457-B054-46C5-A41C-D734E958A513}"/>
               </a:ext>
             </a:extLst>
           </p:cNvPr>
@@ -7605,7 +7610,7 @@
           <p:cNvPr id="10" name="">
             <a:extLst xmlns:a="http://schemas.openxmlformats.org/drawingml/2006/main">
               <a:ext uri="{FF2B5EF4-FFF2-40B4-BE49-F238E27FC236}">
-                <a16:creationId xmlns:a16="http://schemas.microsoft.com/office/drawing/2014/main" id="{FA02725D-2AC8-4590-9872-336233371394}"/>
+                <a16:creationId xmlns:a16="http://schemas.microsoft.com/office/drawing/2014/main" id="{E36BF747-EAE3-4248-801D-CAEC8E5B882B}"/>
               </a:ext>
             </a:extLst>
           </p:cNvPr>
@@ -7731,7 +7736,7 @@
           <p:cNvPr id="11" name="">
             <a:extLst xmlns:a="http://schemas.openxmlformats.org/drawingml/2006/main">
               <a:ext uri="{FF2B5EF4-FFF2-40B4-BE49-F238E27FC236}">
-                <a16:creationId xmlns:a16="http://schemas.microsoft.com/office/drawing/2014/main" id="{9347CEFC-A7A5-4A40-8035-896BFA083492}"/>
+                <a16:creationId xmlns:a16="http://schemas.microsoft.com/office/drawing/2014/main" id="{18CE76C1-EB6E-46C5-A530-D8080C38D954}"/>
               </a:ext>
             </a:extLst>
           </p:cNvPr>
@@ -7788,7 +7793,7 @@
           <p:cNvPr id="12" name="">
             <a:extLst xmlns:a="http://schemas.openxmlformats.org/drawingml/2006/main">
               <a:ext uri="{FF2B5EF4-FFF2-40B4-BE49-F238E27FC236}">
-                <a16:creationId xmlns:a16="http://schemas.microsoft.com/office/drawing/2014/main" id="{5E98EA4A-D36E-4240-B1A4-AC14F82C59AF}"/>
+                <a16:creationId xmlns:a16="http://schemas.microsoft.com/office/drawing/2014/main" id="{1B9CC156-D1FA-4FAF-B729-5148AE7542D3}"/>
               </a:ext>
             </a:extLst>
           </p:cNvPr>
@@ -7843,7 +7848,7 @@
     </p:spTree>
     <p:extLst>
       <p:ext uri="{BB962C8B-B14F-4D97-AF65-F5344CB8AC3E}">
-        <p14:creationId xmlns:p14="http://schemas.microsoft.com/office/powerpoint/2010/main" val="1380885948"/>
+        <p14:creationId xmlns:p14="http://schemas.microsoft.com/office/powerpoint/2010/main" val="296365641"/>
       </p:ext>
     </p:extLst>
   </p:cSld>
@@ -7874,7 +7879,7 @@
           <p:cNvPr id="18" name="">
             <a:extLst xmlns:a="http://schemas.openxmlformats.org/drawingml/2006/main">
               <a:ext uri="{FF2B5EF4-FFF2-40B4-BE49-F238E27FC236}">
-                <a16:creationId xmlns:a16="http://schemas.microsoft.com/office/drawing/2014/main" id="{89074CE5-0C5E-46DA-876D-FD46279FB465}"/>
+                <a16:creationId xmlns:a16="http://schemas.microsoft.com/office/drawing/2014/main" id="{4BDE0BDF-E76C-486C-A303-71224BF5919E}"/>
               </a:ext>
             </a:extLst>
           </p:cNvPr>
@@ -7931,7 +7936,7 @@
           <p:cNvPr id="2" name="">
             <a:extLst xmlns:a="http://schemas.openxmlformats.org/drawingml/2006/main">
               <a:ext uri="{FF2B5EF4-FFF2-40B4-BE49-F238E27FC236}">
-                <a16:creationId xmlns:a16="http://schemas.microsoft.com/office/drawing/2014/main" id="{A8742419-CD1A-4F1D-A1A1-3E3EA587E5C5}"/>
+                <a16:creationId xmlns:a16="http://schemas.microsoft.com/office/drawing/2014/main" id="{086C4DEA-09C0-4626-8995-AA142539A0C7}"/>
               </a:ext>
             </a:extLst>
           </p:cNvPr>
@@ -7988,7 +7993,7 @@
           <p:cNvPr id="3" name="">
             <a:extLst xmlns:a="http://schemas.openxmlformats.org/drawingml/2006/main">
               <a:ext uri="{FF2B5EF4-FFF2-40B4-BE49-F238E27FC236}">
-                <a16:creationId xmlns:a16="http://schemas.microsoft.com/office/drawing/2014/main" id="{ED7A6DA2-A89E-4604-8DA7-1578AD286A79}"/>
+                <a16:creationId xmlns:a16="http://schemas.microsoft.com/office/drawing/2014/main" id="{40E24502-7AD5-4445-9722-FEA69819E5C5}"/>
               </a:ext>
             </a:extLst>
           </p:cNvPr>
@@ -8018,7 +8023,7 @@
           <p:cNvPr id="4" name="">
             <a:extLst xmlns:a="http://schemas.openxmlformats.org/drawingml/2006/main">
               <a:ext uri="{FF2B5EF4-FFF2-40B4-BE49-F238E27FC236}">
-                <a16:creationId xmlns:a16="http://schemas.microsoft.com/office/drawing/2014/main" id="{9B3F27BB-04C4-4DBD-AA6E-871486B1A060}"/>
+                <a16:creationId xmlns:a16="http://schemas.microsoft.com/office/drawing/2014/main" id="{E505F5CF-D96E-4BB4-9D89-529278E95ECF}"/>
               </a:ext>
             </a:extLst>
           </p:cNvPr>
@@ -8075,7 +8080,7 @@
           <p:cNvPr id="5" name="">
             <a:extLst xmlns:a="http://schemas.openxmlformats.org/drawingml/2006/main">
               <a:ext uri="{FF2B5EF4-FFF2-40B4-BE49-F238E27FC236}">
-                <a16:creationId xmlns:a16="http://schemas.microsoft.com/office/drawing/2014/main" id="{06076525-F1F5-4A2E-B323-184A5EDA440F}"/>
+                <a16:creationId xmlns:a16="http://schemas.microsoft.com/office/drawing/2014/main" id="{77EA5BAF-2E03-4D24-BCA6-9C2534742B90}"/>
               </a:ext>
             </a:extLst>
           </p:cNvPr>
@@ -8107,7 +8112,7 @@
           <p:cNvPr id="6" name="">
             <a:extLst xmlns:a="http://schemas.openxmlformats.org/drawingml/2006/main">
               <a:ext uri="{FF2B5EF4-FFF2-40B4-BE49-F238E27FC236}">
-                <a16:creationId xmlns:a16="http://schemas.microsoft.com/office/drawing/2014/main" id="{6305524F-28A0-4107-B16C-0D1B54C746A1}"/>
+                <a16:creationId xmlns:a16="http://schemas.microsoft.com/office/drawing/2014/main" id="{3CC66F8D-1BFE-47D7-82AF-745C0D749103}"/>
               </a:ext>
             </a:extLst>
           </p:cNvPr>
@@ -8164,7 +8169,7 @@
           <p:cNvPr id="7" name="">
             <a:extLst xmlns:a="http://schemas.openxmlformats.org/drawingml/2006/main">
               <a:ext uri="{FF2B5EF4-FFF2-40B4-BE49-F238E27FC236}">
-                <a16:creationId xmlns:a16="http://schemas.microsoft.com/office/drawing/2014/main" id="{B4AA5838-509A-4B4E-8DBC-206193F796E0}"/>
+                <a16:creationId xmlns:a16="http://schemas.microsoft.com/office/drawing/2014/main" id="{FF54DAE2-0222-456E-8E2B-D27D289F3134}"/>
               </a:ext>
             </a:extLst>
           </p:cNvPr>
@@ -8221,7 +8226,7 @@
           <p:cNvPr id="8" name="">
             <a:extLst xmlns:a="http://schemas.openxmlformats.org/drawingml/2006/main">
               <a:ext uri="{FF2B5EF4-FFF2-40B4-BE49-F238E27FC236}">
-                <a16:creationId xmlns:a16="http://schemas.microsoft.com/office/drawing/2014/main" id="{3EE697E8-601F-435E-B78D-6960C8A5A719}"/>
+                <a16:creationId xmlns:a16="http://schemas.microsoft.com/office/drawing/2014/main" id="{2F143C54-3271-4919-9732-CE04FC533949}"/>
               </a:ext>
             </a:extLst>
           </p:cNvPr>
@@ -8278,7 +8283,7 @@
           <p:cNvPr id="9" name="">
             <a:extLst xmlns:a="http://schemas.openxmlformats.org/drawingml/2006/main">
               <a:ext uri="{FF2B5EF4-FFF2-40B4-BE49-F238E27FC236}">
-                <a16:creationId xmlns:a16="http://schemas.microsoft.com/office/drawing/2014/main" id="{BD58D4A1-B11D-42D4-AD91-DB14FAFBCFCE}"/>
+                <a16:creationId xmlns:a16="http://schemas.microsoft.com/office/drawing/2014/main" id="{014655B2-64B9-439B-8E99-6F9060D7B506}"/>
               </a:ext>
             </a:extLst>
           </p:cNvPr>
@@ -8310,7 +8315,7 @@
           <p:cNvPr id="10" name="">
             <a:extLst xmlns:a="http://schemas.openxmlformats.org/drawingml/2006/main">
               <a:ext uri="{FF2B5EF4-FFF2-40B4-BE49-F238E27FC236}">
-                <a16:creationId xmlns:a16="http://schemas.microsoft.com/office/drawing/2014/main" id="{8B59A48F-7198-49E7-A916-5F37AEF45DB4}"/>
+                <a16:creationId xmlns:a16="http://schemas.microsoft.com/office/drawing/2014/main" id="{8F9F7149-AFDB-4E34-B843-60D25701D8E4}"/>
               </a:ext>
             </a:extLst>
           </p:cNvPr>
@@ -8367,7 +8372,7 @@
           <p:cNvPr id="11" name="">
             <a:extLst xmlns:a="http://schemas.openxmlformats.org/drawingml/2006/main">
               <a:ext uri="{FF2B5EF4-FFF2-40B4-BE49-F238E27FC236}">
-                <a16:creationId xmlns:a16="http://schemas.microsoft.com/office/drawing/2014/main" id="{7FB7BD7C-DD68-4A51-8D69-41BB251F5E32}"/>
+                <a16:creationId xmlns:a16="http://schemas.microsoft.com/office/drawing/2014/main" id="{2FF716B9-C614-404F-8883-12CA0BB50807}"/>
               </a:ext>
             </a:extLst>
           </p:cNvPr>
@@ -8424,7 +8429,7 @@
           <p:cNvPr id="12" name="">
             <a:extLst xmlns:a="http://schemas.openxmlformats.org/drawingml/2006/main">
               <a:ext uri="{FF2B5EF4-FFF2-40B4-BE49-F238E27FC236}">
-                <a16:creationId xmlns:a16="http://schemas.microsoft.com/office/drawing/2014/main" id="{98BA509B-CBED-4796-B7E9-991F74A46E70}"/>
+                <a16:creationId xmlns:a16="http://schemas.microsoft.com/office/drawing/2014/main" id="{24C0E22E-916C-4AB4-884E-58F7391ADDFB}"/>
               </a:ext>
             </a:extLst>
           </p:cNvPr>
@@ -8481,7 +8486,7 @@
           <p:cNvPr id="13" name="">
             <a:extLst xmlns:a="http://schemas.openxmlformats.org/drawingml/2006/main">
               <a:ext uri="{FF2B5EF4-FFF2-40B4-BE49-F238E27FC236}">
-                <a16:creationId xmlns:a16="http://schemas.microsoft.com/office/drawing/2014/main" id="{7C00D4CB-CE5B-4E67-A90E-BBC6F3D01E8C}"/>
+                <a16:creationId xmlns:a16="http://schemas.microsoft.com/office/drawing/2014/main" id="{0D6CB340-A973-4B4F-821D-649B21A82364}"/>
               </a:ext>
             </a:extLst>
           </p:cNvPr>
@@ -8513,7 +8518,7 @@
           <p:cNvPr id="14" name="">
             <a:extLst xmlns:a="http://schemas.openxmlformats.org/drawingml/2006/main">
               <a:ext uri="{FF2B5EF4-FFF2-40B4-BE49-F238E27FC236}">
-                <a16:creationId xmlns:a16="http://schemas.microsoft.com/office/drawing/2014/main" id="{B0F92B2D-631B-46DE-9900-5EE50D73B4B1}"/>
+                <a16:creationId xmlns:a16="http://schemas.microsoft.com/office/drawing/2014/main" id="{6FE5C2E1-3621-4B2A-8EF1-E1EDD3192044}"/>
               </a:ext>
             </a:extLst>
           </p:cNvPr>
@@ -8570,7 +8575,7 @@
           <p:cNvPr id="15" name="">
             <a:extLst xmlns:a="http://schemas.openxmlformats.org/drawingml/2006/main">
               <a:ext uri="{FF2B5EF4-FFF2-40B4-BE49-F238E27FC236}">
-                <a16:creationId xmlns:a16="http://schemas.microsoft.com/office/drawing/2014/main" id="{274AA3C6-A928-4437-BE46-F89B40CD31EC}"/>
+                <a16:creationId xmlns:a16="http://schemas.microsoft.com/office/drawing/2014/main" id="{63C3E6E9-E01D-4DC1-8D08-2401E4D86679}"/>
               </a:ext>
             </a:extLst>
           </p:cNvPr>
@@ -8627,7 +8632,7 @@
           <p:cNvPr id="16" name="">
             <a:extLst xmlns:a="http://schemas.openxmlformats.org/drawingml/2006/main">
               <a:ext uri="{FF2B5EF4-FFF2-40B4-BE49-F238E27FC236}">
-                <a16:creationId xmlns:a16="http://schemas.microsoft.com/office/drawing/2014/main" id="{BF01FFD0-395F-469B-9042-A78FEA5E3EC4}"/>
+                <a16:creationId xmlns:a16="http://schemas.microsoft.com/office/drawing/2014/main" id="{627F6462-09DD-442E-B397-0BA42D8B6360}"/>
               </a:ext>
             </a:extLst>
           </p:cNvPr>
@@ -8684,7 +8689,7 @@
           <p:cNvPr id="17" name="">
             <a:extLst xmlns:a="http://schemas.openxmlformats.org/drawingml/2006/main">
               <a:ext uri="{FF2B5EF4-FFF2-40B4-BE49-F238E27FC236}">
-                <a16:creationId xmlns:a16="http://schemas.microsoft.com/office/drawing/2014/main" id="{DA90772D-0292-40B3-B1F7-12B7C66BBAEB}"/>
+                <a16:creationId xmlns:a16="http://schemas.microsoft.com/office/drawing/2014/main" id="{3BD2F7E9-7DEC-4050-BB8C-82E26A6F6985}"/>
               </a:ext>
             </a:extLst>
           </p:cNvPr>
@@ -8739,7 +8744,7 @@
     </p:spTree>
     <p:extLst>
       <p:ext uri="{BB962C8B-B14F-4D97-AF65-F5344CB8AC3E}">
-        <p14:creationId xmlns:p14="http://schemas.microsoft.com/office/powerpoint/2010/main" val="700795771"/>
+        <p14:creationId xmlns:p14="http://schemas.microsoft.com/office/powerpoint/2010/main" val="1064208912"/>
       </p:ext>
     </p:extLst>
   </p:cSld>
@@ -8770,7 +8775,7 @@
           <p:cNvPr id="25" name="">
             <a:extLst xmlns:a="http://schemas.openxmlformats.org/drawingml/2006/main">
               <a:ext uri="{FF2B5EF4-FFF2-40B4-BE49-F238E27FC236}">
-                <a16:creationId xmlns:a16="http://schemas.microsoft.com/office/drawing/2014/main" id="{20AF15E6-F0DA-4216-ADB0-41BECD51BF0E}"/>
+                <a16:creationId xmlns:a16="http://schemas.microsoft.com/office/drawing/2014/main" id="{8198E621-3A2E-4B6E-A187-3B0DC13C05BC}"/>
               </a:ext>
             </a:extLst>
           </p:cNvPr>
@@ -8827,7 +8832,7 @@
           <p:cNvPr id="2" name="">
             <a:extLst xmlns:a="http://schemas.openxmlformats.org/drawingml/2006/main">
               <a:ext uri="{FF2B5EF4-FFF2-40B4-BE49-F238E27FC236}">
-                <a16:creationId xmlns:a16="http://schemas.microsoft.com/office/drawing/2014/main" id="{E43AB6A7-77D0-435A-B8D1-C5EEEC98C7A2}"/>
+                <a16:creationId xmlns:a16="http://schemas.microsoft.com/office/drawing/2014/main" id="{AAC00118-2530-48B8-83E2-F4593997822F}"/>
               </a:ext>
             </a:extLst>
           </p:cNvPr>
@@ -8884,7 +8889,7 @@
           <p:cNvPr id="3" name="">
             <a:extLst xmlns:a="http://schemas.openxmlformats.org/drawingml/2006/main">
               <a:ext uri="{FF2B5EF4-FFF2-40B4-BE49-F238E27FC236}">
-                <a16:creationId xmlns:a16="http://schemas.microsoft.com/office/drawing/2014/main" id="{F5E1403D-0B34-4D85-9AB1-F628D92979D4}"/>
+                <a16:creationId xmlns:a16="http://schemas.microsoft.com/office/drawing/2014/main" id="{8B52BDAD-B3D1-472E-8888-5460831B7C8F}"/>
               </a:ext>
             </a:extLst>
           </p:cNvPr>
@@ -8914,7 +8919,7 @@
           <p:cNvPr id="4" name="">
             <a:extLst xmlns:a="http://schemas.openxmlformats.org/drawingml/2006/main">
               <a:ext uri="{FF2B5EF4-FFF2-40B4-BE49-F238E27FC236}">
-                <a16:creationId xmlns:a16="http://schemas.microsoft.com/office/drawing/2014/main" id="{2DEA2BC9-545F-4D9A-AC5C-AA1CDDEBAB08}"/>
+                <a16:creationId xmlns:a16="http://schemas.microsoft.com/office/drawing/2014/main" id="{A5E90BAB-BCD8-4B21-9818-B4896934B21E}"/>
               </a:ext>
             </a:extLst>
           </p:cNvPr>
@@ -8971,7 +8976,7 @@
           <p:cNvPr id="5" name="">
             <a:extLst xmlns:a="http://schemas.openxmlformats.org/drawingml/2006/main">
               <a:ext uri="{FF2B5EF4-FFF2-40B4-BE49-F238E27FC236}">
-                <a16:creationId xmlns:a16="http://schemas.microsoft.com/office/drawing/2014/main" id="{3DA15FE0-6266-4B98-8F20-0C5D1F209EE5}"/>
+                <a16:creationId xmlns:a16="http://schemas.microsoft.com/office/drawing/2014/main" id="{1831AE55-4158-4B96-8B63-EF12913827B3}"/>
               </a:ext>
             </a:extLst>
           </p:cNvPr>
@@ -9003,7 +9008,7 @@
           <p:cNvPr id="6" name="">
             <a:extLst xmlns:a="http://schemas.openxmlformats.org/drawingml/2006/main">
               <a:ext uri="{FF2B5EF4-FFF2-40B4-BE49-F238E27FC236}">
-                <a16:creationId xmlns:a16="http://schemas.microsoft.com/office/drawing/2014/main" id="{0A26E89E-E8CF-4B2C-875D-EBD3B109C355}"/>
+                <a16:creationId xmlns:a16="http://schemas.microsoft.com/office/drawing/2014/main" id="{64004AB6-48DC-4FD1-B606-9B6309CFF9C9}"/>
               </a:ext>
             </a:extLst>
           </p:cNvPr>
@@ -9060,7 +9065,7 @@
           <p:cNvPr id="7" name="">
             <a:extLst xmlns:a="http://schemas.openxmlformats.org/drawingml/2006/main">
               <a:ext uri="{FF2B5EF4-FFF2-40B4-BE49-F238E27FC236}">
-                <a16:creationId xmlns:a16="http://schemas.microsoft.com/office/drawing/2014/main" id="{3F5B45F7-FE6A-4FF6-A5D3-A075E2722E44}"/>
+                <a16:creationId xmlns:a16="http://schemas.microsoft.com/office/drawing/2014/main" id="{B6FBC5E5-B940-4C4B-905E-857528ACAC3A}"/>
               </a:ext>
             </a:extLst>
           </p:cNvPr>
@@ -9117,7 +9122,7 @@
           <p:cNvPr id="8" name="">
             <a:extLst xmlns:a="http://schemas.openxmlformats.org/drawingml/2006/main">
               <a:ext uri="{FF2B5EF4-FFF2-40B4-BE49-F238E27FC236}">
-                <a16:creationId xmlns:a16="http://schemas.microsoft.com/office/drawing/2014/main" id="{29F83C0F-1A17-4881-9D28-833A7E648336}"/>
+                <a16:creationId xmlns:a16="http://schemas.microsoft.com/office/drawing/2014/main" id="{12E261D5-EA32-45AA-948B-121BD02EEDD6}"/>
               </a:ext>
             </a:extLst>
           </p:cNvPr>
@@ -9149,7 +9154,7 @@
           <p:cNvPr id="9" name="">
             <a:extLst xmlns:a="http://schemas.openxmlformats.org/drawingml/2006/main">
               <a:ext uri="{FF2B5EF4-FFF2-40B4-BE49-F238E27FC236}">
-                <a16:creationId xmlns:a16="http://schemas.microsoft.com/office/drawing/2014/main" id="{39126314-1D86-492E-9E7A-211F707313BC}"/>
+                <a16:creationId xmlns:a16="http://schemas.microsoft.com/office/drawing/2014/main" id="{992E5FAF-93AC-4D20-A048-57AD060DF4BD}"/>
               </a:ext>
             </a:extLst>
           </p:cNvPr>
@@ -9206,7 +9211,7 @@
           <p:cNvPr id="10" name="">
             <a:extLst xmlns:a="http://schemas.openxmlformats.org/drawingml/2006/main">
               <a:ext uri="{FF2B5EF4-FFF2-40B4-BE49-F238E27FC236}">
-                <a16:creationId xmlns:a16="http://schemas.microsoft.com/office/drawing/2014/main" id="{F2BFC49B-C795-497A-8FFC-557F596FB815}"/>
+                <a16:creationId xmlns:a16="http://schemas.microsoft.com/office/drawing/2014/main" id="{862B9D3D-EBB0-4733-AD2D-7A6D1E403897}"/>
               </a:ext>
             </a:extLst>
           </p:cNvPr>
@@ -9263,7 +9268,7 @@
           <p:cNvPr id="11" name="">
             <a:extLst xmlns:a="http://schemas.openxmlformats.org/drawingml/2006/main">
               <a:ext uri="{FF2B5EF4-FFF2-40B4-BE49-F238E27FC236}">
-                <a16:creationId xmlns:a16="http://schemas.microsoft.com/office/drawing/2014/main" id="{2A9C57D6-0A05-45F8-B514-C5DC6153C959}"/>
+                <a16:creationId xmlns:a16="http://schemas.microsoft.com/office/drawing/2014/main" id="{7A8AD98E-D803-4597-A6AD-9E4EE04C828A}"/>
               </a:ext>
             </a:extLst>
           </p:cNvPr>
@@ -9295,7 +9300,7 @@
           <p:cNvPr id="12" name="">
             <a:extLst xmlns:a="http://schemas.openxmlformats.org/drawingml/2006/main">
               <a:ext uri="{FF2B5EF4-FFF2-40B4-BE49-F238E27FC236}">
-                <a16:creationId xmlns:a16="http://schemas.microsoft.com/office/drawing/2014/main" id="{A55134D7-43AB-413E-BB4A-7254126F85A3}"/>
+                <a16:creationId xmlns:a16="http://schemas.microsoft.com/office/drawing/2014/main" id="{304D7A80-C72D-4996-BF82-3829F5B28272}"/>
               </a:ext>
             </a:extLst>
           </p:cNvPr>
@@ -9352,7 +9357,7 @@
           <p:cNvPr id="13" name="">
             <a:extLst xmlns:a="http://schemas.openxmlformats.org/drawingml/2006/main">
               <a:ext uri="{FF2B5EF4-FFF2-40B4-BE49-F238E27FC236}">
-                <a16:creationId xmlns:a16="http://schemas.microsoft.com/office/drawing/2014/main" id="{FA0E10BA-C387-4FEA-AF1A-170948CD3F32}"/>
+                <a16:creationId xmlns:a16="http://schemas.microsoft.com/office/drawing/2014/main" id="{7C7906FC-D2FB-4DA1-B13E-8FA2A912ECAF}"/>
               </a:ext>
             </a:extLst>
           </p:cNvPr>
@@ -9409,7 +9414,7 @@
           <p:cNvPr id="14" name="">
             <a:extLst xmlns:a="http://schemas.openxmlformats.org/drawingml/2006/main">
               <a:ext uri="{FF2B5EF4-FFF2-40B4-BE49-F238E27FC236}">
-                <a16:creationId xmlns:a16="http://schemas.microsoft.com/office/drawing/2014/main" id="{7188F34B-FA67-4B61-BA2C-B6EE4AC11258}"/>
+                <a16:creationId xmlns:a16="http://schemas.microsoft.com/office/drawing/2014/main" id="{43662B2C-7BA4-4AD2-BE4A-77A9421DB4E9}"/>
               </a:ext>
             </a:extLst>
           </p:cNvPr>
@@ -9441,7 +9446,7 @@
           <p:cNvPr id="15" name="">
             <a:extLst xmlns:a="http://schemas.openxmlformats.org/drawingml/2006/main">
               <a:ext uri="{FF2B5EF4-FFF2-40B4-BE49-F238E27FC236}">
-                <a16:creationId xmlns:a16="http://schemas.microsoft.com/office/drawing/2014/main" id="{4D7763E2-C59F-45DF-8EB4-FBDCDF094D7D}"/>
+                <a16:creationId xmlns:a16="http://schemas.microsoft.com/office/drawing/2014/main" id="{B9258A27-A104-4A0B-B805-52CD28C82F90}"/>
               </a:ext>
             </a:extLst>
           </p:cNvPr>
@@ -9498,7 +9503,7 @@
           <p:cNvPr id="16" name="">
             <a:extLst xmlns:a="http://schemas.openxmlformats.org/drawingml/2006/main">
               <a:ext uri="{FF2B5EF4-FFF2-40B4-BE49-F238E27FC236}">
-                <a16:creationId xmlns:a16="http://schemas.microsoft.com/office/drawing/2014/main" id="{7AFA1A0B-1B22-442D-B2CF-DB027F1A4514}"/>
+                <a16:creationId xmlns:a16="http://schemas.microsoft.com/office/drawing/2014/main" id="{EB2FF93B-217F-41AA-A2F7-C695B65D3390}"/>
               </a:ext>
             </a:extLst>
           </p:cNvPr>
@@ -9555,7 +9560,7 @@
           <p:cNvPr id="17" name="">
             <a:extLst xmlns:a="http://schemas.openxmlformats.org/drawingml/2006/main">
               <a:ext uri="{FF2B5EF4-FFF2-40B4-BE49-F238E27FC236}">
-                <a16:creationId xmlns:a16="http://schemas.microsoft.com/office/drawing/2014/main" id="{3BD7CAD7-167E-4166-BCD8-A5E4553EFFA3}"/>
+                <a16:creationId xmlns:a16="http://schemas.microsoft.com/office/drawing/2014/main" id="{950BF0A9-AC33-4D74-AFC2-DD385F3552B1}"/>
               </a:ext>
             </a:extLst>
           </p:cNvPr>
@@ -9587,7 +9592,7 @@
           <p:cNvPr id="18" name="">
             <a:extLst xmlns:a="http://schemas.openxmlformats.org/drawingml/2006/main">
               <a:ext uri="{FF2B5EF4-FFF2-40B4-BE49-F238E27FC236}">
-                <a16:creationId xmlns:a16="http://schemas.microsoft.com/office/drawing/2014/main" id="{89355181-A5F5-4F02-BF77-002550629F3B}"/>
+                <a16:creationId xmlns:a16="http://schemas.microsoft.com/office/drawing/2014/main" id="{561A68E5-89CF-48FF-83EC-42ADDDAA5226}"/>
               </a:ext>
             </a:extLst>
           </p:cNvPr>
@@ -9644,7 +9649,7 @@
           <p:cNvPr id="19" name="">
             <a:extLst xmlns:a="http://schemas.openxmlformats.org/drawingml/2006/main">
               <a:ext uri="{FF2B5EF4-FFF2-40B4-BE49-F238E27FC236}">
-                <a16:creationId xmlns:a16="http://schemas.microsoft.com/office/drawing/2014/main" id="{AEA926B1-1B8D-4C23-9DE9-FE8EE39BEA59}"/>
+                <a16:creationId xmlns:a16="http://schemas.microsoft.com/office/drawing/2014/main" id="{E8F29D4D-752D-468F-BB41-4062213AEFE0}"/>
               </a:ext>
             </a:extLst>
           </p:cNvPr>
@@ -9701,7 +9706,7 @@
           <p:cNvPr id="20" name="">
             <a:extLst xmlns:a="http://schemas.openxmlformats.org/drawingml/2006/main">
               <a:ext uri="{FF2B5EF4-FFF2-40B4-BE49-F238E27FC236}">
-                <a16:creationId xmlns:a16="http://schemas.microsoft.com/office/drawing/2014/main" id="{653B2C41-D646-4F9A-98A9-7890996458FC}"/>
+                <a16:creationId xmlns:a16="http://schemas.microsoft.com/office/drawing/2014/main" id="{397F4566-5B49-4EB8-8E8D-506F0B6829A7}"/>
               </a:ext>
             </a:extLst>
           </p:cNvPr>
@@ -9733,7 +9738,7 @@
           <p:cNvPr id="21" name="">
             <a:extLst xmlns:a="http://schemas.openxmlformats.org/drawingml/2006/main">
               <a:ext uri="{FF2B5EF4-FFF2-40B4-BE49-F238E27FC236}">
-                <a16:creationId xmlns:a16="http://schemas.microsoft.com/office/drawing/2014/main" id="{55C70530-555C-4B5F-ABD6-FF40D115319F}"/>
+                <a16:creationId xmlns:a16="http://schemas.microsoft.com/office/drawing/2014/main" id="{205A0E42-18EF-404B-8CB7-31E251CC46DE}"/>
               </a:ext>
             </a:extLst>
           </p:cNvPr>
@@ -9790,7 +9795,7 @@
           <p:cNvPr id="22" name="">
             <a:extLst xmlns:a="http://schemas.openxmlformats.org/drawingml/2006/main">
               <a:ext uri="{FF2B5EF4-FFF2-40B4-BE49-F238E27FC236}">
-                <a16:creationId xmlns:a16="http://schemas.microsoft.com/office/drawing/2014/main" id="{11D080E3-F568-4C9C-A5CD-4B1CC4F19BBC}"/>
+                <a16:creationId xmlns:a16="http://schemas.microsoft.com/office/drawing/2014/main" id="{1FC208C7-9B13-4EA1-9193-88819FFDD5FC}"/>
               </a:ext>
             </a:extLst>
           </p:cNvPr>
@@ -9847,7 +9852,7 @@
           <p:cNvPr id="23" name="">
             <a:extLst xmlns:a="http://schemas.openxmlformats.org/drawingml/2006/main">
               <a:ext uri="{FF2B5EF4-FFF2-40B4-BE49-F238E27FC236}">
-                <a16:creationId xmlns:a16="http://schemas.microsoft.com/office/drawing/2014/main" id="{DA1BC723-7F94-4821-949C-8678784301BD}"/>
+                <a16:creationId xmlns:a16="http://schemas.microsoft.com/office/drawing/2014/main" id="{823B838B-7595-4AC1-B962-F12A2AEB409E}"/>
               </a:ext>
             </a:extLst>
           </p:cNvPr>
@@ -9904,7 +9909,7 @@
           <p:cNvPr id="24" name="">
             <a:extLst xmlns:a="http://schemas.openxmlformats.org/drawingml/2006/main">
               <a:ext uri="{FF2B5EF4-FFF2-40B4-BE49-F238E27FC236}">
-                <a16:creationId xmlns:a16="http://schemas.microsoft.com/office/drawing/2014/main" id="{93788AAB-875E-4A7E-9379-9AC0BD332173}"/>
+                <a16:creationId xmlns:a16="http://schemas.microsoft.com/office/drawing/2014/main" id="{759D30DE-DDA3-4AB8-8C8D-55D26D0B2936}"/>
               </a:ext>
             </a:extLst>
           </p:cNvPr>
@@ -9959,7 +9964,7 @@
     </p:spTree>
     <p:extLst>
       <p:ext uri="{BB962C8B-B14F-4D97-AF65-F5344CB8AC3E}">
-        <p14:creationId xmlns:p14="http://schemas.microsoft.com/office/powerpoint/2010/main" val="377812396"/>
+        <p14:creationId xmlns:p14="http://schemas.microsoft.com/office/powerpoint/2010/main" val="808838924"/>
       </p:ext>
     </p:extLst>
   </p:cSld>
@@ -9990,7 +9995,7 @@
           <p:cNvPr id="38" name="">
             <a:extLst xmlns:a="http://schemas.openxmlformats.org/drawingml/2006/main">
               <a:ext uri="{FF2B5EF4-FFF2-40B4-BE49-F238E27FC236}">
-                <a16:creationId xmlns:a16="http://schemas.microsoft.com/office/drawing/2014/main" id="{618B9DE5-C7B6-4D25-9050-5C4750B50B8F}"/>
+                <a16:creationId xmlns:a16="http://schemas.microsoft.com/office/drawing/2014/main" id="{98984FE9-646C-4372-A605-71ECBF091919}"/>
               </a:ext>
             </a:extLst>
           </p:cNvPr>
@@ -10047,7 +10052,7 @@
           <p:cNvPr id="2" name="">
             <a:extLst xmlns:a="http://schemas.openxmlformats.org/drawingml/2006/main">
               <a:ext uri="{FF2B5EF4-FFF2-40B4-BE49-F238E27FC236}">
-                <a16:creationId xmlns:a16="http://schemas.microsoft.com/office/drawing/2014/main" id="{14BCCF3B-D1BB-4ABB-9E55-3F768C6889F7}"/>
+                <a16:creationId xmlns:a16="http://schemas.microsoft.com/office/drawing/2014/main" id="{E86E0723-BB33-4659-8939-66A430DF9945}"/>
               </a:ext>
             </a:extLst>
           </p:cNvPr>
@@ -10104,7 +10109,7 @@
           <p:cNvPr id="3" name="">
             <a:extLst xmlns:a="http://schemas.openxmlformats.org/drawingml/2006/main">
               <a:ext uri="{FF2B5EF4-FFF2-40B4-BE49-F238E27FC236}">
-                <a16:creationId xmlns:a16="http://schemas.microsoft.com/office/drawing/2014/main" id="{F479E490-4338-4B35-8B24-AF3BDCAAE1D8}"/>
+                <a16:creationId xmlns:a16="http://schemas.microsoft.com/office/drawing/2014/main" id="{03B542B7-E222-4F81-991C-D34B5A5EA42A}"/>
               </a:ext>
             </a:extLst>
           </p:cNvPr>
@@ -10134,7 +10139,7 @@
           <p:cNvPr id="4" name="">
             <a:extLst xmlns:a="http://schemas.openxmlformats.org/drawingml/2006/main">
               <a:ext uri="{FF2B5EF4-FFF2-40B4-BE49-F238E27FC236}">
-                <a16:creationId xmlns:a16="http://schemas.microsoft.com/office/drawing/2014/main" id="{D64CC4EB-E679-4A3C-838D-0EEFD20F74A5}"/>
+                <a16:creationId xmlns:a16="http://schemas.microsoft.com/office/drawing/2014/main" id="{CEAF94B7-E325-4A4E-8F79-B5A5D9E292D7}"/>
               </a:ext>
             </a:extLst>
           </p:cNvPr>
@@ -10191,7 +10196,7 @@
           <p:cNvPr id="5" name="">
             <a:extLst xmlns:a="http://schemas.openxmlformats.org/drawingml/2006/main">
               <a:ext uri="{FF2B5EF4-FFF2-40B4-BE49-F238E27FC236}">
-                <a16:creationId xmlns:a16="http://schemas.microsoft.com/office/drawing/2014/main" id="{11AD6E43-1BD0-4E5C-A9E0-6C202F576AC3}"/>
+                <a16:creationId xmlns:a16="http://schemas.microsoft.com/office/drawing/2014/main" id="{74F5BA92-F432-4B29-B4F0-9CBAD488D047}"/>
               </a:ext>
             </a:extLst>
           </p:cNvPr>
@@ -10225,7 +10230,7 @@
           <p:cNvPr id="6" name="">
             <a:extLst xmlns:a="http://schemas.openxmlformats.org/drawingml/2006/main">
               <a:ext uri="{FF2B5EF4-FFF2-40B4-BE49-F238E27FC236}">
-                <a16:creationId xmlns:a16="http://schemas.microsoft.com/office/drawing/2014/main" id="{128EF61D-4609-4A4F-A352-956AD3F3E8FB}"/>
+                <a16:creationId xmlns:a16="http://schemas.microsoft.com/office/drawing/2014/main" id="{244E1BBC-F83A-4422-9D97-B668F206C7AC}"/>
               </a:ext>
             </a:extLst>
           </p:cNvPr>
@@ -10257,7 +10262,7 @@
           <p:cNvPr id="7" name="">
             <a:extLst xmlns:a="http://schemas.openxmlformats.org/drawingml/2006/main">
               <a:ext uri="{FF2B5EF4-FFF2-40B4-BE49-F238E27FC236}">
-                <a16:creationId xmlns:a16="http://schemas.microsoft.com/office/drawing/2014/main" id="{94E9A72A-0921-42D6-984C-8324DF65FA4D}"/>
+                <a16:creationId xmlns:a16="http://schemas.microsoft.com/office/drawing/2014/main" id="{0BF1EA0A-3CFD-4D6B-AB5C-0F40A8CD0597}"/>
               </a:ext>
             </a:extLst>
           </p:cNvPr>
@@ -10314,7 +10319,7 @@
           <p:cNvPr id="8" name="">
             <a:extLst xmlns:a="http://schemas.openxmlformats.org/drawingml/2006/main">
               <a:ext uri="{FF2B5EF4-FFF2-40B4-BE49-F238E27FC236}">
-                <a16:creationId xmlns:a16="http://schemas.microsoft.com/office/drawing/2014/main" id="{665AE99C-158F-47B4-A818-E41546E851F3}"/>
+                <a16:creationId xmlns:a16="http://schemas.microsoft.com/office/drawing/2014/main" id="{C68A1521-7BCC-49A9-976E-0FFF65902536}"/>
               </a:ext>
             </a:extLst>
           </p:cNvPr>
@@ -10394,7 +10399,7 @@
           <p:cNvPr id="9" name="">
             <a:extLst xmlns:a="http://schemas.openxmlformats.org/drawingml/2006/main">
               <a:ext uri="{FF2B5EF4-FFF2-40B4-BE49-F238E27FC236}">
-                <a16:creationId xmlns:a16="http://schemas.microsoft.com/office/drawing/2014/main" id="{96EAE15C-A4C1-4BA3-B2C3-E756D83528C5}"/>
+                <a16:creationId xmlns:a16="http://schemas.microsoft.com/office/drawing/2014/main" id="{37CD4B53-B0F9-45F7-A15A-739D7A15053C}"/>
               </a:ext>
             </a:extLst>
           </p:cNvPr>
@@ -10451,7 +10456,7 @@
           <p:cNvPr id="10" name="">
             <a:extLst xmlns:a="http://schemas.openxmlformats.org/drawingml/2006/main">
               <a:ext uri="{FF2B5EF4-FFF2-40B4-BE49-F238E27FC236}">
-                <a16:creationId xmlns:a16="http://schemas.microsoft.com/office/drawing/2014/main" id="{49997C7A-6996-4971-A76B-0D6A752AB6FE}"/>
+                <a16:creationId xmlns:a16="http://schemas.microsoft.com/office/drawing/2014/main" id="{E1FBAD5B-237C-4BEB-BABD-ED4356843B37}"/>
               </a:ext>
             </a:extLst>
           </p:cNvPr>
@@ -10508,7 +10513,7 @@
           <p:cNvPr id="11" name="">
             <a:extLst xmlns:a="http://schemas.openxmlformats.org/drawingml/2006/main">
               <a:ext uri="{FF2B5EF4-FFF2-40B4-BE49-F238E27FC236}">
-                <a16:creationId xmlns:a16="http://schemas.microsoft.com/office/drawing/2014/main" id="{7DB018C3-FF03-416B-8973-C7BA38A4FED6}"/>
+                <a16:creationId xmlns:a16="http://schemas.microsoft.com/office/drawing/2014/main" id="{990528D6-ACBD-4431-9039-840C4503DAAE}"/>
               </a:ext>
             </a:extLst>
           </p:cNvPr>
@@ -10542,7 +10547,7 @@
           <p:cNvPr id="12" name="">
             <a:extLst xmlns:a="http://schemas.openxmlformats.org/drawingml/2006/main">
               <a:ext uri="{FF2B5EF4-FFF2-40B4-BE49-F238E27FC236}">
-                <a16:creationId xmlns:a16="http://schemas.microsoft.com/office/drawing/2014/main" id="{DA45F35A-84E9-4DB5-B429-3976DA16C3E2}"/>
+                <a16:creationId xmlns:a16="http://schemas.microsoft.com/office/drawing/2014/main" id="{DD129297-6225-40D1-8927-1AFB31E6435E}"/>
               </a:ext>
             </a:extLst>
           </p:cNvPr>
@@ -10574,7 +10579,7 @@
           <p:cNvPr id="13" name="">
             <a:extLst xmlns:a="http://schemas.openxmlformats.org/drawingml/2006/main">
               <a:ext uri="{FF2B5EF4-FFF2-40B4-BE49-F238E27FC236}">
-                <a16:creationId xmlns:a16="http://schemas.microsoft.com/office/drawing/2014/main" id="{E0A98EAC-490A-4962-9C9E-EABE67AF2979}"/>
+                <a16:creationId xmlns:a16="http://schemas.microsoft.com/office/drawing/2014/main" id="{8C5AA8AE-4A31-41DE-A288-A21E8AF450F5}"/>
               </a:ext>
             </a:extLst>
           </p:cNvPr>
@@ -10631,7 +10636,7 @@
           <p:cNvPr id="14" name="">
             <a:extLst xmlns:a="http://schemas.openxmlformats.org/drawingml/2006/main">
               <a:ext uri="{FF2B5EF4-FFF2-40B4-BE49-F238E27FC236}">
-                <a16:creationId xmlns:a16="http://schemas.microsoft.com/office/drawing/2014/main" id="{F0BED293-6FCA-46D2-976A-8F84346833BA}"/>
+                <a16:creationId xmlns:a16="http://schemas.microsoft.com/office/drawing/2014/main" id="{4F4DF961-A5AF-4395-95ED-10FE4E76A080}"/>
               </a:ext>
             </a:extLst>
           </p:cNvPr>
@@ -10711,7 +10716,7 @@
           <p:cNvPr id="15" name="">
             <a:extLst xmlns:a="http://schemas.openxmlformats.org/drawingml/2006/main">
               <a:ext uri="{FF2B5EF4-FFF2-40B4-BE49-F238E27FC236}">
-                <a16:creationId xmlns:a16="http://schemas.microsoft.com/office/drawing/2014/main" id="{D0C9281A-05FE-412D-96BA-D3C36FA5880F}"/>
+                <a16:creationId xmlns:a16="http://schemas.microsoft.com/office/drawing/2014/main" id="{3D990276-1849-4B98-A3B6-5E4FFB208C5B}"/>
               </a:ext>
             </a:extLst>
           </p:cNvPr>
@@ -10768,7 +10773,7 @@
           <p:cNvPr id="16" name="">
             <a:extLst xmlns:a="http://schemas.openxmlformats.org/drawingml/2006/main">
               <a:ext uri="{FF2B5EF4-FFF2-40B4-BE49-F238E27FC236}">
-                <a16:creationId xmlns:a16="http://schemas.microsoft.com/office/drawing/2014/main" id="{EE285266-F2B1-4B22-A800-0DD204031A1D}"/>
+                <a16:creationId xmlns:a16="http://schemas.microsoft.com/office/drawing/2014/main" id="{59D09EA5-0D34-4C79-8336-65D0557572F4}"/>
               </a:ext>
             </a:extLst>
           </p:cNvPr>
@@ -10825,7 +10830,7 @@
           <p:cNvPr id="17" name="">
             <a:extLst xmlns:a="http://schemas.openxmlformats.org/drawingml/2006/main">
               <a:ext uri="{FF2B5EF4-FFF2-40B4-BE49-F238E27FC236}">
-                <a16:creationId xmlns:a16="http://schemas.microsoft.com/office/drawing/2014/main" id="{92D5ABDB-514F-47C5-AEB5-24C137DAE782}"/>
+                <a16:creationId xmlns:a16="http://schemas.microsoft.com/office/drawing/2014/main" id="{9161E5BD-E3C8-4D8B-B028-44053830C02F}"/>
               </a:ext>
             </a:extLst>
           </p:cNvPr>
@@ -10859,7 +10864,7 @@
           <p:cNvPr id="18" name="">
             <a:extLst xmlns:a="http://schemas.openxmlformats.org/drawingml/2006/main">
               <a:ext uri="{FF2B5EF4-FFF2-40B4-BE49-F238E27FC236}">
-                <a16:creationId xmlns:a16="http://schemas.microsoft.com/office/drawing/2014/main" id="{9B1BD53A-6BB7-47BD-BFC9-B3CA6C8D1C3A}"/>
+                <a16:creationId xmlns:a16="http://schemas.microsoft.com/office/drawing/2014/main" id="{0AAC6D2D-3B1C-4849-9DD2-A5EC80CCA2D5}"/>
               </a:ext>
             </a:extLst>
           </p:cNvPr>
@@ -10891,7 +10896,7 @@
           <p:cNvPr id="19" name="">
             <a:extLst xmlns:a="http://schemas.openxmlformats.org/drawingml/2006/main">
               <a:ext uri="{FF2B5EF4-FFF2-40B4-BE49-F238E27FC236}">
-                <a16:creationId xmlns:a16="http://schemas.microsoft.com/office/drawing/2014/main" id="{D239E95D-2D99-4088-A9B3-9CB7EFA94D3A}"/>
+                <a16:creationId xmlns:a16="http://schemas.microsoft.com/office/drawing/2014/main" id="{0FB3654A-7742-4DE2-89C4-51D332C600D9}"/>
               </a:ext>
             </a:extLst>
           </p:cNvPr>
@@ -10948,7 +10953,7 @@
           <p:cNvPr id="20" name="">
             <a:extLst xmlns:a="http://schemas.openxmlformats.org/drawingml/2006/main">
               <a:ext uri="{FF2B5EF4-FFF2-40B4-BE49-F238E27FC236}">
-                <a16:creationId xmlns:a16="http://schemas.microsoft.com/office/drawing/2014/main" id="{CDE1C7E3-B2E8-4025-B797-848974A5C95C}"/>
+                <a16:creationId xmlns:a16="http://schemas.microsoft.com/office/drawing/2014/main" id="{0F9434F7-6513-497C-B40D-759A34EFB3A4}"/>
               </a:ext>
             </a:extLst>
           </p:cNvPr>
@@ -11028,7 +11033,7 @@
           <p:cNvPr id="21" name="">
             <a:extLst xmlns:a="http://schemas.openxmlformats.org/drawingml/2006/main">
               <a:ext uri="{FF2B5EF4-FFF2-40B4-BE49-F238E27FC236}">
-                <a16:creationId xmlns:a16="http://schemas.microsoft.com/office/drawing/2014/main" id="{F923A4BF-2AAD-468B-9113-A8886CCBFDEB}"/>
+                <a16:creationId xmlns:a16="http://schemas.microsoft.com/office/drawing/2014/main" id="{DB30BFE0-8936-41C3-AA5C-FE1E6F661FEF}"/>
               </a:ext>
             </a:extLst>
           </p:cNvPr>
@@ -11085,7 +11090,7 @@
           <p:cNvPr id="22" name="">
             <a:extLst xmlns:a="http://schemas.openxmlformats.org/drawingml/2006/main">
               <a:ext uri="{FF2B5EF4-FFF2-40B4-BE49-F238E27FC236}">
-                <a16:creationId xmlns:a16="http://schemas.microsoft.com/office/drawing/2014/main" id="{8668950C-C24B-4B0D-A667-E669E30F211F}"/>
+                <a16:creationId xmlns:a16="http://schemas.microsoft.com/office/drawing/2014/main" id="{86AEF61A-5476-4C5E-8C2B-2E07CC8BADF7}"/>
               </a:ext>
             </a:extLst>
           </p:cNvPr>
@@ -11142,7 +11147,7 @@
           <p:cNvPr id="23" name="">
             <a:extLst xmlns:a="http://schemas.openxmlformats.org/drawingml/2006/main">
               <a:ext uri="{FF2B5EF4-FFF2-40B4-BE49-F238E27FC236}">
-                <a16:creationId xmlns:a16="http://schemas.microsoft.com/office/drawing/2014/main" id="{21EC2979-DC12-46FA-8B79-49C0F96CF2A5}"/>
+                <a16:creationId xmlns:a16="http://schemas.microsoft.com/office/drawing/2014/main" id="{3DF9295B-E4B3-47AC-9277-89F65CF32B6B}"/>
               </a:ext>
             </a:extLst>
           </p:cNvPr>
@@ -11176,7 +11181,7 @@
           <p:cNvPr id="24" name="">
             <a:extLst xmlns:a="http://schemas.openxmlformats.org/drawingml/2006/main">
               <a:ext uri="{FF2B5EF4-FFF2-40B4-BE49-F238E27FC236}">
-                <a16:creationId xmlns:a16="http://schemas.microsoft.com/office/drawing/2014/main" id="{9B0FB389-EFF6-48D4-AE58-C35CCD4EC1C9}"/>
+                <a16:creationId xmlns:a16="http://schemas.microsoft.com/office/drawing/2014/main" id="{2FC86E8F-B8CA-4994-9A46-D6772543B3D7}"/>
               </a:ext>
             </a:extLst>
           </p:cNvPr>
@@ -11208,7 +11213,7 @@
           <p:cNvPr id="25" name="">
             <a:extLst xmlns:a="http://schemas.openxmlformats.org/drawingml/2006/main">
               <a:ext uri="{FF2B5EF4-FFF2-40B4-BE49-F238E27FC236}">
-                <a16:creationId xmlns:a16="http://schemas.microsoft.com/office/drawing/2014/main" id="{364F584F-4C53-44C8-96F5-06D1F996F429}"/>
+                <a16:creationId xmlns:a16="http://schemas.microsoft.com/office/drawing/2014/main" id="{8D717901-66C3-412D-BC8D-548DE17176AF}"/>
               </a:ext>
             </a:extLst>
           </p:cNvPr>
@@ -11265,7 +11270,7 @@
           <p:cNvPr id="26" name="">
             <a:extLst xmlns:a="http://schemas.openxmlformats.org/drawingml/2006/main">
               <a:ext uri="{FF2B5EF4-FFF2-40B4-BE49-F238E27FC236}">
-                <a16:creationId xmlns:a16="http://schemas.microsoft.com/office/drawing/2014/main" id="{387430F1-C144-4412-A1D7-62D8F92CCC2D}"/>
+                <a16:creationId xmlns:a16="http://schemas.microsoft.com/office/drawing/2014/main" id="{7F6B1F1E-F3A3-4AD7-960C-EF20A4F8CB36}"/>
               </a:ext>
             </a:extLst>
           </p:cNvPr>
@@ -11345,7 +11350,7 @@
           <p:cNvPr id="27" name="">
             <a:extLst xmlns:a="http://schemas.openxmlformats.org/drawingml/2006/main">
               <a:ext uri="{FF2B5EF4-FFF2-40B4-BE49-F238E27FC236}">
-                <a16:creationId xmlns:a16="http://schemas.microsoft.com/office/drawing/2014/main" id="{DEE4A019-2285-4A80-AD5E-79B21C6B4D45}"/>
+                <a16:creationId xmlns:a16="http://schemas.microsoft.com/office/drawing/2014/main" id="{DB19F647-4B2D-4B4A-AB6C-231175BAB5BA}"/>
               </a:ext>
             </a:extLst>
           </p:cNvPr>
@@ -11402,7 +11407,7 @@
           <p:cNvPr id="28" name="">
             <a:extLst xmlns:a="http://schemas.openxmlformats.org/drawingml/2006/main">
               <a:ext uri="{FF2B5EF4-FFF2-40B4-BE49-F238E27FC236}">
-                <a16:creationId xmlns:a16="http://schemas.microsoft.com/office/drawing/2014/main" id="{B9306DAF-42BA-4243-A78D-85A74C08A8ED}"/>
+                <a16:creationId xmlns:a16="http://schemas.microsoft.com/office/drawing/2014/main" id="{1E550DC0-2AAF-4D0A-88F5-AE648DE757AA}"/>
               </a:ext>
             </a:extLst>
           </p:cNvPr>
@@ -11459,7 +11464,7 @@
           <p:cNvPr id="29" name="">
             <a:extLst xmlns:a="http://schemas.openxmlformats.org/drawingml/2006/main">
               <a:ext uri="{FF2B5EF4-FFF2-40B4-BE49-F238E27FC236}">
-                <a16:creationId xmlns:a16="http://schemas.microsoft.com/office/drawing/2014/main" id="{F0C3FB43-A8CF-4DEB-8ACA-9467E82D1CFF}"/>
+                <a16:creationId xmlns:a16="http://schemas.microsoft.com/office/drawing/2014/main" id="{7EB3C451-A6A1-4817-9D91-F4E98B543B32}"/>
               </a:ext>
             </a:extLst>
           </p:cNvPr>
@@ -11493,7 +11498,7 @@
           <p:cNvPr id="30" name="">
             <a:extLst xmlns:a="http://schemas.openxmlformats.org/drawingml/2006/main">
               <a:ext uri="{FF2B5EF4-FFF2-40B4-BE49-F238E27FC236}">
-                <a16:creationId xmlns:a16="http://schemas.microsoft.com/office/drawing/2014/main" id="{744B7583-6838-4C68-B163-512CC4055041}"/>
+                <a16:creationId xmlns:a16="http://schemas.microsoft.com/office/drawing/2014/main" id="{1C1F37BF-CB11-4207-A387-8167998621F8}"/>
               </a:ext>
             </a:extLst>
           </p:cNvPr>
@@ -11525,7 +11530,7 @@
           <p:cNvPr id="31" name="">
             <a:extLst xmlns:a="http://schemas.openxmlformats.org/drawingml/2006/main">
               <a:ext uri="{FF2B5EF4-FFF2-40B4-BE49-F238E27FC236}">
-                <a16:creationId xmlns:a16="http://schemas.microsoft.com/office/drawing/2014/main" id="{7F46A444-5351-44F7-83D3-9676D24AF423}"/>
+                <a16:creationId xmlns:a16="http://schemas.microsoft.com/office/drawing/2014/main" id="{EE8B3175-25AB-4060-BCD6-961A874CA7DF}"/>
               </a:ext>
             </a:extLst>
           </p:cNvPr>
@@ -11582,7 +11587,7 @@
           <p:cNvPr id="32" name="">
             <a:extLst xmlns:a="http://schemas.openxmlformats.org/drawingml/2006/main">
               <a:ext uri="{FF2B5EF4-FFF2-40B4-BE49-F238E27FC236}">
-                <a16:creationId xmlns:a16="http://schemas.microsoft.com/office/drawing/2014/main" id="{BA96E2F3-6271-4639-AFAD-083CC073E555}"/>
+                <a16:creationId xmlns:a16="http://schemas.microsoft.com/office/drawing/2014/main" id="{2601F9E9-6D5D-491D-9D4A-F979CC10E06C}"/>
               </a:ext>
             </a:extLst>
           </p:cNvPr>
@@ -11662,7 +11667,7 @@
           <p:cNvPr id="33" name="">
             <a:extLst xmlns:a="http://schemas.openxmlformats.org/drawingml/2006/main">
               <a:ext uri="{FF2B5EF4-FFF2-40B4-BE49-F238E27FC236}">
-                <a16:creationId xmlns:a16="http://schemas.microsoft.com/office/drawing/2014/main" id="{0113CAD2-7C5F-4E53-91EC-22358149378D}"/>
+                <a16:creationId xmlns:a16="http://schemas.microsoft.com/office/drawing/2014/main" id="{DCBAB00F-9CFC-4516-ABCB-C6A11FE6A2C9}"/>
               </a:ext>
             </a:extLst>
           </p:cNvPr>
@@ -11719,7 +11724,7 @@
           <p:cNvPr id="34" name="">
             <a:extLst xmlns:a="http://schemas.openxmlformats.org/drawingml/2006/main">
               <a:ext uri="{FF2B5EF4-FFF2-40B4-BE49-F238E27FC236}">
-                <a16:creationId xmlns:a16="http://schemas.microsoft.com/office/drawing/2014/main" id="{307D6511-F38E-44BC-9480-54AD92728599}"/>
+                <a16:creationId xmlns:a16="http://schemas.microsoft.com/office/drawing/2014/main" id="{E17CB093-B55B-4711-B15E-0E3E7D8CB70A}"/>
               </a:ext>
             </a:extLst>
           </p:cNvPr>
@@ -11776,7 +11781,7 @@
           <p:cNvPr id="35" name="">
             <a:extLst xmlns:a="http://schemas.openxmlformats.org/drawingml/2006/main">
               <a:ext uri="{FF2B5EF4-FFF2-40B4-BE49-F238E27FC236}">
-                <a16:creationId xmlns:a16="http://schemas.microsoft.com/office/drawing/2014/main" id="{D1488098-EE74-486B-8D07-4EB6CA669C59}"/>
+                <a16:creationId xmlns:a16="http://schemas.microsoft.com/office/drawing/2014/main" id="{BF82C814-030A-4C72-938F-269AF09D2412}"/>
               </a:ext>
             </a:extLst>
           </p:cNvPr>
@@ -11833,7 +11838,7 @@
           <p:cNvPr id="36" name="">
             <a:extLst xmlns:a="http://schemas.openxmlformats.org/drawingml/2006/main">
               <a:ext uri="{FF2B5EF4-FFF2-40B4-BE49-F238E27FC236}">
-                <a16:creationId xmlns:a16="http://schemas.microsoft.com/office/drawing/2014/main" id="{E8C0CF6C-A8C2-4F23-9000-2A181E5BC530}"/>
+                <a16:creationId xmlns:a16="http://schemas.microsoft.com/office/drawing/2014/main" id="{8ED34BBA-77D3-4E4C-BE22-61AA6C0678D3}"/>
               </a:ext>
             </a:extLst>
           </p:cNvPr>
@@ -11865,7 +11870,7 @@
           <p:cNvPr id="37" name="">
             <a:extLst xmlns:a="http://schemas.openxmlformats.org/drawingml/2006/main">
               <a:ext uri="{FF2B5EF4-FFF2-40B4-BE49-F238E27FC236}">
-                <a16:creationId xmlns:a16="http://schemas.microsoft.com/office/drawing/2014/main" id="{0B9A2E1E-9DBB-4D53-9E23-17769D1CEA32}"/>
+                <a16:creationId xmlns:a16="http://schemas.microsoft.com/office/drawing/2014/main" id="{9DDFE5F4-AF4F-4B6F-8508-A7213D556AA5}"/>
               </a:ext>
             </a:extLst>
           </p:cNvPr>
@@ -11920,7 +11925,7 @@
     </p:spTree>
     <p:extLst>
       <p:ext uri="{BB962C8B-B14F-4D97-AF65-F5344CB8AC3E}">
-        <p14:creationId xmlns:p14="http://schemas.microsoft.com/office/powerpoint/2010/main" val="939336465"/>
+        <p14:creationId xmlns:p14="http://schemas.microsoft.com/office/powerpoint/2010/main" val="1002940776"/>
       </p:ext>
     </p:extLst>
   </p:cSld>
@@ -11951,7 +11956,7 @@
           <p:cNvPr id="27" name="">
             <a:extLst xmlns:a="http://schemas.openxmlformats.org/drawingml/2006/main">
               <a:ext uri="{FF2B5EF4-FFF2-40B4-BE49-F238E27FC236}">
-                <a16:creationId xmlns:a16="http://schemas.microsoft.com/office/drawing/2014/main" id="{157FC6B5-8D87-4114-A7BB-F8807D105DC4}"/>
+                <a16:creationId xmlns:a16="http://schemas.microsoft.com/office/drawing/2014/main" id="{744125B2-F7AE-415A-A0A7-508C133F194C}"/>
               </a:ext>
             </a:extLst>
           </p:cNvPr>
@@ -12008,7 +12013,7 @@
           <p:cNvPr id="2" name="">
             <a:extLst xmlns:a="http://schemas.openxmlformats.org/drawingml/2006/main">
               <a:ext uri="{FF2B5EF4-FFF2-40B4-BE49-F238E27FC236}">
-                <a16:creationId xmlns:a16="http://schemas.microsoft.com/office/drawing/2014/main" id="{2258FAF6-02B9-45BD-9AA2-2FC721E3E629}"/>
+                <a16:creationId xmlns:a16="http://schemas.microsoft.com/office/drawing/2014/main" id="{10DD238A-9B91-4B59-80F5-B8D6582470B4}"/>
               </a:ext>
             </a:extLst>
           </p:cNvPr>
@@ -12065,7 +12070,7 @@
           <p:cNvPr id="3" name="">
             <a:extLst xmlns:a="http://schemas.openxmlformats.org/drawingml/2006/main">
               <a:ext uri="{FF2B5EF4-FFF2-40B4-BE49-F238E27FC236}">
-                <a16:creationId xmlns:a16="http://schemas.microsoft.com/office/drawing/2014/main" id="{DA5A7AC2-BC7B-4456-89E6-27F7C6795119}"/>
+                <a16:creationId xmlns:a16="http://schemas.microsoft.com/office/drawing/2014/main" id="{93B7408A-4B94-4138-B9E1-4D6294F9CD2B}"/>
               </a:ext>
             </a:extLst>
           </p:cNvPr>
@@ -12095,7 +12100,7 @@
           <p:cNvPr id="4" name="">
             <a:extLst xmlns:a="http://schemas.openxmlformats.org/drawingml/2006/main">
               <a:ext uri="{FF2B5EF4-FFF2-40B4-BE49-F238E27FC236}">
-                <a16:creationId xmlns:a16="http://schemas.microsoft.com/office/drawing/2014/main" id="{FC07052F-0E42-4E48-A66D-80ADE0DFB986}"/>
+                <a16:creationId xmlns:a16="http://schemas.microsoft.com/office/drawing/2014/main" id="{377CEF07-8430-451C-8509-7CD3F1BA1766}"/>
               </a:ext>
             </a:extLst>
           </p:cNvPr>
@@ -12152,7 +12157,7 @@
           <p:cNvPr id="5" name="">
             <a:extLst xmlns:a="http://schemas.openxmlformats.org/drawingml/2006/main">
               <a:ext uri="{FF2B5EF4-FFF2-40B4-BE49-F238E27FC236}">
-                <a16:creationId xmlns:a16="http://schemas.microsoft.com/office/drawing/2014/main" id="{16936ED2-B648-41AC-8D44-BA18256D7A2A}"/>
+                <a16:creationId xmlns:a16="http://schemas.microsoft.com/office/drawing/2014/main" id="{E3ED70B0-2373-46D3-9FD4-6773F25F84DA}"/>
               </a:ext>
             </a:extLst>
           </p:cNvPr>
@@ -12184,7 +12189,7 @@
           <p:cNvPr id="6" name="">
             <a:extLst xmlns:a="http://schemas.openxmlformats.org/drawingml/2006/main">
               <a:ext uri="{FF2B5EF4-FFF2-40B4-BE49-F238E27FC236}">
-                <a16:creationId xmlns:a16="http://schemas.microsoft.com/office/drawing/2014/main" id="{78B2BC70-6E23-4572-AAB2-3A9933A08981}"/>
+                <a16:creationId xmlns:a16="http://schemas.microsoft.com/office/drawing/2014/main" id="{084D477C-DE1F-48B3-92BC-0C403145C8C7}"/>
               </a:ext>
             </a:extLst>
           </p:cNvPr>
@@ -12241,7 +12246,7 @@
           <p:cNvPr id="7" name="">
             <a:extLst xmlns:a="http://schemas.openxmlformats.org/drawingml/2006/main">
               <a:ext uri="{FF2B5EF4-FFF2-40B4-BE49-F238E27FC236}">
-                <a16:creationId xmlns:a16="http://schemas.microsoft.com/office/drawing/2014/main" id="{545E3CC8-8CC2-47CF-B55B-BF6AB3942802}"/>
+                <a16:creationId xmlns:a16="http://schemas.microsoft.com/office/drawing/2014/main" id="{855F48EB-51E7-4656-8434-26FD856244AC}"/>
               </a:ext>
             </a:extLst>
           </p:cNvPr>
@@ -12298,7 +12303,7 @@
           <p:cNvPr id="8" name="">
             <a:extLst xmlns:a="http://schemas.openxmlformats.org/drawingml/2006/main">
               <a:ext uri="{FF2B5EF4-FFF2-40B4-BE49-F238E27FC236}">
-                <a16:creationId xmlns:a16="http://schemas.microsoft.com/office/drawing/2014/main" id="{0B361D5C-3FD7-43C0-A3A5-F69FB588F63D}"/>
+                <a16:creationId xmlns:a16="http://schemas.microsoft.com/office/drawing/2014/main" id="{DACACEDA-0276-4CC4-8915-0F70DC8617F9}"/>
               </a:ext>
             </a:extLst>
           </p:cNvPr>
@@ -12330,7 +12335,7 @@
           <p:cNvPr id="9" name="">
             <a:extLst xmlns:a="http://schemas.openxmlformats.org/drawingml/2006/main">
               <a:ext uri="{FF2B5EF4-FFF2-40B4-BE49-F238E27FC236}">
-                <a16:creationId xmlns:a16="http://schemas.microsoft.com/office/drawing/2014/main" id="{0096F97A-EA20-4B0E-9C50-747D2B34C9AD}"/>
+                <a16:creationId xmlns:a16="http://schemas.microsoft.com/office/drawing/2014/main" id="{13F8C4EE-DFC1-4757-A2E1-4DCBD1051675}"/>
               </a:ext>
             </a:extLst>
           </p:cNvPr>
@@ -12387,7 +12392,7 @@
           <p:cNvPr id="10" name="">
             <a:extLst xmlns:a="http://schemas.openxmlformats.org/drawingml/2006/main">
               <a:ext uri="{FF2B5EF4-FFF2-40B4-BE49-F238E27FC236}">
-                <a16:creationId xmlns:a16="http://schemas.microsoft.com/office/drawing/2014/main" id="{B8D83CEC-8378-43F9-A339-E19C16F05641}"/>
+                <a16:creationId xmlns:a16="http://schemas.microsoft.com/office/drawing/2014/main" id="{C9B989E1-FE63-4F38-8CB1-C5901C03BAB7}"/>
               </a:ext>
             </a:extLst>
           </p:cNvPr>
@@ -12444,7 +12449,7 @@
           <p:cNvPr id="11" name="">
             <a:extLst xmlns:a="http://schemas.openxmlformats.org/drawingml/2006/main">
               <a:ext uri="{FF2B5EF4-FFF2-40B4-BE49-F238E27FC236}">
-                <a16:creationId xmlns:a16="http://schemas.microsoft.com/office/drawing/2014/main" id="{3CD9842E-076C-4C29-9E00-E227B6E9CFE9}"/>
+                <a16:creationId xmlns:a16="http://schemas.microsoft.com/office/drawing/2014/main" id="{1F614E9D-E39D-42E1-BE07-C722375165CD}"/>
               </a:ext>
             </a:extLst>
           </p:cNvPr>
@@ -12476,7 +12481,7 @@
           <p:cNvPr id="12" name="">
             <a:extLst xmlns:a="http://schemas.openxmlformats.org/drawingml/2006/main">
               <a:ext uri="{FF2B5EF4-FFF2-40B4-BE49-F238E27FC236}">
-                <a16:creationId xmlns:a16="http://schemas.microsoft.com/office/drawing/2014/main" id="{624264F6-AB52-4A10-AB81-B94E774840E7}"/>
+                <a16:creationId xmlns:a16="http://schemas.microsoft.com/office/drawing/2014/main" id="{14EE157A-E0EA-4426-8895-39BB25607D13}"/>
               </a:ext>
             </a:extLst>
           </p:cNvPr>
@@ -12533,7 +12538,7 @@
           <p:cNvPr id="13" name="">
             <a:extLst xmlns:a="http://schemas.openxmlformats.org/drawingml/2006/main">
               <a:ext uri="{FF2B5EF4-FFF2-40B4-BE49-F238E27FC236}">
-                <a16:creationId xmlns:a16="http://schemas.microsoft.com/office/drawing/2014/main" id="{32AF69E8-38FA-475B-A3E7-C86B9B624AFD}"/>
+                <a16:creationId xmlns:a16="http://schemas.microsoft.com/office/drawing/2014/main" id="{7A1E04C2-B0CD-481E-B409-22B95AFF67E8}"/>
               </a:ext>
             </a:extLst>
           </p:cNvPr>
@@ -12590,7 +12595,7 @@
           <p:cNvPr id="14" name="">
             <a:extLst xmlns:a="http://schemas.openxmlformats.org/drawingml/2006/main">
               <a:ext uri="{FF2B5EF4-FFF2-40B4-BE49-F238E27FC236}">
-                <a16:creationId xmlns:a16="http://schemas.microsoft.com/office/drawing/2014/main" id="{DCB54BD7-0D5C-4314-83CB-44C1A2285D4B}"/>
+                <a16:creationId xmlns:a16="http://schemas.microsoft.com/office/drawing/2014/main" id="{4D44ED58-D436-457B-B5A9-3ABB2357950A}"/>
               </a:ext>
             </a:extLst>
           </p:cNvPr>
@@ -12622,7 +12627,7 @@
           <p:cNvPr id="15" name="">
             <a:extLst xmlns:a="http://schemas.openxmlformats.org/drawingml/2006/main">
               <a:ext uri="{FF2B5EF4-FFF2-40B4-BE49-F238E27FC236}">
-                <a16:creationId xmlns:a16="http://schemas.microsoft.com/office/drawing/2014/main" id="{FE0097F6-6EBC-4747-8661-6F501AC3B7CC}"/>
+                <a16:creationId xmlns:a16="http://schemas.microsoft.com/office/drawing/2014/main" id="{85448D92-D2E3-4E32-8148-88799243FAC9}"/>
               </a:ext>
             </a:extLst>
           </p:cNvPr>
@@ -12679,7 +12684,7 @@
           <p:cNvPr id="16" name="">
             <a:extLst xmlns:a="http://schemas.openxmlformats.org/drawingml/2006/main">
               <a:ext uri="{FF2B5EF4-FFF2-40B4-BE49-F238E27FC236}">
-                <a16:creationId xmlns:a16="http://schemas.microsoft.com/office/drawing/2014/main" id="{4E22240C-0667-453B-B158-6216C76C79B4}"/>
+                <a16:creationId xmlns:a16="http://schemas.microsoft.com/office/drawing/2014/main" id="{575ED97E-AA1A-4CEB-924B-DECA0E5E40D9}"/>
               </a:ext>
             </a:extLst>
           </p:cNvPr>
@@ -12736,7 +12741,7 @@
           <p:cNvPr id="17" name="">
             <a:extLst xmlns:a="http://schemas.openxmlformats.org/drawingml/2006/main">
               <a:ext uri="{FF2B5EF4-FFF2-40B4-BE49-F238E27FC236}">
-                <a16:creationId xmlns:a16="http://schemas.microsoft.com/office/drawing/2014/main" id="{83CF4074-5EC9-40DB-9855-5BD4DAD5DDB7}"/>
+                <a16:creationId xmlns:a16="http://schemas.microsoft.com/office/drawing/2014/main" id="{03722A38-1D3F-4EF6-BD78-839BCC56B8A2}"/>
               </a:ext>
             </a:extLst>
           </p:cNvPr>
@@ -12768,7 +12773,7 @@
           <p:cNvPr id="18" name="">
             <a:extLst xmlns:a="http://schemas.openxmlformats.org/drawingml/2006/main">
               <a:ext uri="{FF2B5EF4-FFF2-40B4-BE49-F238E27FC236}">
-                <a16:creationId xmlns:a16="http://schemas.microsoft.com/office/drawing/2014/main" id="{67895F72-2ADA-498C-8B46-D8B471E7EA97}"/>
+                <a16:creationId xmlns:a16="http://schemas.microsoft.com/office/drawing/2014/main" id="{E92263EB-8FD8-4E85-AD6C-C4E61E5BB845}"/>
               </a:ext>
             </a:extLst>
           </p:cNvPr>
@@ -12825,7 +12830,7 @@
           <p:cNvPr id="19" name="">
             <a:extLst xmlns:a="http://schemas.openxmlformats.org/drawingml/2006/main">
               <a:ext uri="{FF2B5EF4-FFF2-40B4-BE49-F238E27FC236}">
-                <a16:creationId xmlns:a16="http://schemas.microsoft.com/office/drawing/2014/main" id="{2378B3A5-9183-4139-8A0D-4EA1D4A00AC1}"/>
+                <a16:creationId xmlns:a16="http://schemas.microsoft.com/office/drawing/2014/main" id="{45B33692-7E29-4B49-A4CF-1E243DF7C096}"/>
               </a:ext>
             </a:extLst>
           </p:cNvPr>
@@ -12882,7 +12887,7 @@
           <p:cNvPr id="20" name="">
             <a:extLst xmlns:a="http://schemas.openxmlformats.org/drawingml/2006/main">
               <a:ext uri="{FF2B5EF4-FFF2-40B4-BE49-F238E27FC236}">
-                <a16:creationId xmlns:a16="http://schemas.microsoft.com/office/drawing/2014/main" id="{785F8996-764B-417B-94C0-2B5F2EA29209}"/>
+                <a16:creationId xmlns:a16="http://schemas.microsoft.com/office/drawing/2014/main" id="{C447F238-4D63-41BF-AA48-876FC61D8376}"/>
               </a:ext>
             </a:extLst>
           </p:cNvPr>
@@ -12914,7 +12919,7 @@
           <p:cNvPr id="21" name="">
             <a:extLst xmlns:a="http://schemas.openxmlformats.org/drawingml/2006/main">
               <a:ext uri="{FF2B5EF4-FFF2-40B4-BE49-F238E27FC236}">
-                <a16:creationId xmlns:a16="http://schemas.microsoft.com/office/drawing/2014/main" id="{2E4C5A46-7DFD-4B23-9C7A-9C8D07980FB0}"/>
+                <a16:creationId xmlns:a16="http://schemas.microsoft.com/office/drawing/2014/main" id="{3DFC2D96-6757-4A96-B6CD-270B779A30A9}"/>
               </a:ext>
             </a:extLst>
           </p:cNvPr>
@@ -12971,7 +12976,7 @@
           <p:cNvPr id="22" name="">
             <a:extLst xmlns:a="http://schemas.openxmlformats.org/drawingml/2006/main">
               <a:ext uri="{FF2B5EF4-FFF2-40B4-BE49-F238E27FC236}">
-                <a16:creationId xmlns:a16="http://schemas.microsoft.com/office/drawing/2014/main" id="{7F476A39-2FDE-472A-9FC3-8DFF6D625E5E}"/>
+                <a16:creationId xmlns:a16="http://schemas.microsoft.com/office/drawing/2014/main" id="{64D494AC-30B8-4902-BAB2-283685CDD002}"/>
               </a:ext>
             </a:extLst>
           </p:cNvPr>
@@ -13028,7 +13033,7 @@
           <p:cNvPr id="23" name="">
             <a:extLst xmlns:a="http://schemas.openxmlformats.org/drawingml/2006/main">
               <a:ext uri="{FF2B5EF4-FFF2-40B4-BE49-F238E27FC236}">
-                <a16:creationId xmlns:a16="http://schemas.microsoft.com/office/drawing/2014/main" id="{2326F78B-46E5-4852-ADEA-A064169FE6F0}"/>
+                <a16:creationId xmlns:a16="http://schemas.microsoft.com/office/drawing/2014/main" id="{5396EC97-FC44-4193-A95F-B268ADD3E368}"/>
               </a:ext>
             </a:extLst>
           </p:cNvPr>
@@ -13060,7 +13065,7 @@
           <p:cNvPr id="24" name="">
             <a:extLst xmlns:a="http://schemas.openxmlformats.org/drawingml/2006/main">
               <a:ext uri="{FF2B5EF4-FFF2-40B4-BE49-F238E27FC236}">
-                <a16:creationId xmlns:a16="http://schemas.microsoft.com/office/drawing/2014/main" id="{1A0A3E17-B81B-4CEE-9ADE-99AADC476639}"/>
+                <a16:creationId xmlns:a16="http://schemas.microsoft.com/office/drawing/2014/main" id="{19228DCF-8454-4F62-9DED-965ECF4CB277}"/>
               </a:ext>
             </a:extLst>
           </p:cNvPr>
@@ -13117,7 +13122,7 @@
           <p:cNvPr id="25" name="">
             <a:extLst xmlns:a="http://schemas.openxmlformats.org/drawingml/2006/main">
               <a:ext uri="{FF2B5EF4-FFF2-40B4-BE49-F238E27FC236}">
-                <a16:creationId xmlns:a16="http://schemas.microsoft.com/office/drawing/2014/main" id="{40A9FBB5-51FF-4ADF-B04D-6F6BDAB61790}"/>
+                <a16:creationId xmlns:a16="http://schemas.microsoft.com/office/drawing/2014/main" id="{AE72FDE1-4094-4220-8999-5C1B047A8F59}"/>
               </a:ext>
             </a:extLst>
           </p:cNvPr>
@@ -13174,7 +13179,7 @@
           <p:cNvPr id="26" name="">
             <a:extLst xmlns:a="http://schemas.openxmlformats.org/drawingml/2006/main">
               <a:ext uri="{FF2B5EF4-FFF2-40B4-BE49-F238E27FC236}">
-                <a16:creationId xmlns:a16="http://schemas.microsoft.com/office/drawing/2014/main" id="{1DC2840C-0E76-4103-8957-53E8069C93A1}"/>
+                <a16:creationId xmlns:a16="http://schemas.microsoft.com/office/drawing/2014/main" id="{219B18E3-7FBB-46C7-B7BD-EAFF09A02392}"/>
               </a:ext>
             </a:extLst>
           </p:cNvPr>
@@ -13229,7 +13234,7 @@
     </p:spTree>
     <p:extLst>
       <p:ext uri="{BB962C8B-B14F-4D97-AF65-F5344CB8AC3E}">
-        <p14:creationId xmlns:p14="http://schemas.microsoft.com/office/powerpoint/2010/main" val="1081500609"/>
+        <p14:creationId xmlns:p14="http://schemas.microsoft.com/office/powerpoint/2010/main" val="224727309"/>
       </p:ext>
     </p:extLst>
   </p:cSld>
@@ -13260,7 +13265,7 @@
           <p:cNvPr id="18" name="">
             <a:extLst xmlns:a="http://schemas.openxmlformats.org/drawingml/2006/main">
               <a:ext uri="{FF2B5EF4-FFF2-40B4-BE49-F238E27FC236}">
-                <a16:creationId xmlns:a16="http://schemas.microsoft.com/office/drawing/2014/main" id="{4ECE6D16-4E76-4532-A2EF-136D720A03C9}"/>
+                <a16:creationId xmlns:a16="http://schemas.microsoft.com/office/drawing/2014/main" id="{37F3AE24-2514-4301-99C8-A904F8D0E167}"/>
               </a:ext>
             </a:extLst>
           </p:cNvPr>
@@ -13317,7 +13322,7 @@
           <p:cNvPr id="2" name="">
             <a:extLst xmlns:a="http://schemas.openxmlformats.org/drawingml/2006/main">
               <a:ext uri="{FF2B5EF4-FFF2-40B4-BE49-F238E27FC236}">
-                <a16:creationId xmlns:a16="http://schemas.microsoft.com/office/drawing/2014/main" id="{86734E2F-DA68-496D-BCDA-F8E1DFE683D6}"/>
+                <a16:creationId xmlns:a16="http://schemas.microsoft.com/office/drawing/2014/main" id="{CB43CE2A-A440-4CB2-B31F-78E7B130975C}"/>
               </a:ext>
             </a:extLst>
           </p:cNvPr>
@@ -13374,7 +13379,7 @@
           <p:cNvPr id="3" name="">
             <a:extLst xmlns:a="http://schemas.openxmlformats.org/drawingml/2006/main">
               <a:ext uri="{FF2B5EF4-FFF2-40B4-BE49-F238E27FC236}">
-                <a16:creationId xmlns:a16="http://schemas.microsoft.com/office/drawing/2014/main" id="{36E006CA-1C26-4C80-ABCD-6C0BEB18F3A5}"/>
+                <a16:creationId xmlns:a16="http://schemas.microsoft.com/office/drawing/2014/main" id="{E4615716-1016-4AC3-941A-ABDB0E47B662}"/>
               </a:ext>
             </a:extLst>
           </p:cNvPr>
@@ -13404,7 +13409,7 @@
           <p:cNvPr id="4" name="">
             <a:extLst xmlns:a="http://schemas.openxmlformats.org/drawingml/2006/main">
               <a:ext uri="{FF2B5EF4-FFF2-40B4-BE49-F238E27FC236}">
-                <a16:creationId xmlns:a16="http://schemas.microsoft.com/office/drawing/2014/main" id="{E57E3510-A89A-42D2-97D1-64D25157500B}"/>
+                <a16:creationId xmlns:a16="http://schemas.microsoft.com/office/drawing/2014/main" id="{590E01C7-7A93-4387-A912-5690896FFE4D}"/>
               </a:ext>
             </a:extLst>
           </p:cNvPr>
@@ -13461,7 +13466,7 @@
           <p:cNvPr id="5" name="">
             <a:extLst xmlns:a="http://schemas.openxmlformats.org/drawingml/2006/main">
               <a:ext uri="{FF2B5EF4-FFF2-40B4-BE49-F238E27FC236}">
-                <a16:creationId xmlns:a16="http://schemas.microsoft.com/office/drawing/2014/main" id="{88592E0C-C0D7-446F-A465-2761DC551FC7}"/>
+                <a16:creationId xmlns:a16="http://schemas.microsoft.com/office/drawing/2014/main" id="{A5196BBA-2691-4DC3-BC33-45D6E90EE988}"/>
               </a:ext>
             </a:extLst>
           </p:cNvPr>
@@ -13493,7 +13498,7 @@
           <p:cNvPr id="6" name="">
             <a:extLst xmlns:a="http://schemas.openxmlformats.org/drawingml/2006/main">
               <a:ext uri="{FF2B5EF4-FFF2-40B4-BE49-F238E27FC236}">
-                <a16:creationId xmlns:a16="http://schemas.microsoft.com/office/drawing/2014/main" id="{5F6E27F5-98E9-482F-8554-3773AE1963C6}"/>
+                <a16:creationId xmlns:a16="http://schemas.microsoft.com/office/drawing/2014/main" id="{0947D5CA-DB21-404F-BCD7-E21214143F74}"/>
               </a:ext>
             </a:extLst>
           </p:cNvPr>
@@ -13550,7 +13555,7 @@
           <p:cNvPr id="7" name="">
             <a:extLst xmlns:a="http://schemas.openxmlformats.org/drawingml/2006/main">
               <a:ext uri="{FF2B5EF4-FFF2-40B4-BE49-F238E27FC236}">
-                <a16:creationId xmlns:a16="http://schemas.microsoft.com/office/drawing/2014/main" id="{810A2C70-FF6A-466A-8843-1F5C7F31BD50}"/>
+                <a16:creationId xmlns:a16="http://schemas.microsoft.com/office/drawing/2014/main" id="{7FCB1B36-D502-4A3B-92C0-939A08BA0A2D}"/>
               </a:ext>
             </a:extLst>
           </p:cNvPr>
@@ -13676,7 +13681,7 @@
           <p:cNvPr id="8" name="">
             <a:extLst xmlns:a="http://schemas.openxmlformats.org/drawingml/2006/main">
               <a:ext uri="{FF2B5EF4-FFF2-40B4-BE49-F238E27FC236}">
-                <a16:creationId xmlns:a16="http://schemas.microsoft.com/office/drawing/2014/main" id="{6CB31D97-17A4-46C9-8A07-36DEA3601956}"/>
+                <a16:creationId xmlns:a16="http://schemas.microsoft.com/office/drawing/2014/main" id="{C6147773-23B3-4038-92FD-E7DD5994433E}"/>
               </a:ext>
             </a:extLst>
           </p:cNvPr>
@@ -13708,7 +13713,7 @@
           <p:cNvPr id="9" name="">
             <a:extLst xmlns:a="http://schemas.openxmlformats.org/drawingml/2006/main">
               <a:ext uri="{FF2B5EF4-FFF2-40B4-BE49-F238E27FC236}">
-                <a16:creationId xmlns:a16="http://schemas.microsoft.com/office/drawing/2014/main" id="{5FA33541-B52E-4B3E-9C8C-08C4908B9719}"/>
+                <a16:creationId xmlns:a16="http://schemas.microsoft.com/office/drawing/2014/main" id="{2DBBF715-622F-4301-BA73-A6348E9F30FC}"/>
               </a:ext>
             </a:extLst>
           </p:cNvPr>
@@ -13765,7 +13770,7 @@
           <p:cNvPr id="10" name="">
             <a:extLst xmlns:a="http://schemas.openxmlformats.org/drawingml/2006/main">
               <a:ext uri="{FF2B5EF4-FFF2-40B4-BE49-F238E27FC236}">
-                <a16:creationId xmlns:a16="http://schemas.microsoft.com/office/drawing/2014/main" id="{6CC6FC84-FDCE-4065-854C-4E3EDDCC4F88}"/>
+                <a16:creationId xmlns:a16="http://schemas.microsoft.com/office/drawing/2014/main" id="{009D5B4C-D4BA-4271-9896-DB85CA239C91}"/>
               </a:ext>
             </a:extLst>
           </p:cNvPr>
@@ -13822,7 +13827,7 @@
           <p:cNvPr id="11" name="">
             <a:extLst xmlns:a="http://schemas.openxmlformats.org/drawingml/2006/main">
               <a:ext uri="{FF2B5EF4-FFF2-40B4-BE49-F238E27FC236}">
-                <a16:creationId xmlns:a16="http://schemas.microsoft.com/office/drawing/2014/main" id="{6C88C076-1222-48FA-AD9D-EC463FDF16CF}"/>
+                <a16:creationId xmlns:a16="http://schemas.microsoft.com/office/drawing/2014/main" id="{3E4D5E3B-9402-40EB-A0F4-ECD5FA1B245A}"/>
               </a:ext>
             </a:extLst>
           </p:cNvPr>
@@ -13854,7 +13859,7 @@
           <p:cNvPr id="12" name="">
             <a:extLst xmlns:a="http://schemas.openxmlformats.org/drawingml/2006/main">
               <a:ext uri="{FF2B5EF4-FFF2-40B4-BE49-F238E27FC236}">
-                <a16:creationId xmlns:a16="http://schemas.microsoft.com/office/drawing/2014/main" id="{26D3BBBF-E444-46FC-98AA-2430DCB9FE23}"/>
+                <a16:creationId xmlns:a16="http://schemas.microsoft.com/office/drawing/2014/main" id="{AE0545E9-E479-4A69-BC8D-752DC3689792}"/>
               </a:ext>
             </a:extLst>
           </p:cNvPr>
@@ -13911,7 +13916,7 @@
           <p:cNvPr id="13" name="">
             <a:extLst xmlns:a="http://schemas.openxmlformats.org/drawingml/2006/main">
               <a:ext uri="{FF2B5EF4-FFF2-40B4-BE49-F238E27FC236}">
-                <a16:creationId xmlns:a16="http://schemas.microsoft.com/office/drawing/2014/main" id="{D5D6B632-559D-4BA8-A158-43C77B54AC5F}"/>
+                <a16:creationId xmlns:a16="http://schemas.microsoft.com/office/drawing/2014/main" id="{9C30B955-1450-4D04-A545-0DBB2664D206}"/>
               </a:ext>
             </a:extLst>
           </p:cNvPr>
@@ -14060,7 +14065,7 @@
           <p:cNvPr id="14" name="">
             <a:extLst xmlns:a="http://schemas.openxmlformats.org/drawingml/2006/main">
               <a:ext uri="{FF2B5EF4-FFF2-40B4-BE49-F238E27FC236}">
-                <a16:creationId xmlns:a16="http://schemas.microsoft.com/office/drawing/2014/main" id="{02B49CAD-4B81-479B-ADDF-515B8F3F4FDA}"/>
+                <a16:creationId xmlns:a16="http://schemas.microsoft.com/office/drawing/2014/main" id="{CCAD15B8-8DF1-42B8-9DE7-855EB1E04521}"/>
               </a:ext>
             </a:extLst>
           </p:cNvPr>
@@ -14092,7 +14097,7 @@
           <p:cNvPr id="15" name="">
             <a:extLst xmlns:a="http://schemas.openxmlformats.org/drawingml/2006/main">
               <a:ext uri="{FF2B5EF4-FFF2-40B4-BE49-F238E27FC236}">
-                <a16:creationId xmlns:a16="http://schemas.microsoft.com/office/drawing/2014/main" id="{2855B1C1-960D-4702-859C-2C66AFCBDB8C}"/>
+                <a16:creationId xmlns:a16="http://schemas.microsoft.com/office/drawing/2014/main" id="{E65963C2-EBCD-49F8-8890-C7682C8092B4}"/>
               </a:ext>
             </a:extLst>
           </p:cNvPr>
@@ -14149,7 +14154,7 @@
           <p:cNvPr id="16" name="">
             <a:extLst xmlns:a="http://schemas.openxmlformats.org/drawingml/2006/main">
               <a:ext uri="{FF2B5EF4-FFF2-40B4-BE49-F238E27FC236}">
-                <a16:creationId xmlns:a16="http://schemas.microsoft.com/office/drawing/2014/main" id="{A72230BD-1E0C-422D-99A1-4A721F946553}"/>
+                <a16:creationId xmlns:a16="http://schemas.microsoft.com/office/drawing/2014/main" id="{2E781DF6-7B6B-490E-82CF-4348AA06A477}"/>
               </a:ext>
             </a:extLst>
           </p:cNvPr>
@@ -14181,7 +14186,7 @@
           <p:cNvPr id="17" name="">
             <a:extLst xmlns:a="http://schemas.openxmlformats.org/drawingml/2006/main">
               <a:ext uri="{FF2B5EF4-FFF2-40B4-BE49-F238E27FC236}">
-                <a16:creationId xmlns:a16="http://schemas.microsoft.com/office/drawing/2014/main" id="{1D3C7D0F-BFA2-47BC-9B91-741208887F2D}"/>
+                <a16:creationId xmlns:a16="http://schemas.microsoft.com/office/drawing/2014/main" id="{09E143F2-B5B9-4D9B-84C0-21D8AA53CF39}"/>
               </a:ext>
             </a:extLst>
           </p:cNvPr>
@@ -14236,7 +14241,7 @@
     </p:spTree>
     <p:extLst>
       <p:ext uri="{BB962C8B-B14F-4D97-AF65-F5344CB8AC3E}">
-        <p14:creationId xmlns:p14="http://schemas.microsoft.com/office/powerpoint/2010/main" val="1160122724"/>
+        <p14:creationId xmlns:p14="http://schemas.microsoft.com/office/powerpoint/2010/main" val="1532286427"/>
       </p:ext>
     </p:extLst>
   </p:cSld>
@@ -14267,7 +14272,7 @@
           <p:cNvPr id="27" name="">
             <a:extLst xmlns:a="http://schemas.openxmlformats.org/drawingml/2006/main">
               <a:ext uri="{FF2B5EF4-FFF2-40B4-BE49-F238E27FC236}">
-                <a16:creationId xmlns:a16="http://schemas.microsoft.com/office/drawing/2014/main" id="{F452F6EC-4D7F-4F4C-8CA6-824B82CCFAC0}"/>
+                <a16:creationId xmlns:a16="http://schemas.microsoft.com/office/drawing/2014/main" id="{CF79F635-92F4-4C61-A963-A69A923F5B8E}"/>
               </a:ext>
             </a:extLst>
           </p:cNvPr>
@@ -14324,7 +14329,7 @@
           <p:cNvPr id="2" name="">
             <a:extLst xmlns:a="http://schemas.openxmlformats.org/drawingml/2006/main">
               <a:ext uri="{FF2B5EF4-FFF2-40B4-BE49-F238E27FC236}">
-                <a16:creationId xmlns:a16="http://schemas.microsoft.com/office/drawing/2014/main" id="{CFB262E1-0202-4F4D-A8FC-717BD1632417}"/>
+                <a16:creationId xmlns:a16="http://schemas.microsoft.com/office/drawing/2014/main" id="{B901D5AD-B5DC-45E2-A565-3F321E85C427}"/>
               </a:ext>
             </a:extLst>
           </p:cNvPr>
@@ -14381,7 +14386,7 @@
           <p:cNvPr id="3" name="">
             <a:extLst xmlns:a="http://schemas.openxmlformats.org/drawingml/2006/main">
               <a:ext uri="{FF2B5EF4-FFF2-40B4-BE49-F238E27FC236}">
-                <a16:creationId xmlns:a16="http://schemas.microsoft.com/office/drawing/2014/main" id="{A4E09A4E-D236-42D6-988E-E2256885C488}"/>
+                <a16:creationId xmlns:a16="http://schemas.microsoft.com/office/drawing/2014/main" id="{EB26430E-E5F4-46E3-B1AD-9A42C27A4E64}"/>
               </a:ext>
             </a:extLst>
           </p:cNvPr>
@@ -14411,7 +14416,7 @@
           <p:cNvPr id="4" name="">
             <a:extLst xmlns:a="http://schemas.openxmlformats.org/drawingml/2006/main">
               <a:ext uri="{FF2B5EF4-FFF2-40B4-BE49-F238E27FC236}">
-                <a16:creationId xmlns:a16="http://schemas.microsoft.com/office/drawing/2014/main" id="{10546998-EDC4-4D0E-A015-2EDC6B521D3D}"/>
+                <a16:creationId xmlns:a16="http://schemas.microsoft.com/office/drawing/2014/main" id="{5E3C53ED-8667-4CB5-A3AC-228596086966}"/>
               </a:ext>
             </a:extLst>
           </p:cNvPr>
@@ -14468,7 +14473,7 @@
           <p:cNvPr id="5" name="">
             <a:extLst xmlns:a="http://schemas.openxmlformats.org/drawingml/2006/main">
               <a:ext uri="{FF2B5EF4-FFF2-40B4-BE49-F238E27FC236}">
-                <a16:creationId xmlns:a16="http://schemas.microsoft.com/office/drawing/2014/main" id="{8C532791-9DA0-411F-8C58-4E8ED7F78F1E}"/>
+                <a16:creationId xmlns:a16="http://schemas.microsoft.com/office/drawing/2014/main" id="{5EDF46C3-E231-4391-A8D1-A0441DD74A1B}"/>
               </a:ext>
             </a:extLst>
           </p:cNvPr>
@@ -14500,7 +14505,7 @@
           <p:cNvPr id="6" name="">
             <a:extLst xmlns:a="http://schemas.openxmlformats.org/drawingml/2006/main">
               <a:ext uri="{FF2B5EF4-FFF2-40B4-BE49-F238E27FC236}">
-                <a16:creationId xmlns:a16="http://schemas.microsoft.com/office/drawing/2014/main" id="{1707CAE6-9EFE-469B-8584-4C9FD2707071}"/>
+                <a16:creationId xmlns:a16="http://schemas.microsoft.com/office/drawing/2014/main" id="{7C22C9B6-03FE-49B7-80CD-F2CE91105492}"/>
               </a:ext>
             </a:extLst>
           </p:cNvPr>
@@ -14532,7 +14537,7 @@
           <p:cNvPr id="7" name="">
             <a:extLst xmlns:a="http://schemas.openxmlformats.org/drawingml/2006/main">
               <a:ext uri="{FF2B5EF4-FFF2-40B4-BE49-F238E27FC236}">
-                <a16:creationId xmlns:a16="http://schemas.microsoft.com/office/drawing/2014/main" id="{9D80F52A-1317-439E-80AC-4374F95C90D3}"/>
+                <a16:creationId xmlns:a16="http://schemas.microsoft.com/office/drawing/2014/main" id="{DB50110A-369B-4BC7-8A7C-27828C6A1A90}"/>
               </a:ext>
             </a:extLst>
           </p:cNvPr>
@@ -14589,7 +14594,7 @@
           <p:cNvPr id="8" name="">
             <a:extLst xmlns:a="http://schemas.openxmlformats.org/drawingml/2006/main">
               <a:ext uri="{FF2B5EF4-FFF2-40B4-BE49-F238E27FC236}">
-                <a16:creationId xmlns:a16="http://schemas.microsoft.com/office/drawing/2014/main" id="{1571D8B1-796D-4D7C-A4ED-3E6725408199}"/>
+                <a16:creationId xmlns:a16="http://schemas.microsoft.com/office/drawing/2014/main" id="{A99912BA-4B64-4313-9E28-E7DD20315759}"/>
               </a:ext>
             </a:extLst>
           </p:cNvPr>
@@ -14646,7 +14651,7 @@
           <p:cNvPr id="9" name="">
             <a:extLst xmlns:a="http://schemas.openxmlformats.org/drawingml/2006/main">
               <a:ext uri="{FF2B5EF4-FFF2-40B4-BE49-F238E27FC236}">
-                <a16:creationId xmlns:a16="http://schemas.microsoft.com/office/drawing/2014/main" id="{B0187CAA-DBA4-4E01-AA0E-74E0F651A086}"/>
+                <a16:creationId xmlns:a16="http://schemas.microsoft.com/office/drawing/2014/main" id="{BD7A629F-3E20-4456-B132-1D85CE47BE70}"/>
               </a:ext>
             </a:extLst>
           </p:cNvPr>
@@ -14703,7 +14708,7 @@
           <p:cNvPr id="10" name="">
             <a:extLst xmlns:a="http://schemas.openxmlformats.org/drawingml/2006/main">
               <a:ext uri="{FF2B5EF4-FFF2-40B4-BE49-F238E27FC236}">
-                <a16:creationId xmlns:a16="http://schemas.microsoft.com/office/drawing/2014/main" id="{C8D007E7-BE8F-4FFE-A54B-12607C24FA7C}"/>
+                <a16:creationId xmlns:a16="http://schemas.microsoft.com/office/drawing/2014/main" id="{43B9D304-2A7A-4523-930A-C6379C3A51C7}"/>
               </a:ext>
             </a:extLst>
           </p:cNvPr>
@@ -14735,7 +14740,7 @@
           <p:cNvPr id="11" name="">
             <a:extLst xmlns:a="http://schemas.openxmlformats.org/drawingml/2006/main">
               <a:ext uri="{FF2B5EF4-FFF2-40B4-BE49-F238E27FC236}">
-                <a16:creationId xmlns:a16="http://schemas.microsoft.com/office/drawing/2014/main" id="{F33443C9-4015-4129-8CFB-B24CAAA027DE}"/>
+                <a16:creationId xmlns:a16="http://schemas.microsoft.com/office/drawing/2014/main" id="{A1572E8D-BCE5-4BE4-961F-358CA336456D}"/>
               </a:ext>
             </a:extLst>
           </p:cNvPr>
@@ -14767,7 +14772,7 @@
           <p:cNvPr id="12" name="">
             <a:extLst xmlns:a="http://schemas.openxmlformats.org/drawingml/2006/main">
               <a:ext uri="{FF2B5EF4-FFF2-40B4-BE49-F238E27FC236}">
-                <a16:creationId xmlns:a16="http://schemas.microsoft.com/office/drawing/2014/main" id="{12ED95AC-82ED-4E8B-B575-BF646B6BA1D1}"/>
+                <a16:creationId xmlns:a16="http://schemas.microsoft.com/office/drawing/2014/main" id="{A3505AB7-C5C3-4EAF-B9BD-DF3F5429749E}"/>
               </a:ext>
             </a:extLst>
           </p:cNvPr>
@@ -14824,7 +14829,7 @@
           <p:cNvPr id="13" name="">
             <a:extLst xmlns:a="http://schemas.openxmlformats.org/drawingml/2006/main">
               <a:ext uri="{FF2B5EF4-FFF2-40B4-BE49-F238E27FC236}">
-                <a16:creationId xmlns:a16="http://schemas.microsoft.com/office/drawing/2014/main" id="{DAE70875-17B8-4EAD-9A91-B0905D13D2B6}"/>
+                <a16:creationId xmlns:a16="http://schemas.microsoft.com/office/drawing/2014/main" id="{DFFE7DB4-9948-4989-9DC9-199EE86FC984}"/>
               </a:ext>
             </a:extLst>
           </p:cNvPr>
@@ -14881,7 +14886,7 @@
           <p:cNvPr id="14" name="">
             <a:extLst xmlns:a="http://schemas.openxmlformats.org/drawingml/2006/main">
               <a:ext uri="{FF2B5EF4-FFF2-40B4-BE49-F238E27FC236}">
-                <a16:creationId xmlns:a16="http://schemas.microsoft.com/office/drawing/2014/main" id="{A6F46C79-82C0-43B2-A9D5-77D53D7D82B6}"/>
+                <a16:creationId xmlns:a16="http://schemas.microsoft.com/office/drawing/2014/main" id="{28747667-DF55-4C2B-A134-655BF00C6DD1}"/>
               </a:ext>
             </a:extLst>
           </p:cNvPr>
@@ -14938,7 +14943,7 @@
           <p:cNvPr id="15" name="">
             <a:extLst xmlns:a="http://schemas.openxmlformats.org/drawingml/2006/main">
               <a:ext uri="{FF2B5EF4-FFF2-40B4-BE49-F238E27FC236}">
-                <a16:creationId xmlns:a16="http://schemas.microsoft.com/office/drawing/2014/main" id="{2250C7AC-EFB1-421A-B1ED-B4BFA1DE0DFA}"/>
+                <a16:creationId xmlns:a16="http://schemas.microsoft.com/office/drawing/2014/main" id="{3E9420BF-B57E-48F8-9943-C453C181A9F1}"/>
               </a:ext>
             </a:extLst>
           </p:cNvPr>
@@ -14970,7 +14975,7 @@
           <p:cNvPr id="16" name="">
             <a:extLst xmlns:a="http://schemas.openxmlformats.org/drawingml/2006/main">
               <a:ext uri="{FF2B5EF4-FFF2-40B4-BE49-F238E27FC236}">
-                <a16:creationId xmlns:a16="http://schemas.microsoft.com/office/drawing/2014/main" id="{C6621532-B834-40C2-8FFC-28480439874D}"/>
+                <a16:creationId xmlns:a16="http://schemas.microsoft.com/office/drawing/2014/main" id="{E38ABECA-A293-4BC0-B0FF-DFD00202B67E}"/>
               </a:ext>
             </a:extLst>
           </p:cNvPr>
@@ -15002,7 +15007,7 @@
           <p:cNvPr id="17" name="">
             <a:extLst xmlns:a="http://schemas.openxmlformats.org/drawingml/2006/main">
               <a:ext uri="{FF2B5EF4-FFF2-40B4-BE49-F238E27FC236}">
-                <a16:creationId xmlns:a16="http://schemas.microsoft.com/office/drawing/2014/main" id="{F1CAE740-330C-46FF-BF2D-CD28A47682B1}"/>
+                <a16:creationId xmlns:a16="http://schemas.microsoft.com/office/drawing/2014/main" id="{E7D0B020-A1C0-405D-A656-8248660F060A}"/>
               </a:ext>
             </a:extLst>
           </p:cNvPr>
@@ -15059,7 +15064,7 @@
           <p:cNvPr id="18" name="">
             <a:extLst xmlns:a="http://schemas.openxmlformats.org/drawingml/2006/main">
               <a:ext uri="{FF2B5EF4-FFF2-40B4-BE49-F238E27FC236}">
-                <a16:creationId xmlns:a16="http://schemas.microsoft.com/office/drawing/2014/main" id="{8C9C5033-2E8E-4745-989C-61996F10185F}"/>
+                <a16:creationId xmlns:a16="http://schemas.microsoft.com/office/drawing/2014/main" id="{AD6CF5C7-2E82-422D-8738-792534346F42}"/>
               </a:ext>
             </a:extLst>
           </p:cNvPr>
@@ -15116,7 +15121,7 @@
           <p:cNvPr id="19" name="">
             <a:extLst xmlns:a="http://schemas.openxmlformats.org/drawingml/2006/main">
               <a:ext uri="{FF2B5EF4-FFF2-40B4-BE49-F238E27FC236}">
-                <a16:creationId xmlns:a16="http://schemas.microsoft.com/office/drawing/2014/main" id="{65810002-BD0F-4746-A9F3-E9231E5953ED}"/>
+                <a16:creationId xmlns:a16="http://schemas.microsoft.com/office/drawing/2014/main" id="{C1770380-6253-42C0-BDB2-813D5F88F930}"/>
               </a:ext>
             </a:extLst>
           </p:cNvPr>
@@ -15173,7 +15178,7 @@
           <p:cNvPr id="20" name="">
             <a:extLst xmlns:a="http://schemas.openxmlformats.org/drawingml/2006/main">
               <a:ext uri="{FF2B5EF4-FFF2-40B4-BE49-F238E27FC236}">
-                <a16:creationId xmlns:a16="http://schemas.microsoft.com/office/drawing/2014/main" id="{60D7BD65-110D-42EB-AC24-EF7DADD39322}"/>
+                <a16:creationId xmlns:a16="http://schemas.microsoft.com/office/drawing/2014/main" id="{69A7CB54-2A07-47A7-9DFA-7BE6552E8566}"/>
               </a:ext>
             </a:extLst>
           </p:cNvPr>
@@ -15205,7 +15210,7 @@
           <p:cNvPr id="21" name="">
             <a:extLst xmlns:a="http://schemas.openxmlformats.org/drawingml/2006/main">
               <a:ext uri="{FF2B5EF4-FFF2-40B4-BE49-F238E27FC236}">
-                <a16:creationId xmlns:a16="http://schemas.microsoft.com/office/drawing/2014/main" id="{CDE69CE8-23BF-46C6-B61D-9D6BAA8F1CB8}"/>
+                <a16:creationId xmlns:a16="http://schemas.microsoft.com/office/drawing/2014/main" id="{DD30B5F7-3AC0-4062-AACF-F453ACB9EDB3}"/>
               </a:ext>
             </a:extLst>
           </p:cNvPr>
@@ -15237,7 +15242,7 @@
           <p:cNvPr id="22" name="">
             <a:extLst xmlns:a="http://schemas.openxmlformats.org/drawingml/2006/main">
               <a:ext uri="{FF2B5EF4-FFF2-40B4-BE49-F238E27FC236}">
-                <a16:creationId xmlns:a16="http://schemas.microsoft.com/office/drawing/2014/main" id="{FE7CE309-26F1-402E-BFCB-E34CD8A22961}"/>
+                <a16:creationId xmlns:a16="http://schemas.microsoft.com/office/drawing/2014/main" id="{685D4193-E828-4216-A649-95F7A9E7C10A}"/>
               </a:ext>
             </a:extLst>
           </p:cNvPr>
@@ -15294,7 +15299,7 @@
           <p:cNvPr id="23" name="">
             <a:extLst xmlns:a="http://schemas.openxmlformats.org/drawingml/2006/main">
               <a:ext uri="{FF2B5EF4-FFF2-40B4-BE49-F238E27FC236}">
-                <a16:creationId xmlns:a16="http://schemas.microsoft.com/office/drawing/2014/main" id="{29A47B45-6E69-4A82-8C25-F49D8DA42EF9}"/>
+                <a16:creationId xmlns:a16="http://schemas.microsoft.com/office/drawing/2014/main" id="{D94723EC-8B27-4551-9BCF-886D18EEF263}"/>
               </a:ext>
             </a:extLst>
           </p:cNvPr>
@@ -15351,7 +15356,7 @@
           <p:cNvPr id="24" name="">
             <a:extLst xmlns:a="http://schemas.openxmlformats.org/drawingml/2006/main">
               <a:ext uri="{FF2B5EF4-FFF2-40B4-BE49-F238E27FC236}">
-                <a16:creationId xmlns:a16="http://schemas.microsoft.com/office/drawing/2014/main" id="{C47E8EDB-EB44-4B0A-A7B4-12F328F3FC18}"/>
+                <a16:creationId xmlns:a16="http://schemas.microsoft.com/office/drawing/2014/main" id="{24099D61-8508-43A0-A1BD-57099746B153}"/>
               </a:ext>
             </a:extLst>
           </p:cNvPr>
@@ -15408,7 +15413,7 @@
           <p:cNvPr id="25" name="">
             <a:extLst xmlns:a="http://schemas.openxmlformats.org/drawingml/2006/main">
               <a:ext uri="{FF2B5EF4-FFF2-40B4-BE49-F238E27FC236}">
-                <a16:creationId xmlns:a16="http://schemas.microsoft.com/office/drawing/2014/main" id="{327EEB73-D82E-467D-8621-8DF19AF61111}"/>
+                <a16:creationId xmlns:a16="http://schemas.microsoft.com/office/drawing/2014/main" id="{A0CDB6AE-8BBA-4343-9F47-EF1AF54908DA}"/>
               </a:ext>
             </a:extLst>
           </p:cNvPr>
@@ -15465,7 +15470,7 @@
           <p:cNvPr id="26" name="">
             <a:extLst xmlns:a="http://schemas.openxmlformats.org/drawingml/2006/main">
               <a:ext uri="{FF2B5EF4-FFF2-40B4-BE49-F238E27FC236}">
-                <a16:creationId xmlns:a16="http://schemas.microsoft.com/office/drawing/2014/main" id="{624EF672-C544-454B-BCE0-33A468DA7561}"/>
+                <a16:creationId xmlns:a16="http://schemas.microsoft.com/office/drawing/2014/main" id="{B95BBB09-A0FD-4AA6-B8F8-5EA54FC0F8CF}"/>
               </a:ext>
             </a:extLst>
           </p:cNvPr>
@@ -15520,7 +15525,7 @@
     </p:spTree>
     <p:extLst>
       <p:ext uri="{BB962C8B-B14F-4D97-AF65-F5344CB8AC3E}">
-        <p14:creationId xmlns:p14="http://schemas.microsoft.com/office/powerpoint/2010/main" val="201374226"/>
+        <p14:creationId xmlns:p14="http://schemas.microsoft.com/office/powerpoint/2010/main" val="1114271528"/>
       </p:ext>
     </p:extLst>
   </p:cSld>
@@ -15551,7 +15556,7 @@
           <p:cNvPr id="19" name="">
             <a:extLst xmlns:a="http://schemas.openxmlformats.org/drawingml/2006/main">
               <a:ext uri="{FF2B5EF4-FFF2-40B4-BE49-F238E27FC236}">
-                <a16:creationId xmlns:a16="http://schemas.microsoft.com/office/drawing/2014/main" id="{EC6CDD58-C237-41F8-82CA-59F24CA515C3}"/>
+                <a16:creationId xmlns:a16="http://schemas.microsoft.com/office/drawing/2014/main" id="{D0060EB2-8E27-4F1B-ABA7-004FD4FE98A3}"/>
               </a:ext>
             </a:extLst>
           </p:cNvPr>
@@ -15598,7 +15603,7 @@
                 <a:ea typeface="Arial"/>
                 <a:cs typeface="Arial"/>
               </a:rPr>
-              <a:t>REPRODUCIBLE EVIDENCE</a:t>
+              <a:t>V1.0.0 FIXTURE EVIDENCE</a:t>
             </a:r>
           </a:p>
         </p:txBody>
@@ -15608,7 +15613,7 @@
           <p:cNvPr id="2" name="">
             <a:extLst xmlns:a="http://schemas.openxmlformats.org/drawingml/2006/main">
               <a:ext uri="{FF2B5EF4-FFF2-40B4-BE49-F238E27FC236}">
-                <a16:creationId xmlns:a16="http://schemas.microsoft.com/office/drawing/2014/main" id="{E13AC80C-2B8C-4558-9039-06166A74D6D1}"/>
+                <a16:creationId xmlns:a16="http://schemas.microsoft.com/office/drawing/2014/main" id="{7F4E7F73-3060-4331-B5F1-8397616EDA50}"/>
               </a:ext>
             </a:extLst>
           </p:cNvPr>
@@ -15665,7 +15670,7 @@
           <p:cNvPr id="3" name="">
             <a:extLst xmlns:a="http://schemas.openxmlformats.org/drawingml/2006/main">
               <a:ext uri="{FF2B5EF4-FFF2-40B4-BE49-F238E27FC236}">
-                <a16:creationId xmlns:a16="http://schemas.microsoft.com/office/drawing/2014/main" id="{618A3DE0-523B-4457-B539-97DB5B99992B}"/>
+                <a16:creationId xmlns:a16="http://schemas.microsoft.com/office/drawing/2014/main" id="{293C56B1-7CFE-4E53-9918-74571EF015C7}"/>
               </a:ext>
             </a:extLst>
           </p:cNvPr>
@@ -15695,7 +15700,7 @@
           <p:cNvPr id="4" name="">
             <a:extLst xmlns:a="http://schemas.openxmlformats.org/drawingml/2006/main">
               <a:ext uri="{FF2B5EF4-FFF2-40B4-BE49-F238E27FC236}">
-                <a16:creationId xmlns:a16="http://schemas.microsoft.com/office/drawing/2014/main" id="{4A3B3CFD-7AFA-4412-B38F-054BC476D0E7}"/>
+                <a16:creationId xmlns:a16="http://schemas.microsoft.com/office/drawing/2014/main" id="{84FF61EE-12BC-475F-AA12-66BA9A20ED4C}"/>
               </a:ext>
             </a:extLst>
           </p:cNvPr>
@@ -15752,7 +15757,7 @@
           <p:cNvPr id="5" name="">
             <a:extLst xmlns:a="http://schemas.openxmlformats.org/drawingml/2006/main">
               <a:ext uri="{FF2B5EF4-FFF2-40B4-BE49-F238E27FC236}">
-                <a16:creationId xmlns:a16="http://schemas.microsoft.com/office/drawing/2014/main" id="{86AE06C6-F88C-40DC-854F-69BBF8F7AE47}"/>
+                <a16:creationId xmlns:a16="http://schemas.microsoft.com/office/drawing/2014/main" id="{7ECD2E7B-0848-4700-B4BD-440CA86015EF}"/>
               </a:ext>
             </a:extLst>
           </p:cNvPr>
@@ -15784,7 +15789,7 @@
           <p:cNvPr id="6" name="">
             <a:extLst xmlns:a="http://schemas.openxmlformats.org/drawingml/2006/main">
               <a:ext uri="{FF2B5EF4-FFF2-40B4-BE49-F238E27FC236}">
-                <a16:creationId xmlns:a16="http://schemas.microsoft.com/office/drawing/2014/main" id="{AF36E8BC-3E4A-48D0-BB4C-DA335AC114A9}"/>
+                <a16:creationId xmlns:a16="http://schemas.microsoft.com/office/drawing/2014/main" id="{0309AEEF-2B5D-47FA-98B8-91979A3FFB34}"/>
               </a:ext>
             </a:extLst>
           </p:cNvPr>
@@ -15841,7 +15846,7 @@
           <p:cNvPr id="7" name="">
             <a:extLst xmlns:a="http://schemas.openxmlformats.org/drawingml/2006/main">
               <a:ext uri="{FF2B5EF4-FFF2-40B4-BE49-F238E27FC236}">
-                <a16:creationId xmlns:a16="http://schemas.microsoft.com/office/drawing/2014/main" id="{B6BF139E-BE28-443F-8A2D-8928A34849F3}"/>
+                <a16:creationId xmlns:a16="http://schemas.microsoft.com/office/drawing/2014/main" id="{A4C1EC49-4465-4A88-8318-A6FC1CAD99CB}"/>
               </a:ext>
             </a:extLst>
           </p:cNvPr>
@@ -15898,7 +15903,7 @@
           <p:cNvPr id="8" name="">
             <a:extLst xmlns:a="http://schemas.openxmlformats.org/drawingml/2006/main">
               <a:ext uri="{FF2B5EF4-FFF2-40B4-BE49-F238E27FC236}">
-                <a16:creationId xmlns:a16="http://schemas.microsoft.com/office/drawing/2014/main" id="{C5DEC58D-00D8-481B-84C6-838A866424A9}"/>
+                <a16:creationId xmlns:a16="http://schemas.microsoft.com/office/drawing/2014/main" id="{5B073822-631F-4B3D-821F-BE4645FCA505}"/>
               </a:ext>
             </a:extLst>
           </p:cNvPr>
@@ -15930,7 +15935,7 @@
           <p:cNvPr id="9" name="">
             <a:extLst xmlns:a="http://schemas.openxmlformats.org/drawingml/2006/main">
               <a:ext uri="{FF2B5EF4-FFF2-40B4-BE49-F238E27FC236}">
-                <a16:creationId xmlns:a16="http://schemas.microsoft.com/office/drawing/2014/main" id="{24F2721A-5A88-4DF0-87CF-B8A3B6A55E4B}"/>
+                <a16:creationId xmlns:a16="http://schemas.microsoft.com/office/drawing/2014/main" id="{8684A238-E57F-4DFD-B02F-63B9CDEF6DC6}"/>
               </a:ext>
             </a:extLst>
           </p:cNvPr>
@@ -15987,7 +15992,7 @@
           <p:cNvPr id="10" name="">
             <a:extLst xmlns:a="http://schemas.openxmlformats.org/drawingml/2006/main">
               <a:ext uri="{FF2B5EF4-FFF2-40B4-BE49-F238E27FC236}">
-                <a16:creationId xmlns:a16="http://schemas.microsoft.com/office/drawing/2014/main" id="{3DB894F3-FDAE-4A8F-9519-F1A23B3DEAEE}"/>
+                <a16:creationId xmlns:a16="http://schemas.microsoft.com/office/drawing/2014/main" id="{350DDFDE-1E20-4CD3-86E9-817346F855DE}"/>
               </a:ext>
             </a:extLst>
           </p:cNvPr>
@@ -16044,7 +16049,7 @@
           <p:cNvPr id="11" name="">
             <a:extLst xmlns:a="http://schemas.openxmlformats.org/drawingml/2006/main">
               <a:ext uri="{FF2B5EF4-FFF2-40B4-BE49-F238E27FC236}">
-                <a16:creationId xmlns:a16="http://schemas.microsoft.com/office/drawing/2014/main" id="{7C76864F-3F78-4F50-8EA2-21B5AD815D78}"/>
+                <a16:creationId xmlns:a16="http://schemas.microsoft.com/office/drawing/2014/main" id="{6CB29B9A-BE8B-488C-BC02-0DF813232F41}"/>
               </a:ext>
             </a:extLst>
           </p:cNvPr>
@@ -16076,7 +16081,7 @@
           <p:cNvPr id="12" name="">
             <a:extLst xmlns:a="http://schemas.openxmlformats.org/drawingml/2006/main">
               <a:ext uri="{FF2B5EF4-FFF2-40B4-BE49-F238E27FC236}">
-                <a16:creationId xmlns:a16="http://schemas.microsoft.com/office/drawing/2014/main" id="{12D893D1-C435-4084-B7F1-ED24EDFD6E91}"/>
+                <a16:creationId xmlns:a16="http://schemas.microsoft.com/office/drawing/2014/main" id="{5E6991BB-DFC8-47DC-B2ED-F0B5C3D3C6D6}"/>
               </a:ext>
             </a:extLst>
           </p:cNvPr>
@@ -16133,7 +16138,7 @@
           <p:cNvPr id="13" name="">
             <a:extLst xmlns:a="http://schemas.openxmlformats.org/drawingml/2006/main">
               <a:ext uri="{FF2B5EF4-FFF2-40B4-BE49-F238E27FC236}">
-                <a16:creationId xmlns:a16="http://schemas.microsoft.com/office/drawing/2014/main" id="{88B91DA2-EDC9-4067-99EE-C51C2C4E933C}"/>
+                <a16:creationId xmlns:a16="http://schemas.microsoft.com/office/drawing/2014/main" id="{89E02573-2EC9-4591-920F-73556127379C}"/>
               </a:ext>
             </a:extLst>
           </p:cNvPr>
@@ -16190,7 +16195,7 @@
           <p:cNvPr id="14" name="">
             <a:extLst xmlns:a="http://schemas.openxmlformats.org/drawingml/2006/main">
               <a:ext uri="{FF2B5EF4-FFF2-40B4-BE49-F238E27FC236}">
-                <a16:creationId xmlns:a16="http://schemas.microsoft.com/office/drawing/2014/main" id="{F6D80029-51B9-43A6-BB68-0377A0F4D279}"/>
+                <a16:creationId xmlns:a16="http://schemas.microsoft.com/office/drawing/2014/main" id="{FABF4C2E-4E14-4B7F-8154-A0D23802A40D}"/>
               </a:ext>
             </a:extLst>
           </p:cNvPr>
@@ -16222,7 +16227,7 @@
           <p:cNvPr id="15" name="">
             <a:extLst xmlns:a="http://schemas.openxmlformats.org/drawingml/2006/main">
               <a:ext uri="{FF2B5EF4-FFF2-40B4-BE49-F238E27FC236}">
-                <a16:creationId xmlns:a16="http://schemas.microsoft.com/office/drawing/2014/main" id="{EE67B753-D086-45C0-A5C4-D423232D9471}"/>
+                <a16:creationId xmlns:a16="http://schemas.microsoft.com/office/drawing/2014/main" id="{65C45A09-E5D6-45BF-AF5C-81B1F3A93730}"/>
               </a:ext>
             </a:extLst>
           </p:cNvPr>
@@ -16279,7 +16284,7 @@
           <p:cNvPr id="16" name="">
             <a:extLst xmlns:a="http://schemas.openxmlformats.org/drawingml/2006/main">
               <a:ext uri="{FF2B5EF4-FFF2-40B4-BE49-F238E27FC236}">
-                <a16:creationId xmlns:a16="http://schemas.microsoft.com/office/drawing/2014/main" id="{A5F91E00-D85A-4E08-B934-F20F930CC366}"/>
+                <a16:creationId xmlns:a16="http://schemas.microsoft.com/office/drawing/2014/main" id="{B460DA9C-E5B0-4798-A692-268CCB367BB6}"/>
               </a:ext>
             </a:extLst>
           </p:cNvPr>
@@ -16336,7 +16341,7 @@
           <p:cNvPr id="17" name="">
             <a:extLst xmlns:a="http://schemas.openxmlformats.org/drawingml/2006/main">
               <a:ext uri="{FF2B5EF4-FFF2-40B4-BE49-F238E27FC236}">
-                <a16:creationId xmlns:a16="http://schemas.microsoft.com/office/drawing/2014/main" id="{04D0882E-F3A8-43B0-8E2D-E311882EED3D}"/>
+                <a16:creationId xmlns:a16="http://schemas.microsoft.com/office/drawing/2014/main" id="{867FEE9D-2E2B-4FEA-8991-D1C1AA2A543A}"/>
               </a:ext>
             </a:extLst>
           </p:cNvPr>
@@ -16368,7 +16373,7 @@
           <p:cNvPr id="18" name="">
             <a:extLst xmlns:a="http://schemas.openxmlformats.org/drawingml/2006/main">
               <a:ext uri="{FF2B5EF4-FFF2-40B4-BE49-F238E27FC236}">
-                <a16:creationId xmlns:a16="http://schemas.microsoft.com/office/drawing/2014/main" id="{491FB838-2586-4856-8687-5CD768E558E9}"/>
+                <a16:creationId xmlns:a16="http://schemas.microsoft.com/office/drawing/2014/main" id="{41F2BF4A-D0AC-4661-9728-F44BE236FC13}"/>
               </a:ext>
             </a:extLst>
           </p:cNvPr>
@@ -16423,7 +16428,7 @@
     </p:spTree>
     <p:extLst>
       <p:ext uri="{BB962C8B-B14F-4D97-AF65-F5344CB8AC3E}">
-        <p14:creationId xmlns:p14="http://schemas.microsoft.com/office/powerpoint/2010/main" val="1539694885"/>
+        <p14:creationId xmlns:p14="http://schemas.microsoft.com/office/powerpoint/2010/main" val="1214485154"/>
       </p:ext>
     </p:extLst>
   </p:cSld>
@@ -16454,7 +16459,7 @@
           <p:cNvPr id="15" name="">
             <a:extLst xmlns:a="http://schemas.openxmlformats.org/drawingml/2006/main">
               <a:ext uri="{FF2B5EF4-FFF2-40B4-BE49-F238E27FC236}">
-                <a16:creationId xmlns:a16="http://schemas.microsoft.com/office/drawing/2014/main" id="{F99EABB4-BAA1-48AD-B76A-69026BCE91C9}"/>
+                <a16:creationId xmlns:a16="http://schemas.microsoft.com/office/drawing/2014/main" id="{AAE1804F-2076-44D9-AE8E-5DF0DAF582A0}"/>
               </a:ext>
             </a:extLst>
           </p:cNvPr>
@@ -16511,7 +16516,7 @@
           <p:cNvPr id="2" name="">
             <a:extLst xmlns:a="http://schemas.openxmlformats.org/drawingml/2006/main">
               <a:ext uri="{FF2B5EF4-FFF2-40B4-BE49-F238E27FC236}">
-                <a16:creationId xmlns:a16="http://schemas.microsoft.com/office/drawing/2014/main" id="{F505C589-9D03-4D99-962D-B7F08C734EAE}"/>
+                <a16:creationId xmlns:a16="http://schemas.microsoft.com/office/drawing/2014/main" id="{4E149EC1-09BA-440B-B628-A49EDB65B691}"/>
               </a:ext>
             </a:extLst>
           </p:cNvPr>
@@ -16568,7 +16573,7 @@
           <p:cNvPr id="3" name="">
             <a:extLst xmlns:a="http://schemas.openxmlformats.org/drawingml/2006/main">
               <a:ext uri="{FF2B5EF4-FFF2-40B4-BE49-F238E27FC236}">
-                <a16:creationId xmlns:a16="http://schemas.microsoft.com/office/drawing/2014/main" id="{6C465EE9-6842-460C-BF69-669971B1DB8A}"/>
+                <a16:creationId xmlns:a16="http://schemas.microsoft.com/office/drawing/2014/main" id="{458B7160-ED78-4471-A6D6-233946896D43}"/>
               </a:ext>
             </a:extLst>
           </p:cNvPr>
@@ -16598,7 +16603,7 @@
           <p:cNvPr id="4" name="">
             <a:extLst xmlns:a="http://schemas.openxmlformats.org/drawingml/2006/main">
               <a:ext uri="{FF2B5EF4-FFF2-40B4-BE49-F238E27FC236}">
-                <a16:creationId xmlns:a16="http://schemas.microsoft.com/office/drawing/2014/main" id="{F47A430F-71CC-4816-AA71-E1AF096C578D}"/>
+                <a16:creationId xmlns:a16="http://schemas.microsoft.com/office/drawing/2014/main" id="{3E34DF7E-617B-43C6-B29E-2AEE38718C31}"/>
               </a:ext>
             </a:extLst>
           </p:cNvPr>
@@ -16662,7 +16667,7 @@
         </p:xfrm>
         <a:graphic xmlns:a="http://schemas.openxmlformats.org/drawingml/2006/main">
           <a:graphicData uri="http://schemas.openxmlformats.org/drawingml/2006/chart">
-            <c:chart xmlns:r="http://schemas.openxmlformats.org/officeDocument/2006/relationships" xmlns:c="http://schemas.openxmlformats.org/drawingml/2006/chart" r:id="Rc9d67eaff6f54ff4"/>
+            <c:chart xmlns:r="http://schemas.openxmlformats.org/officeDocument/2006/relationships" xmlns:c="http://schemas.openxmlformats.org/drawingml/2006/chart" r:id="R0b0781e46fe5455d"/>
           </a:graphicData>
         </a:graphic>
       </p:graphicFrame>
@@ -16671,7 +16676,7 @@
           <p:cNvPr id="6" name="">
             <a:extLst xmlns:a="http://schemas.openxmlformats.org/drawingml/2006/main">
               <a:ext uri="{FF2B5EF4-FFF2-40B4-BE49-F238E27FC236}">
-                <a16:creationId xmlns:a16="http://schemas.microsoft.com/office/drawing/2014/main" id="{7D846C95-1A0D-4504-B110-215DE73E2FD7}"/>
+                <a16:creationId xmlns:a16="http://schemas.microsoft.com/office/drawing/2014/main" id="{9A1DA1AC-8ECE-4601-9B6B-B57E90621D18}"/>
               </a:ext>
             </a:extLst>
           </p:cNvPr>
@@ -16703,7 +16708,7 @@
           <p:cNvPr id="7" name="">
             <a:extLst xmlns:a="http://schemas.openxmlformats.org/drawingml/2006/main">
               <a:ext uri="{FF2B5EF4-FFF2-40B4-BE49-F238E27FC236}">
-                <a16:creationId xmlns:a16="http://schemas.microsoft.com/office/drawing/2014/main" id="{2CD2BABC-AE0B-4BDE-8BD9-BF0D9FEAFFC7}"/>
+                <a16:creationId xmlns:a16="http://schemas.microsoft.com/office/drawing/2014/main" id="{B2FA36F1-2D14-4529-844B-07E5AAC31B91}"/>
               </a:ext>
             </a:extLst>
           </p:cNvPr>
@@ -16783,7 +16788,7 @@
           <p:cNvPr id="8" name="">
             <a:extLst xmlns:a="http://schemas.openxmlformats.org/drawingml/2006/main">
               <a:ext uri="{FF2B5EF4-FFF2-40B4-BE49-F238E27FC236}">
-                <a16:creationId xmlns:a16="http://schemas.microsoft.com/office/drawing/2014/main" id="{E38B7288-8732-4C3A-B583-D586B5DB1EC4}"/>
+                <a16:creationId xmlns:a16="http://schemas.microsoft.com/office/drawing/2014/main" id="{239B7F6A-7E81-4690-909F-DAB53DAB6AA0}"/>
               </a:ext>
             </a:extLst>
           </p:cNvPr>
@@ -16840,7 +16845,7 @@
           <p:cNvPr id="9" name="">
             <a:extLst xmlns:a="http://schemas.openxmlformats.org/drawingml/2006/main">
               <a:ext uri="{FF2B5EF4-FFF2-40B4-BE49-F238E27FC236}">
-                <a16:creationId xmlns:a16="http://schemas.microsoft.com/office/drawing/2014/main" id="{B0B4213E-B048-4F34-8187-BBCF9C8C1372}"/>
+                <a16:creationId xmlns:a16="http://schemas.microsoft.com/office/drawing/2014/main" id="{B3EEAD68-CD1A-4C51-9B9F-41BD538DCFBE}"/>
               </a:ext>
             </a:extLst>
           </p:cNvPr>
@@ -16897,7 +16902,7 @@
           <p:cNvPr id="10" name="">
             <a:extLst xmlns:a="http://schemas.openxmlformats.org/drawingml/2006/main">
               <a:ext uri="{FF2B5EF4-FFF2-40B4-BE49-F238E27FC236}">
-                <a16:creationId xmlns:a16="http://schemas.microsoft.com/office/drawing/2014/main" id="{F12A5263-C52E-4C64-A874-89D80ECBCAFC}"/>
+                <a16:creationId xmlns:a16="http://schemas.microsoft.com/office/drawing/2014/main" id="{3F9750A0-C062-496C-906F-2172C0125EE7}"/>
               </a:ext>
             </a:extLst>
           </p:cNvPr>
@@ -16954,7 +16959,7 @@
           <p:cNvPr id="11" name="">
             <a:extLst xmlns:a="http://schemas.openxmlformats.org/drawingml/2006/main">
               <a:ext uri="{FF2B5EF4-FFF2-40B4-BE49-F238E27FC236}">
-                <a16:creationId xmlns:a16="http://schemas.microsoft.com/office/drawing/2014/main" id="{584399E4-6D6F-40F3-B7D1-342A8894E4EC}"/>
+                <a16:creationId xmlns:a16="http://schemas.microsoft.com/office/drawing/2014/main" id="{69615A2B-1205-4AA5-99B1-31679DCC63CD}"/>
               </a:ext>
             </a:extLst>
           </p:cNvPr>
@@ -17011,7 +17016,7 @@
           <p:cNvPr id="12" name="">
             <a:extLst xmlns:a="http://schemas.openxmlformats.org/drawingml/2006/main">
               <a:ext uri="{FF2B5EF4-FFF2-40B4-BE49-F238E27FC236}">
-                <a16:creationId xmlns:a16="http://schemas.microsoft.com/office/drawing/2014/main" id="{4872E8B5-277B-4C7E-BE0A-FF911470D6B2}"/>
+                <a16:creationId xmlns:a16="http://schemas.microsoft.com/office/drawing/2014/main" id="{89112B49-7B19-41A0-9213-6FF33B5CE1C4}"/>
               </a:ext>
             </a:extLst>
           </p:cNvPr>
@@ -17068,7 +17073,7 @@
           <p:cNvPr id="13" name="">
             <a:extLst xmlns:a="http://schemas.openxmlformats.org/drawingml/2006/main">
               <a:ext uri="{FF2B5EF4-FFF2-40B4-BE49-F238E27FC236}">
-                <a16:creationId xmlns:a16="http://schemas.microsoft.com/office/drawing/2014/main" id="{7EEC617B-129A-44AA-9E1C-36716C2F542E}"/>
+                <a16:creationId xmlns:a16="http://schemas.microsoft.com/office/drawing/2014/main" id="{437EFFE2-4DC5-4537-8D6C-F3CE7DE56C64}"/>
               </a:ext>
             </a:extLst>
           </p:cNvPr>
@@ -17125,7 +17130,7 @@
           <p:cNvPr id="14" name="">
             <a:extLst xmlns:a="http://schemas.openxmlformats.org/drawingml/2006/main">
               <a:ext uri="{FF2B5EF4-FFF2-40B4-BE49-F238E27FC236}">
-                <a16:creationId xmlns:a16="http://schemas.microsoft.com/office/drawing/2014/main" id="{9DA5D54D-8B16-4665-B81E-D5748A1BC6E7}"/>
+                <a16:creationId xmlns:a16="http://schemas.microsoft.com/office/drawing/2014/main" id="{210A9F3A-3CFF-4B18-8BBB-AE9E730A71C4}"/>
               </a:ext>
             </a:extLst>
           </p:cNvPr>
@@ -17180,7 +17185,7 @@
     </p:spTree>
     <p:extLst>
       <p:ext uri="{BB962C8B-B14F-4D97-AF65-F5344CB8AC3E}">
-        <p14:creationId xmlns:p14="http://schemas.microsoft.com/office/powerpoint/2010/main" val="649320674"/>
+        <p14:creationId xmlns:p14="http://schemas.microsoft.com/office/powerpoint/2010/main" val="1683040731"/>
       </p:ext>
     </p:extLst>
   </p:cSld>

</xml_diff>